<commit_message>
Añadir slide de respuestas al Treasure Hunt del Módulo 5
Co-Authored-By: Claude Opus 4.6 (1M context) <noreply@anthropic.com>
</commit_message>
<xml_diff>
--- a/docs/slides/Modulo 5/identidad_digital_parte2.pptx
+++ b/docs/slides/Modulo 5/identidad_digital_parte2.pptx
@@ -34,6 +34,7 @@
     <p:sldId id="282" r:id="rId33"/>
     <p:sldId id="283" r:id="rId34"/>
     <p:sldId id="284" r:id="rId35"/>
+    <p:sldId id="285" r:id="rId36"/>
   </p:sldIdLst>
   <p:sldSz cx="12188952" cy="6858000" type="screen4x3"/>
   <p:notesSz cx="6858000" cy="9144000"/>
@@ -4937,7 +4938,7 @@
         <p:spPr>
           <a:xfrm>
             <a:off x="0" y="0"/>
-            <a:ext cx="12188952" cy="6858000"/>
+            <a:ext cx="12188952" cy="73152"/>
           </a:xfrm>
           <a:prstGeom prst="rect">
             <a:avLst/>
@@ -4979,8 +4980,8 @@
         </p:nvSpPr>
         <p:spPr>
           <a:xfrm>
-            <a:off x="914400" y="2286000"/>
-            <a:ext cx="10058400" cy="1828800"/>
+            <a:off x="457200" y="274320"/>
+            <a:ext cx="10972800" cy="731520"/>
           </a:xfrm>
           <a:prstGeom prst="rect">
             <a:avLst/>
@@ -4992,33 +4993,72 @@
           <a:lstStyle/>
           <a:p>
             <a:pPr algn="l">
-              <a:defRPr sz="4800" b="1">
-                <a:solidFill>
-                  <a:srgbClr val="FFFFFF"/>
-                </a:solidFill>
-                <a:latin typeface="Calibri"/>
-              </a:defRPr>
-            </a:pPr>
-            <a:r>
-              <a:t>Integracion de DID/VC</a:t>
-            </a:r>
-            <a:br/>
-            <a:r>
-              <a:t>en Soluciones Empresariales</a:t>
-            </a:r>
-          </a:p>
-        </p:txBody>
-      </p:sp>
-      <p:sp>
-        <p:nvSpPr>
-          <p:cNvPr id="4" name="TextBox 3"/>
+              <a:defRPr sz="3200" b="1">
+                <a:solidFill>
+                  <a:srgbClr val="22627E"/>
+                </a:solidFill>
+                <a:latin typeface="Calibri"/>
+              </a:defRPr>
+            </a:pPr>
+            <a:r>
+              <a:t>Treasure Hunt: respuestas</a:t>
+            </a:r>
+          </a:p>
+        </p:txBody>
+      </p:sp>
+      <p:sp>
+        <p:nvSpPr>
+          <p:cNvPr id="4" name="Rectangle 3"/>
+          <p:cNvSpPr/>
+          <p:nvPr/>
+        </p:nvSpPr>
+        <p:spPr>
+          <a:xfrm>
+            <a:off x="457200" y="1051560"/>
+            <a:ext cx="10972800" cy="27432"/>
+          </a:xfrm>
+          <a:prstGeom prst="rect">
+            <a:avLst/>
+          </a:prstGeom>
+          <a:solidFill>
+            <a:srgbClr val="22627E"/>
+          </a:solidFill>
+          <a:ln>
+            <a:noFill/>
+          </a:ln>
+        </p:spPr>
+        <p:style>
+          <a:lnRef idx="1">
+            <a:schemeClr val="accent1"/>
+          </a:lnRef>
+          <a:fillRef idx="3">
+            <a:schemeClr val="accent1"/>
+          </a:fillRef>
+          <a:effectRef idx="2">
+            <a:schemeClr val="accent1"/>
+          </a:effectRef>
+          <a:fontRef idx="minor">
+            <a:schemeClr val="lt1"/>
+          </a:fontRef>
+        </p:style>
+        <p:txBody>
+          <a:bodyPr rtlCol="0" anchor="ctr"/>
+          <a:lstStyle/>
+          <a:p>
+            <a:pPr algn="ctr"/>
+          </a:p>
+        </p:txBody>
+      </p:sp>
+      <p:sp>
+        <p:nvSpPr>
+          <p:cNvPr id="5" name="TextBox 4"/>
           <p:cNvSpPr txBox="1"/>
           <p:nvPr/>
         </p:nvSpPr>
         <p:spPr>
           <a:xfrm>
-            <a:off x="914400" y="4114800"/>
-            <a:ext cx="10058400" cy="1371600"/>
+            <a:off x="640080" y="1280160"/>
+            <a:ext cx="10515600" cy="5029200"/>
           </a:xfrm>
           <a:prstGeom prst="rect">
             <a:avLst/>
@@ -5026,19 +5066,207 @@
           <a:noFill/>
         </p:spPr>
         <p:txBody>
-          <a:bodyPr wrap="square"/>
-          <a:lstStyle/>
-          <a:p>
-            <a:pPr algn="l">
-              <a:defRPr sz="2400" b="0">
-                <a:solidFill>
-                  <a:srgbClr val="FFFFFF"/>
-                </a:solidFill>
-                <a:latin typeface="Calibri"/>
-              </a:defRPr>
-            </a:pPr>
-            <a:r>
-              <a:t>De la teoria a la practica: como se usa la identidad descentralizada</a:t>
+          <a:bodyPr wrap="square">
+            <a:spAutoFit/>
+          </a:bodyPr>
+          <a:lstStyle/>
+          <a:p>
+            <a:pPr>
+              <a:spcAft>
+                <a:spcPts val="800"/>
+              </a:spcAft>
+              <a:defRPr sz="2000">
+                <a:solidFill>
+                  <a:srgbClr val="333333"/>
+                </a:solidFill>
+                <a:latin typeface="Calibri"/>
+              </a:defRPr>
+            </a:pPr>
+            <a:r>
+              <a:t>1. Alex Puig, CTO de Everis (ahora NTT Data) y primer presidente de Alastria.</a:t>
+            </a:r>
+          </a:p>
+          <a:p>
+            <a:pPr>
+              <a:spcAft>
+                <a:spcPts val="800"/>
+              </a:spcAft>
+              <a:defRPr sz="2000">
+                <a:solidFill>
+                  <a:srgbClr val="333333"/>
+                </a:solidFill>
+                <a:latin typeface="Calibri"/>
+              </a:defRPr>
+            </a:pPr>
+            <a:r>
+              <a:t>   Impulso la creacion del consorcio junto con otros directivos del sector fintech y blockchain espanol.</a:t>
+            </a:r>
+          </a:p>
+          <a:p>
+            <a:pPr>
+              <a:spcAft>
+                <a:spcPts val="800"/>
+              </a:spcAft>
+              <a:defRPr sz="2000">
+                <a:solidFill>
+                  <a:srgbClr val="333333"/>
+                </a:solidFill>
+                <a:latin typeface="Calibri"/>
+              </a:defRPr>
+            </a:pPr>
+          </a:p>
+          <a:p>
+            <a:pPr>
+              <a:spcAft>
+                <a:spcPts val="800"/>
+              </a:spcAft>
+              <a:defRPr sz="2000">
+                <a:solidFill>
+                  <a:srgbClr val="333333"/>
+                </a:solidFill>
+                <a:latin typeface="Calibri"/>
+              </a:defRPr>
+            </a:pPr>
+            <a:r>
+              <a:t>2. Se presento en el Mobile World Congress (MWC) de Barcelona en 2017.</a:t>
+            </a:r>
+          </a:p>
+          <a:p>
+            <a:pPr>
+              <a:spcAft>
+                <a:spcPts val="800"/>
+              </a:spcAft>
+              <a:defRPr sz="2000">
+                <a:solidFill>
+                  <a:srgbClr val="333333"/>
+                </a:solidFill>
+                <a:latin typeface="Calibri"/>
+              </a:defRPr>
+            </a:pPr>
+          </a:p>
+          <a:p>
+            <a:pPr>
+              <a:spcAft>
+                <a:spcPts val="800"/>
+              </a:spcAft>
+              <a:defRPr sz="2000">
+                <a:solidFill>
+                  <a:srgbClr val="333333"/>
+                </a:solidFill>
+                <a:latin typeface="Calibri"/>
+              </a:defRPr>
+            </a:pPr>
+            <a:r>
+              <a:t>3. Alastria se fundo con 70 miembros fundadores en 2017.</a:t>
+            </a:r>
+          </a:p>
+          <a:p>
+            <a:pPr>
+              <a:spcAft>
+                <a:spcPts val="800"/>
+              </a:spcAft>
+              <a:defRPr sz="2000">
+                <a:solidFill>
+                  <a:srgbClr val="333333"/>
+                </a:solidFill>
+                <a:latin typeface="Calibri"/>
+              </a:defRPr>
+            </a:pPr>
+            <a:r>
+              <a:t>   Actualmente cuenta con mas de 500 entidades miembro.</a:t>
+            </a:r>
+          </a:p>
+          <a:p>
+            <a:pPr>
+              <a:spcAft>
+                <a:spcPts val="800"/>
+              </a:spcAft>
+              <a:defRPr sz="2000">
+                <a:solidFill>
+                  <a:srgbClr val="333333"/>
+                </a:solidFill>
+                <a:latin typeface="Calibri"/>
+              </a:defRPr>
+            </a:pPr>
+          </a:p>
+          <a:p>
+            <a:pPr>
+              <a:spcAft>
+                <a:spcPts val="800"/>
+              </a:spcAft>
+              <a:defRPr sz="2000">
+                <a:solidFill>
+                  <a:srgbClr val="333333"/>
+                </a:solidFill>
+                <a:latin typeface="Calibri"/>
+              </a:defRPr>
+            </a:pPr>
+            <a:r>
+              <a:t>4. Espana, a traves de Alastria y otros actores, es miembro de la</a:t>
+            </a:r>
+          </a:p>
+          <a:p>
+            <a:pPr>
+              <a:spcAft>
+                <a:spcPts val="800"/>
+              </a:spcAft>
+              <a:defRPr sz="2000">
+                <a:solidFill>
+                  <a:srgbClr val="333333"/>
+                </a:solidFill>
+                <a:latin typeface="Calibri"/>
+              </a:defRPr>
+            </a:pPr>
+            <a:r>
+              <a:t>   European Blockchain Partnership (EBP) desde 2018. Alastria colabora</a:t>
+            </a:r>
+          </a:p>
+          <a:p>
+            <a:pPr>
+              <a:spcAft>
+                <a:spcPts val="800"/>
+              </a:spcAft>
+              <a:defRPr sz="2000">
+                <a:solidFill>
+                  <a:srgbClr val="333333"/>
+                </a:solidFill>
+                <a:latin typeface="Calibri"/>
+              </a:defRPr>
+            </a:pPr>
+            <a:r>
+              <a:t>   con EBSI compartiendo estandares de identidad (DID/VC) y participando</a:t>
+            </a:r>
+          </a:p>
+          <a:p>
+            <a:pPr>
+              <a:spcAft>
+                <a:spcPts val="800"/>
+              </a:spcAft>
+              <a:defRPr sz="2000">
+                <a:solidFill>
+                  <a:srgbClr val="333333"/>
+                </a:solidFill>
+                <a:latin typeface="Calibri"/>
+              </a:defRPr>
+            </a:pPr>
+            <a:r>
+              <a:t>   en los pilotos europeos. La Red B (Hyperledger Besu) esta alineada</a:t>
+            </a:r>
+          </a:p>
+          <a:p>
+            <a:pPr>
+              <a:spcAft>
+                <a:spcPts val="800"/>
+              </a:spcAft>
+              <a:defRPr sz="2000">
+                <a:solidFill>
+                  <a:srgbClr val="333333"/>
+                </a:solidFill>
+                <a:latin typeface="Calibri"/>
+              </a:defRPr>
+            </a:pPr>
+            <a:r>
+              <a:t>   tecnologicamente con EBSI para facilitar la interoperabilidad.</a:t>
             </a:r>
           </a:p>
         </p:txBody>
@@ -5070,7 +5298,7 @@
         <p:spPr>
           <a:xfrm>
             <a:off x="0" y="0"/>
-            <a:ext cx="12188952" cy="73152"/>
+            <a:ext cx="12188952" cy="6858000"/>
           </a:xfrm>
           <a:prstGeom prst="rect">
             <a:avLst/>
@@ -5112,8 +5340,8 @@
         </p:nvSpPr>
         <p:spPr>
           <a:xfrm>
-            <a:off x="457200" y="274320"/>
-            <a:ext cx="10972800" cy="731520"/>
+            <a:off x="914400" y="2286000"/>
+            <a:ext cx="10058400" cy="1828800"/>
           </a:xfrm>
           <a:prstGeom prst="rect">
             <a:avLst/>
@@ -5125,72 +5353,33 @@
           <a:lstStyle/>
           <a:p>
             <a:pPr algn="l">
-              <a:defRPr sz="3200" b="1">
-                <a:solidFill>
-                  <a:srgbClr val="22627E"/>
-                </a:solidFill>
-                <a:latin typeface="Calibri"/>
-              </a:defRPr>
-            </a:pPr>
-            <a:r>
-              <a:t>Caso 1: Onboarding KYC bancario con VCs</a:t>
-            </a:r>
-          </a:p>
-        </p:txBody>
-      </p:sp>
-      <p:sp>
-        <p:nvSpPr>
-          <p:cNvPr id="4" name="Rectangle 3"/>
-          <p:cNvSpPr/>
-          <p:nvPr/>
-        </p:nvSpPr>
-        <p:spPr>
-          <a:xfrm>
-            <a:off x="457200" y="1051560"/>
-            <a:ext cx="10972800" cy="27432"/>
-          </a:xfrm>
-          <a:prstGeom prst="rect">
-            <a:avLst/>
-          </a:prstGeom>
-          <a:solidFill>
-            <a:srgbClr val="22627E"/>
-          </a:solidFill>
-          <a:ln>
-            <a:noFill/>
-          </a:ln>
-        </p:spPr>
-        <p:style>
-          <a:lnRef idx="1">
-            <a:schemeClr val="accent1"/>
-          </a:lnRef>
-          <a:fillRef idx="3">
-            <a:schemeClr val="accent1"/>
-          </a:fillRef>
-          <a:effectRef idx="2">
-            <a:schemeClr val="accent1"/>
-          </a:effectRef>
-          <a:fontRef idx="minor">
-            <a:schemeClr val="lt1"/>
-          </a:fontRef>
-        </p:style>
-        <p:txBody>
-          <a:bodyPr rtlCol="0" anchor="ctr"/>
-          <a:lstStyle/>
-          <a:p>
-            <a:pPr algn="ctr"/>
-          </a:p>
-        </p:txBody>
-      </p:sp>
-      <p:sp>
-        <p:nvSpPr>
-          <p:cNvPr id="5" name="TextBox 4"/>
+              <a:defRPr sz="4800" b="1">
+                <a:solidFill>
+                  <a:srgbClr val="FFFFFF"/>
+                </a:solidFill>
+                <a:latin typeface="Calibri"/>
+              </a:defRPr>
+            </a:pPr>
+            <a:r>
+              <a:t>Integracion de DID/VC</a:t>
+            </a:r>
+            <a:br/>
+            <a:r>
+              <a:t>en Soluciones Empresariales</a:t>
+            </a:r>
+          </a:p>
+        </p:txBody>
+      </p:sp>
+      <p:sp>
+        <p:nvSpPr>
+          <p:cNvPr id="4" name="TextBox 3"/>
           <p:cNvSpPr txBox="1"/>
           <p:nvPr/>
         </p:nvSpPr>
         <p:spPr>
           <a:xfrm>
-            <a:off x="640080" y="1280160"/>
-            <a:ext cx="10515600" cy="5029200"/>
+            <a:off x="914400" y="4114800"/>
+            <a:ext cx="10058400" cy="1371600"/>
           </a:xfrm>
           <a:prstGeom prst="rect">
             <a:avLst/>
@@ -5198,168 +5387,19 @@
           <a:noFill/>
         </p:spPr>
         <p:txBody>
-          <a:bodyPr wrap="square">
-            <a:spAutoFit/>
-          </a:bodyPr>
-          <a:lstStyle/>
-          <a:p>
-            <a:pPr>
-              <a:spcAft>
-                <a:spcPts val="800"/>
-              </a:spcAft>
-              <a:defRPr sz="2000">
-                <a:solidFill>
-                  <a:srgbClr val="333333"/>
-                </a:solidFill>
-                <a:latin typeface="Calibri"/>
-              </a:defRPr>
-            </a:pPr>
-            <a:r>
-              <a:t>Problema: cada banco repite el proceso KYC (Know Your Customer) desde cero</a:t>
-            </a:r>
-          </a:p>
-          <a:p>
-            <a:pPr>
-              <a:spcAft>
-                <a:spcPts val="800"/>
-              </a:spcAft>
-              <a:defRPr sz="2000">
-                <a:solidFill>
-                  <a:srgbClr val="333333"/>
-                </a:solidFill>
-                <a:latin typeface="Calibri"/>
-              </a:defRPr>
-            </a:pPr>
-            <a:r>
-              <a:t>Solucion con VCs: el cliente hace KYC una vez y obtiene una VC reutilizable</a:t>
-            </a:r>
-          </a:p>
-          <a:p>
-            <a:pPr>
-              <a:spcAft>
-                <a:spcPts val="800"/>
-              </a:spcAft>
-              <a:defRPr sz="2000">
-                <a:solidFill>
-                  <a:srgbClr val="333333"/>
-                </a:solidFill>
-                <a:latin typeface="Calibri"/>
-              </a:defRPr>
-            </a:pPr>
-            <a:r>
-              <a:t>Flujo:</a:t>
-            </a:r>
-          </a:p>
-          <a:p>
-            <a:pPr lvl="1">
-              <a:spcAft>
-                <a:spcPts val="400"/>
-              </a:spcAft>
-              <a:defRPr sz="1700">
-                <a:solidFill>
-                  <a:srgbClr val="666666"/>
-                </a:solidFill>
-                <a:latin typeface="Calibri"/>
-              </a:defRPr>
-            </a:pPr>
-            <a:r>
-              <a:t>    1. El cliente completa KYC en el Banco A (presenta DNI, justificante, etc.)</a:t>
-            </a:r>
-          </a:p>
-          <a:p>
-            <a:pPr lvl="1">
-              <a:spcAft>
-                <a:spcPts val="400"/>
-              </a:spcAft>
-              <a:defRPr sz="1700">
-                <a:solidFill>
-                  <a:srgbClr val="666666"/>
-                </a:solidFill>
-                <a:latin typeface="Calibri"/>
-              </a:defRPr>
-            </a:pPr>
-            <a:r>
-              <a:t>    2. El Banco A emite una VC de tipo 'KYC verificado' al cliente</a:t>
-            </a:r>
-          </a:p>
-          <a:p>
-            <a:pPr lvl="1">
-              <a:spcAft>
-                <a:spcPts val="400"/>
-              </a:spcAft>
-              <a:defRPr sz="1700">
-                <a:solidFill>
-                  <a:srgbClr val="666666"/>
-                </a:solidFill>
-                <a:latin typeface="Calibri"/>
-              </a:defRPr>
-            </a:pPr>
-            <a:r>
-              <a:t>    3. El cliente quiere abrir cuenta en el Banco B</a:t>
-            </a:r>
-          </a:p>
-          <a:p>
-            <a:pPr lvl="1">
-              <a:spcAft>
-                <a:spcPts val="400"/>
-              </a:spcAft>
-              <a:defRPr sz="1700">
-                <a:solidFill>
-                  <a:srgbClr val="666666"/>
-                </a:solidFill>
-                <a:latin typeface="Calibri"/>
-              </a:defRPr>
-            </a:pPr>
-            <a:r>
-              <a:t>    4. Presenta la VC de KYC del Banco A al Banco B</a:t>
-            </a:r>
-          </a:p>
-          <a:p>
-            <a:pPr lvl="1">
-              <a:spcAft>
-                <a:spcPts val="400"/>
-              </a:spcAft>
-              <a:defRPr sz="1700">
-                <a:solidFill>
-                  <a:srgbClr val="666666"/>
-                </a:solidFill>
-                <a:latin typeface="Calibri"/>
-              </a:defRPr>
-            </a:pPr>
-            <a:r>
-              <a:t>    5. El Banco B verifica la firma del Banco A en la red (Alastria/EBSI)</a:t>
-            </a:r>
-          </a:p>
-          <a:p>
-            <a:pPr lvl="1">
-              <a:spcAft>
-                <a:spcPts val="400"/>
-              </a:spcAft>
-              <a:defRPr sz="1700">
-                <a:solidFill>
-                  <a:srgbClr val="666666"/>
-                </a:solidFill>
-                <a:latin typeface="Calibri"/>
-              </a:defRPr>
-            </a:pPr>
-            <a:r>
-              <a:t>    6. Si es valida, acepta el KYC sin repetir el proceso</a:t>
-            </a:r>
-          </a:p>
-          <a:p>
-            <a:pPr lvl="1">
-              <a:spcAft>
-                <a:spcPts val="400"/>
-              </a:spcAft>
-              <a:defRPr sz="1700">
-                <a:solidFill>
-                  <a:srgbClr val="666666"/>
-                </a:solidFill>
-                <a:latin typeface="Calibri"/>
-              </a:defRPr>
-            </a:pPr>
-            <a:r>
-              <a:t>    7. Ahorro: semanas de tramites reducidas a segundos</a:t>
+          <a:bodyPr wrap="square"/>
+          <a:lstStyle/>
+          <a:p>
+            <a:pPr algn="l">
+              <a:defRPr sz="2400" b="0">
+                <a:solidFill>
+                  <a:srgbClr val="FFFFFF"/>
+                </a:solidFill>
+                <a:latin typeface="Calibri"/>
+              </a:defRPr>
+            </a:pPr>
+            <a:r>
+              <a:t>De la teoria a la practica: como se usa la identidad descentralizada</a:t>
             </a:r>
           </a:p>
         </p:txBody>
@@ -5454,7 +5494,7 @@
               </a:defRPr>
             </a:pPr>
             <a:r>
-              <a:t>Caso 2: Titulos universitarios verificables</a:t>
+              <a:t>Caso 1: Onboarding KYC bancario con VCs</a:t>
             </a:r>
           </a:p>
         </p:txBody>
@@ -5536,7 +5576,7 @@
               </a:defRPr>
             </a:pPr>
             <a:r>
-              <a:t>Problema: verificar un titulo universitario requiere contactar a la universidad emisora</a:t>
+              <a:t>Problema: cada banco repite el proceso KYC (Know Your Customer) desde cero</a:t>
             </a:r>
           </a:p>
           <a:p>
@@ -5552,7 +5592,7 @@
               </a:defRPr>
             </a:pPr>
             <a:r>
-              <a:t>Solucion con VCs: la universidad emite el titulo como una Verifiable Credential</a:t>
+              <a:t>Solucion con VCs: el cliente hace KYC una vez y obtiene una VC reutilizable</a:t>
             </a:r>
           </a:p>
           <a:p>
@@ -5584,7 +5624,7 @@
               </a:defRPr>
             </a:pPr>
             <a:r>
-              <a:t>    1. El alumno se gradua y la universidad emite una VC con el titulo</a:t>
+              <a:t>    1. El cliente completa KYC en el Banco A (presenta DNI, justificante, etc.)</a:t>
             </a:r>
           </a:p>
           <a:p>
@@ -5600,7 +5640,7 @@
               </a:defRPr>
             </a:pPr>
             <a:r>
-              <a:t>    2. El alumno guarda la VC en su wallet</a:t>
+              <a:t>    2. El Banco A emite una VC de tipo 'KYC verificado' al cliente</a:t>
             </a:r>
           </a:p>
           <a:p>
@@ -5616,7 +5656,7 @@
               </a:defRPr>
             </a:pPr>
             <a:r>
-              <a:t>    3. Una empresa quiere verificar el titulo del candidato</a:t>
+              <a:t>    3. El cliente quiere abrir cuenta en el Banco B</a:t>
             </a:r>
           </a:p>
           <a:p>
@@ -5632,7 +5672,7 @@
               </a:defRPr>
             </a:pPr>
             <a:r>
-              <a:t>    4. El candidato presenta una VP con la VC del titulo</a:t>
+              <a:t>    4. Presenta la VC de KYC del Banco A al Banco B</a:t>
             </a:r>
           </a:p>
           <a:p>
@@ -5648,7 +5688,7 @@
               </a:defRPr>
             </a:pPr>
             <a:r>
-              <a:t>    5. La empresa verifica la firma de la universidad en la red</a:t>
+              <a:t>    5. El Banco B verifica la firma del Banco A en la red (Alastria/EBSI)</a:t>
             </a:r>
           </a:p>
           <a:p>
@@ -5664,23 +5704,23 @@
               </a:defRPr>
             </a:pPr>
             <a:r>
-              <a:t>    6. Resultado instantaneo: titulo autentico o falso</a:t>
-            </a:r>
-          </a:p>
-          <a:p>
-            <a:pPr>
-              <a:spcAft>
-                <a:spcPts val="800"/>
-              </a:spcAft>
-              <a:defRPr sz="2000">
-                <a:solidFill>
-                  <a:srgbClr val="333333"/>
-                </a:solidFill>
-                <a:latin typeface="Calibri"/>
-              </a:defRPr>
-            </a:pPr>
-            <a:r>
-              <a:t>Implementacion real: universidades espanolas en Alastria + proyecto EBSI Diplomas</a:t>
+              <a:t>    6. Si es valida, acepta el KYC sin repetir el proceso</a:t>
+            </a:r>
+          </a:p>
+          <a:p>
+            <a:pPr lvl="1">
+              <a:spcAft>
+                <a:spcPts val="400"/>
+              </a:spcAft>
+              <a:defRPr sz="1700">
+                <a:solidFill>
+                  <a:srgbClr val="666666"/>
+                </a:solidFill>
+                <a:latin typeface="Calibri"/>
+              </a:defRPr>
+            </a:pPr>
+            <a:r>
+              <a:t>    7. Ahorro: semanas de tramites reducidas a segundos</a:t>
             </a:r>
           </a:p>
         </p:txBody>
@@ -5775,7 +5815,7 @@
               </a:defRPr>
             </a:pPr>
             <a:r>
-              <a:t>Caso 3: Acceso a servicios entre empresas</a:t>
+              <a:t>Caso 2: Titulos universitarios verificables</a:t>
             </a:r>
           </a:p>
         </p:txBody>
@@ -5857,7 +5897,7 @@
               </a:defRPr>
             </a:pPr>
             <a:r>
-              <a:t>Problema: un empleado de la Empresa A necesita acceder a un sistema de la Empresa B</a:t>
+              <a:t>Problema: verificar un titulo universitario requiere contactar a la universidad emisora</a:t>
             </a:r>
           </a:p>
           <a:p>
@@ -5873,7 +5913,7 @@
               </a:defRPr>
             </a:pPr>
             <a:r>
-              <a:t>Hoy: se crea una cuenta en el sistema de B, con su propio usuario/password</a:t>
+              <a:t>Solucion con VCs: la universidad emite el titulo como una Verifiable Credential</a:t>
             </a:r>
           </a:p>
           <a:p>
@@ -5889,7 +5929,103 @@
               </a:defRPr>
             </a:pPr>
             <a:r>
-              <a:t>Con VCs: la Empresa A emite una credencial de empleado como VC</a:t>
+              <a:t>Flujo:</a:t>
+            </a:r>
+          </a:p>
+          <a:p>
+            <a:pPr lvl="1">
+              <a:spcAft>
+                <a:spcPts val="400"/>
+              </a:spcAft>
+              <a:defRPr sz="1700">
+                <a:solidFill>
+                  <a:srgbClr val="666666"/>
+                </a:solidFill>
+                <a:latin typeface="Calibri"/>
+              </a:defRPr>
+            </a:pPr>
+            <a:r>
+              <a:t>    1. El alumno se gradua y la universidad emite una VC con el titulo</a:t>
+            </a:r>
+          </a:p>
+          <a:p>
+            <a:pPr lvl="1">
+              <a:spcAft>
+                <a:spcPts val="400"/>
+              </a:spcAft>
+              <a:defRPr sz="1700">
+                <a:solidFill>
+                  <a:srgbClr val="666666"/>
+                </a:solidFill>
+                <a:latin typeface="Calibri"/>
+              </a:defRPr>
+            </a:pPr>
+            <a:r>
+              <a:t>    2. El alumno guarda la VC en su wallet</a:t>
+            </a:r>
+          </a:p>
+          <a:p>
+            <a:pPr lvl="1">
+              <a:spcAft>
+                <a:spcPts val="400"/>
+              </a:spcAft>
+              <a:defRPr sz="1700">
+                <a:solidFill>
+                  <a:srgbClr val="666666"/>
+                </a:solidFill>
+                <a:latin typeface="Calibri"/>
+              </a:defRPr>
+            </a:pPr>
+            <a:r>
+              <a:t>    3. Una empresa quiere verificar el titulo del candidato</a:t>
+            </a:r>
+          </a:p>
+          <a:p>
+            <a:pPr lvl="1">
+              <a:spcAft>
+                <a:spcPts val="400"/>
+              </a:spcAft>
+              <a:defRPr sz="1700">
+                <a:solidFill>
+                  <a:srgbClr val="666666"/>
+                </a:solidFill>
+                <a:latin typeface="Calibri"/>
+              </a:defRPr>
+            </a:pPr>
+            <a:r>
+              <a:t>    4. El candidato presenta una VP con la VC del titulo</a:t>
+            </a:r>
+          </a:p>
+          <a:p>
+            <a:pPr lvl="1">
+              <a:spcAft>
+                <a:spcPts val="400"/>
+              </a:spcAft>
+              <a:defRPr sz="1700">
+                <a:solidFill>
+                  <a:srgbClr val="666666"/>
+                </a:solidFill>
+                <a:latin typeface="Calibri"/>
+              </a:defRPr>
+            </a:pPr>
+            <a:r>
+              <a:t>    5. La empresa verifica la firma de la universidad en la red</a:t>
+            </a:r>
+          </a:p>
+          <a:p>
+            <a:pPr lvl="1">
+              <a:spcAft>
+                <a:spcPts val="400"/>
+              </a:spcAft>
+              <a:defRPr sz="1700">
+                <a:solidFill>
+                  <a:srgbClr val="666666"/>
+                </a:solidFill>
+                <a:latin typeface="Calibri"/>
+              </a:defRPr>
+            </a:pPr>
+            <a:r>
+              <a:t>    6. Resultado instantaneo: titulo autentico o falso</a:t>
             </a:r>
           </a:p>
           <a:p>
@@ -5905,87 +6041,7 @@
               </a:defRPr>
             </a:pPr>
             <a:r>
-              <a:t>Flujo:</a:t>
-            </a:r>
-          </a:p>
-          <a:p>
-            <a:pPr lvl="1">
-              <a:spcAft>
-                <a:spcPts val="400"/>
-              </a:spcAft>
-              <a:defRPr sz="1700">
-                <a:solidFill>
-                  <a:srgbClr val="666666"/>
-                </a:solidFill>
-                <a:latin typeface="Calibri"/>
-              </a:defRPr>
-            </a:pPr>
-            <a:r>
-              <a:t>    1. Empresa A emite VC: 'Juan es empleado con rol=auditor'</a:t>
-            </a:r>
-          </a:p>
-          <a:p>
-            <a:pPr lvl="1">
-              <a:spcAft>
-                <a:spcPts val="400"/>
-              </a:spcAft>
-              <a:defRPr sz="1700">
-                <a:solidFill>
-                  <a:srgbClr val="666666"/>
-                </a:solidFill>
-                <a:latin typeface="Calibri"/>
-              </a:defRPr>
-            </a:pPr>
-            <a:r>
-              <a:t>    2. Juan presenta la VC al sistema de Empresa B</a:t>
-            </a:r>
-          </a:p>
-          <a:p>
-            <a:pPr lvl="1">
-              <a:spcAft>
-                <a:spcPts val="400"/>
-              </a:spcAft>
-              <a:defRPr sz="1700">
-                <a:solidFill>
-                  <a:srgbClr val="666666"/>
-                </a:solidFill>
-                <a:latin typeface="Calibri"/>
-              </a:defRPr>
-            </a:pPr>
-            <a:r>
-              <a:t>    3. Empresa B verifica la VC y da acceso segun el rol</a:t>
-            </a:r>
-          </a:p>
-          <a:p>
-            <a:pPr lvl="1">
-              <a:spcAft>
-                <a:spcPts val="400"/>
-              </a:spcAft>
-              <a:defRPr sz="1700">
-                <a:solidFill>
-                  <a:srgbClr val="666666"/>
-                </a:solidFill>
-                <a:latin typeface="Calibri"/>
-              </a:defRPr>
-            </a:pPr>
-            <a:r>
-              <a:t>    4. No hay cuenta en B: la identidad viene de A</a:t>
-            </a:r>
-          </a:p>
-          <a:p>
-            <a:pPr>
-              <a:spcAft>
-                <a:spcPts val="800"/>
-              </a:spcAft>
-              <a:defRPr sz="2000">
-                <a:solidFill>
-                  <a:srgbClr val="333333"/>
-                </a:solidFill>
-                <a:latin typeface="Calibri"/>
-              </a:defRPr>
-            </a:pPr>
-            <a:r>
-              <a:t>Ventaja: cuando el empleado deja la Empresa A, se revoca la VC y pierde acceso en B automaticamente</a:t>
+              <a:t>Implementacion real: universidades espanolas en Alastria + proyecto EBSI Diplomas</a:t>
             </a:r>
           </a:p>
         </p:txBody>
@@ -6023,7 +6079,7 @@
             <a:avLst/>
           </a:prstGeom>
           <a:solidFill>
-            <a:srgbClr val="EC0000"/>
+            <a:srgbClr val="22627E"/>
           </a:solidFill>
           <a:ln>
             <a:noFill/>
@@ -6053,20 +6109,54 @@
       </p:sp>
       <p:sp>
         <p:nvSpPr>
-          <p:cNvPr id="3" name="Rectangle 2"/>
+          <p:cNvPr id="3" name="TextBox 2"/>
+          <p:cNvSpPr txBox="1"/>
+          <p:nvPr/>
+        </p:nvSpPr>
+        <p:spPr>
+          <a:xfrm>
+            <a:off x="457200" y="274320"/>
+            <a:ext cx="10972800" cy="731520"/>
+          </a:xfrm>
+          <a:prstGeom prst="rect">
+            <a:avLst/>
+          </a:prstGeom>
+          <a:noFill/>
+        </p:spPr>
+        <p:txBody>
+          <a:bodyPr wrap="square"/>
+          <a:lstStyle/>
+          <a:p>
+            <a:pPr algn="l">
+              <a:defRPr sz="3200" b="1">
+                <a:solidFill>
+                  <a:srgbClr val="22627E"/>
+                </a:solidFill>
+                <a:latin typeface="Calibri"/>
+              </a:defRPr>
+            </a:pPr>
+            <a:r>
+              <a:t>Caso 3: Acceso a servicios entre empresas</a:t>
+            </a:r>
+          </a:p>
+        </p:txBody>
+      </p:sp>
+      <p:sp>
+        <p:nvSpPr>
+          <p:cNvPr id="4" name="Rectangle 3"/>
           <p:cNvSpPr/>
           <p:nvPr/>
         </p:nvSpPr>
         <p:spPr>
           <a:xfrm>
-            <a:off x="457200" y="274320"/>
-            <a:ext cx="1645920" cy="457200"/>
+            <a:off x="457200" y="1051560"/>
+            <a:ext cx="10972800" cy="27432"/>
           </a:xfrm>
           <a:prstGeom prst="rect">
             <a:avLst/>
           </a:prstGeom>
           <a:solidFill>
-            <a:srgbClr val="EC0000"/>
+            <a:srgbClr val="22627E"/>
           </a:solidFill>
           <a:ln>
             <a:noFill/>
@@ -6096,124 +6186,13 @@
       </p:sp>
       <p:sp>
         <p:nvSpPr>
-          <p:cNvPr id="4" name="TextBox 3"/>
-          <p:cNvSpPr txBox="1"/>
-          <p:nvPr/>
-        </p:nvSpPr>
-        <p:spPr>
-          <a:xfrm>
-            <a:off x="457200" y="274320"/>
-            <a:ext cx="1645920" cy="457200"/>
-          </a:xfrm>
-          <a:prstGeom prst="rect">
-            <a:avLst/>
-          </a:prstGeom>
-          <a:noFill/>
-        </p:spPr>
-        <p:txBody>
-          <a:bodyPr wrap="square"/>
-          <a:lstStyle/>
-          <a:p>
-            <a:pPr algn="ctr">
-              <a:defRPr sz="1800" b="1">
-                <a:solidFill>
-                  <a:srgbClr val="FFFFFF"/>
-                </a:solidFill>
-                <a:latin typeface="Calibri"/>
-              </a:defRPr>
-            </a:pPr>
-            <a:r>
-              <a:t>DEBATE</a:t>
-            </a:r>
-          </a:p>
-        </p:txBody>
-      </p:sp>
-      <p:sp>
-        <p:nvSpPr>
           <p:cNvPr id="5" name="TextBox 4"/>
           <p:cNvSpPr txBox="1"/>
           <p:nvPr/>
         </p:nvSpPr>
         <p:spPr>
           <a:xfrm>
-            <a:off x="2377440" y="274320"/>
-            <a:ext cx="9144000" cy="731520"/>
-          </a:xfrm>
-          <a:prstGeom prst="rect">
-            <a:avLst/>
-          </a:prstGeom>
-          <a:noFill/>
-        </p:spPr>
-        <p:txBody>
-          <a:bodyPr wrap="square"/>
-          <a:lstStyle/>
-          <a:p>
-            <a:pPr algn="l">
-              <a:defRPr sz="3000" b="1">
-                <a:solidFill>
-                  <a:srgbClr val="333333"/>
-                </a:solidFill>
-                <a:latin typeface="Calibri"/>
-              </a:defRPr>
-            </a:pPr>
-            <a:r>
-              <a:t>Identidad digital en la empresa</a:t>
-            </a:r>
-          </a:p>
-        </p:txBody>
-      </p:sp>
-      <p:sp>
-        <p:nvSpPr>
-          <p:cNvPr id="6" name="Rectangle 5"/>
-          <p:cNvSpPr/>
-          <p:nvPr/>
-        </p:nvSpPr>
-        <p:spPr>
-          <a:xfrm>
-            <a:off x="457200" y="1051560"/>
-            <a:ext cx="10972800" cy="27432"/>
-          </a:xfrm>
-          <a:prstGeom prst="rect">
-            <a:avLst/>
-          </a:prstGeom>
-          <a:solidFill>
-            <a:srgbClr val="EC0000"/>
-          </a:solidFill>
-          <a:ln>
-            <a:noFill/>
-          </a:ln>
-        </p:spPr>
-        <p:style>
-          <a:lnRef idx="1">
-            <a:schemeClr val="accent1"/>
-          </a:lnRef>
-          <a:fillRef idx="3">
-            <a:schemeClr val="accent1"/>
-          </a:fillRef>
-          <a:effectRef idx="2">
-            <a:schemeClr val="accent1"/>
-          </a:effectRef>
-          <a:fontRef idx="minor">
-            <a:schemeClr val="lt1"/>
-          </a:fontRef>
-        </p:style>
-        <p:txBody>
-          <a:bodyPr rtlCol="0" anchor="ctr"/>
-          <a:lstStyle/>
-          <a:p>
-            <a:pPr algn="ctr"/>
-          </a:p>
-        </p:txBody>
-      </p:sp>
-      <p:sp>
-        <p:nvSpPr>
-          <p:cNvPr id="7" name="TextBox 6"/>
-          <p:cNvSpPr txBox="1"/>
-          <p:nvPr/>
-        </p:nvSpPr>
-        <p:spPr>
-          <a:xfrm>
-            <a:off x="640080" y="1371600"/>
+            <a:off x="640080" y="1280160"/>
             <a:ext cx="10515600" cy="5029200"/>
           </a:xfrm>
           <a:prstGeom prst="rect">
@@ -6229,81 +6208,145 @@
           <a:p>
             <a:pPr>
               <a:spcAft>
-                <a:spcPts val="1600"/>
-              </a:spcAft>
-              <a:defRPr sz="2200">
-                <a:solidFill>
-                  <a:srgbClr val="333333"/>
-                </a:solidFill>
-                <a:latin typeface="Calibri"/>
-              </a:defRPr>
-            </a:pPr>
-            <a:r>
-              <a:t>1. ¿Que ventajas reales tiene la identidad descentralizada frente a un SSO corporativo (Okta, Azure AD)?</a:t>
-            </a:r>
-          </a:p>
-          <a:p>
-            <a:pPr>
-              <a:spcAft>
-                <a:spcPts val="1600"/>
-              </a:spcAft>
-              <a:defRPr sz="2200">
-                <a:solidFill>
-                  <a:srgbClr val="333333"/>
-                </a:solidFill>
-                <a:latin typeface="Calibri"/>
-              </a:defRPr>
-            </a:pPr>
-            <a:r>
-              <a:t>2. ¿Quien deberia ser el 'trusted issuer' para credenciales profesionales? ¿La empresa, un colegio profesional, el Estado?</a:t>
-            </a:r>
-          </a:p>
-          <a:p>
-            <a:pPr>
-              <a:spcAft>
-                <a:spcPts val="1600"/>
-              </a:spcAft>
-              <a:defRPr sz="2200">
-                <a:solidFill>
-                  <a:srgbClr val="333333"/>
-                </a:solidFill>
-                <a:latin typeface="Calibri"/>
-              </a:defRPr>
-            </a:pPr>
-            <a:r>
-              <a:t>3. Si un empleado tiene una VC de 'ingeniero certificado' y la empresa que la emitio cierra, ¿sigue siendo valida?</a:t>
-            </a:r>
-          </a:p>
-          <a:p>
-            <a:pPr>
-              <a:spcAft>
-                <a:spcPts val="1600"/>
-              </a:spcAft>
-              <a:defRPr sz="2200">
-                <a:solidFill>
-                  <a:srgbClr val="333333"/>
-                </a:solidFill>
-                <a:latin typeface="Calibri"/>
-              </a:defRPr>
-            </a:pPr>
-            <a:r>
-              <a:t>4. ¿Como afecta el GDPR al almacenamiento de datos personales en una VC? ¿Y si la VC esta en blockchain?</a:t>
-            </a:r>
-          </a:p>
-          <a:p>
-            <a:pPr>
-              <a:spcAft>
-                <a:spcPts val="1600"/>
-              </a:spcAft>
-              <a:defRPr sz="2200">
-                <a:solidFill>
-                  <a:srgbClr val="333333"/>
-                </a:solidFill>
-                <a:latin typeface="Calibri"/>
-              </a:defRPr>
-            </a:pPr>
-            <a:r>
-              <a:t>5. ¿Veis aplicacion en vuestro sector para las VCs?</a:t>
+                <a:spcPts val="800"/>
+              </a:spcAft>
+              <a:defRPr sz="2000">
+                <a:solidFill>
+                  <a:srgbClr val="333333"/>
+                </a:solidFill>
+                <a:latin typeface="Calibri"/>
+              </a:defRPr>
+            </a:pPr>
+            <a:r>
+              <a:t>Problema: un empleado de la Empresa A necesita acceder a un sistema de la Empresa B</a:t>
+            </a:r>
+          </a:p>
+          <a:p>
+            <a:pPr>
+              <a:spcAft>
+                <a:spcPts val="800"/>
+              </a:spcAft>
+              <a:defRPr sz="2000">
+                <a:solidFill>
+                  <a:srgbClr val="333333"/>
+                </a:solidFill>
+                <a:latin typeface="Calibri"/>
+              </a:defRPr>
+            </a:pPr>
+            <a:r>
+              <a:t>Hoy: se crea una cuenta en el sistema de B, con su propio usuario/password</a:t>
+            </a:r>
+          </a:p>
+          <a:p>
+            <a:pPr>
+              <a:spcAft>
+                <a:spcPts val="800"/>
+              </a:spcAft>
+              <a:defRPr sz="2000">
+                <a:solidFill>
+                  <a:srgbClr val="333333"/>
+                </a:solidFill>
+                <a:latin typeface="Calibri"/>
+              </a:defRPr>
+            </a:pPr>
+            <a:r>
+              <a:t>Con VCs: la Empresa A emite una credencial de empleado como VC</a:t>
+            </a:r>
+          </a:p>
+          <a:p>
+            <a:pPr>
+              <a:spcAft>
+                <a:spcPts val="800"/>
+              </a:spcAft>
+              <a:defRPr sz="2000">
+                <a:solidFill>
+                  <a:srgbClr val="333333"/>
+                </a:solidFill>
+                <a:latin typeface="Calibri"/>
+              </a:defRPr>
+            </a:pPr>
+            <a:r>
+              <a:t>Flujo:</a:t>
+            </a:r>
+          </a:p>
+          <a:p>
+            <a:pPr lvl="1">
+              <a:spcAft>
+                <a:spcPts val="400"/>
+              </a:spcAft>
+              <a:defRPr sz="1700">
+                <a:solidFill>
+                  <a:srgbClr val="666666"/>
+                </a:solidFill>
+                <a:latin typeface="Calibri"/>
+              </a:defRPr>
+            </a:pPr>
+            <a:r>
+              <a:t>    1. Empresa A emite VC: 'Juan es empleado con rol=auditor'</a:t>
+            </a:r>
+          </a:p>
+          <a:p>
+            <a:pPr lvl="1">
+              <a:spcAft>
+                <a:spcPts val="400"/>
+              </a:spcAft>
+              <a:defRPr sz="1700">
+                <a:solidFill>
+                  <a:srgbClr val="666666"/>
+                </a:solidFill>
+                <a:latin typeface="Calibri"/>
+              </a:defRPr>
+            </a:pPr>
+            <a:r>
+              <a:t>    2. Juan presenta la VC al sistema de Empresa B</a:t>
+            </a:r>
+          </a:p>
+          <a:p>
+            <a:pPr lvl="1">
+              <a:spcAft>
+                <a:spcPts val="400"/>
+              </a:spcAft>
+              <a:defRPr sz="1700">
+                <a:solidFill>
+                  <a:srgbClr val="666666"/>
+                </a:solidFill>
+                <a:latin typeface="Calibri"/>
+              </a:defRPr>
+            </a:pPr>
+            <a:r>
+              <a:t>    3. Empresa B verifica la VC y da acceso segun el rol</a:t>
+            </a:r>
+          </a:p>
+          <a:p>
+            <a:pPr lvl="1">
+              <a:spcAft>
+                <a:spcPts val="400"/>
+              </a:spcAft>
+              <a:defRPr sz="1700">
+                <a:solidFill>
+                  <a:srgbClr val="666666"/>
+                </a:solidFill>
+                <a:latin typeface="Calibri"/>
+              </a:defRPr>
+            </a:pPr>
+            <a:r>
+              <a:t>    4. No hay cuenta en B: la identidad viene de A</a:t>
+            </a:r>
+          </a:p>
+          <a:p>
+            <a:pPr>
+              <a:spcAft>
+                <a:spcPts val="800"/>
+              </a:spcAft>
+              <a:defRPr sz="2000">
+                <a:solidFill>
+                  <a:srgbClr val="333333"/>
+                </a:solidFill>
+                <a:latin typeface="Calibri"/>
+              </a:defRPr>
+            </a:pPr>
+            <a:r>
+              <a:t>Ventaja: cuando el empleado deja la Empresa A, se revoca la VC y pierde acceso en B automaticamente</a:t>
             </a:r>
           </a:p>
         </p:txBody>
@@ -6472,13 +6515,13 @@
         <p:spPr>
           <a:xfrm>
             <a:off x="0" y="0"/>
-            <a:ext cx="12188952" cy="6858000"/>
+            <a:ext cx="12188952" cy="73152"/>
           </a:xfrm>
           <a:prstGeom prst="rect">
             <a:avLst/>
           </a:prstGeom>
           <a:solidFill>
-            <a:srgbClr val="22627E"/>
+            <a:srgbClr val="EC0000"/>
           </a:solidFill>
           <a:ln>
             <a:noFill/>
@@ -6508,39 +6551,44 @@
       </p:sp>
       <p:sp>
         <p:nvSpPr>
-          <p:cNvPr id="3" name="TextBox 2"/>
-          <p:cNvSpPr txBox="1"/>
-          <p:nvPr/>
-        </p:nvSpPr>
-        <p:spPr>
-          <a:xfrm>
-            <a:off x="914400" y="2286000"/>
-            <a:ext cx="10058400" cy="1828800"/>
-          </a:xfrm>
-          <a:prstGeom prst="rect">
-            <a:avLst/>
-          </a:prstGeom>
-          <a:noFill/>
-        </p:spPr>
-        <p:txBody>
-          <a:bodyPr wrap="square"/>
-          <a:lstStyle/>
-          <a:p>
-            <a:pPr algn="l">
-              <a:defRPr sz="4800" b="1">
-                <a:solidFill>
-                  <a:srgbClr val="FFFFFF"/>
-                </a:solidFill>
-                <a:latin typeface="Calibri"/>
-              </a:defRPr>
-            </a:pPr>
-            <a:r>
-              <a:t>Arquitecturas Hibridas</a:t>
-            </a:r>
-            <a:br/>
-            <a:r>
-              <a:t>con Multiples Redes</a:t>
-            </a:r>
+          <p:cNvPr id="3" name="Rectangle 2"/>
+          <p:cNvSpPr/>
+          <p:nvPr/>
+        </p:nvSpPr>
+        <p:spPr>
+          <a:xfrm>
+            <a:off x="457200" y="274320"/>
+            <a:ext cx="1645920" cy="457200"/>
+          </a:xfrm>
+          <a:prstGeom prst="rect">
+            <a:avLst/>
+          </a:prstGeom>
+          <a:solidFill>
+            <a:srgbClr val="EC0000"/>
+          </a:solidFill>
+          <a:ln>
+            <a:noFill/>
+          </a:ln>
+        </p:spPr>
+        <p:style>
+          <a:lnRef idx="1">
+            <a:schemeClr val="accent1"/>
+          </a:lnRef>
+          <a:fillRef idx="3">
+            <a:schemeClr val="accent1"/>
+          </a:fillRef>
+          <a:effectRef idx="2">
+            <a:schemeClr val="accent1"/>
+          </a:effectRef>
+          <a:fontRef idx="minor">
+            <a:schemeClr val="lt1"/>
+          </a:fontRef>
+        </p:style>
+        <p:txBody>
+          <a:bodyPr rtlCol="0" anchor="ctr"/>
+          <a:lstStyle/>
+          <a:p>
+            <a:pPr algn="ctr"/>
           </a:p>
         </p:txBody>
       </p:sp>
@@ -6552,8 +6600,8 @@
         </p:nvSpPr>
         <p:spPr>
           <a:xfrm>
-            <a:off x="914400" y="4114800"/>
-            <a:ext cx="10058400" cy="1371600"/>
+            <a:off x="457200" y="274320"/>
+            <a:ext cx="1645920" cy="457200"/>
           </a:xfrm>
           <a:prstGeom prst="rect">
             <a:avLst/>
@@ -6564,16 +6612,196 @@
           <a:bodyPr wrap="square"/>
           <a:lstStyle/>
           <a:p>
+            <a:pPr algn="ctr">
+              <a:defRPr sz="1800" b="1">
+                <a:solidFill>
+                  <a:srgbClr val="FFFFFF"/>
+                </a:solidFill>
+                <a:latin typeface="Calibri"/>
+              </a:defRPr>
+            </a:pPr>
+            <a:r>
+              <a:t>DEBATE</a:t>
+            </a:r>
+          </a:p>
+        </p:txBody>
+      </p:sp>
+      <p:sp>
+        <p:nvSpPr>
+          <p:cNvPr id="5" name="TextBox 4"/>
+          <p:cNvSpPr txBox="1"/>
+          <p:nvPr/>
+        </p:nvSpPr>
+        <p:spPr>
+          <a:xfrm>
+            <a:off x="2377440" y="274320"/>
+            <a:ext cx="9144000" cy="731520"/>
+          </a:xfrm>
+          <a:prstGeom prst="rect">
+            <a:avLst/>
+          </a:prstGeom>
+          <a:noFill/>
+        </p:spPr>
+        <p:txBody>
+          <a:bodyPr wrap="square"/>
+          <a:lstStyle/>
+          <a:p>
             <a:pPr algn="l">
-              <a:defRPr sz="2400" b="0">
-                <a:solidFill>
-                  <a:srgbClr val="FFFFFF"/>
-                </a:solidFill>
-                <a:latin typeface="Calibri"/>
-              </a:defRPr>
-            </a:pPr>
-            <a:r>
-              <a:t>Identidad en una red, negocio en otra</a:t>
+              <a:defRPr sz="3000" b="1">
+                <a:solidFill>
+                  <a:srgbClr val="333333"/>
+                </a:solidFill>
+                <a:latin typeface="Calibri"/>
+              </a:defRPr>
+            </a:pPr>
+            <a:r>
+              <a:t>Identidad digital en la empresa</a:t>
+            </a:r>
+          </a:p>
+        </p:txBody>
+      </p:sp>
+      <p:sp>
+        <p:nvSpPr>
+          <p:cNvPr id="6" name="Rectangle 5"/>
+          <p:cNvSpPr/>
+          <p:nvPr/>
+        </p:nvSpPr>
+        <p:spPr>
+          <a:xfrm>
+            <a:off x="457200" y="1051560"/>
+            <a:ext cx="10972800" cy="27432"/>
+          </a:xfrm>
+          <a:prstGeom prst="rect">
+            <a:avLst/>
+          </a:prstGeom>
+          <a:solidFill>
+            <a:srgbClr val="EC0000"/>
+          </a:solidFill>
+          <a:ln>
+            <a:noFill/>
+          </a:ln>
+        </p:spPr>
+        <p:style>
+          <a:lnRef idx="1">
+            <a:schemeClr val="accent1"/>
+          </a:lnRef>
+          <a:fillRef idx="3">
+            <a:schemeClr val="accent1"/>
+          </a:fillRef>
+          <a:effectRef idx="2">
+            <a:schemeClr val="accent1"/>
+          </a:effectRef>
+          <a:fontRef idx="minor">
+            <a:schemeClr val="lt1"/>
+          </a:fontRef>
+        </p:style>
+        <p:txBody>
+          <a:bodyPr rtlCol="0" anchor="ctr"/>
+          <a:lstStyle/>
+          <a:p>
+            <a:pPr algn="ctr"/>
+          </a:p>
+        </p:txBody>
+      </p:sp>
+      <p:sp>
+        <p:nvSpPr>
+          <p:cNvPr id="7" name="TextBox 6"/>
+          <p:cNvSpPr txBox="1"/>
+          <p:nvPr/>
+        </p:nvSpPr>
+        <p:spPr>
+          <a:xfrm>
+            <a:off x="640080" y="1371600"/>
+            <a:ext cx="10515600" cy="5029200"/>
+          </a:xfrm>
+          <a:prstGeom prst="rect">
+            <a:avLst/>
+          </a:prstGeom>
+          <a:noFill/>
+        </p:spPr>
+        <p:txBody>
+          <a:bodyPr wrap="square">
+            <a:spAutoFit/>
+          </a:bodyPr>
+          <a:lstStyle/>
+          <a:p>
+            <a:pPr>
+              <a:spcAft>
+                <a:spcPts val="1600"/>
+              </a:spcAft>
+              <a:defRPr sz="2200">
+                <a:solidFill>
+                  <a:srgbClr val="333333"/>
+                </a:solidFill>
+                <a:latin typeface="Calibri"/>
+              </a:defRPr>
+            </a:pPr>
+            <a:r>
+              <a:t>1. ¿Que ventajas reales tiene la identidad descentralizada frente a un SSO corporativo (Okta, Azure AD)?</a:t>
+            </a:r>
+          </a:p>
+          <a:p>
+            <a:pPr>
+              <a:spcAft>
+                <a:spcPts val="1600"/>
+              </a:spcAft>
+              <a:defRPr sz="2200">
+                <a:solidFill>
+                  <a:srgbClr val="333333"/>
+                </a:solidFill>
+                <a:latin typeface="Calibri"/>
+              </a:defRPr>
+            </a:pPr>
+            <a:r>
+              <a:t>2. ¿Quien deberia ser el 'trusted issuer' para credenciales profesionales? ¿La empresa, un colegio profesional, el Estado?</a:t>
+            </a:r>
+          </a:p>
+          <a:p>
+            <a:pPr>
+              <a:spcAft>
+                <a:spcPts val="1600"/>
+              </a:spcAft>
+              <a:defRPr sz="2200">
+                <a:solidFill>
+                  <a:srgbClr val="333333"/>
+                </a:solidFill>
+                <a:latin typeface="Calibri"/>
+              </a:defRPr>
+            </a:pPr>
+            <a:r>
+              <a:t>3. Si un empleado tiene una VC de 'ingeniero certificado' y la empresa que la emitio cierra, ¿sigue siendo valida?</a:t>
+            </a:r>
+          </a:p>
+          <a:p>
+            <a:pPr>
+              <a:spcAft>
+                <a:spcPts val="1600"/>
+              </a:spcAft>
+              <a:defRPr sz="2200">
+                <a:solidFill>
+                  <a:srgbClr val="333333"/>
+                </a:solidFill>
+                <a:latin typeface="Calibri"/>
+              </a:defRPr>
+            </a:pPr>
+            <a:r>
+              <a:t>4. ¿Como afecta el GDPR al almacenamiento de datos personales en una VC? ¿Y si la VC esta en blockchain?</a:t>
+            </a:r>
+          </a:p>
+          <a:p>
+            <a:pPr>
+              <a:spcAft>
+                <a:spcPts val="1600"/>
+              </a:spcAft>
+              <a:defRPr sz="2200">
+                <a:solidFill>
+                  <a:srgbClr val="333333"/>
+                </a:solidFill>
+                <a:latin typeface="Calibri"/>
+              </a:defRPr>
+            </a:pPr>
+            <a:r>
+              <a:t>5. ¿Veis aplicacion en vuestro sector para las VCs?</a:t>
             </a:r>
           </a:p>
         </p:txBody>
@@ -6605,7 +6833,7 @@
         <p:spPr>
           <a:xfrm>
             <a:off x="0" y="0"/>
-            <a:ext cx="12188952" cy="73152"/>
+            <a:ext cx="12188952" cy="6858000"/>
           </a:xfrm>
           <a:prstGeom prst="rect">
             <a:avLst/>
@@ -6647,8 +6875,8 @@
         </p:nvSpPr>
         <p:spPr>
           <a:xfrm>
-            <a:off x="457200" y="274320"/>
-            <a:ext cx="10972800" cy="731520"/>
+            <a:off x="914400" y="2286000"/>
+            <a:ext cx="10058400" cy="1828800"/>
           </a:xfrm>
           <a:prstGeom prst="rect">
             <a:avLst/>
@@ -6660,72 +6888,33 @@
           <a:lstStyle/>
           <a:p>
             <a:pPr algn="l">
-              <a:defRPr sz="3200" b="1">
-                <a:solidFill>
-                  <a:srgbClr val="22627E"/>
-                </a:solidFill>
-                <a:latin typeface="Calibri"/>
-              </a:defRPr>
-            </a:pPr>
-            <a:r>
-              <a:t>¿Por que arquitecturas hibridas?</a:t>
-            </a:r>
-          </a:p>
-        </p:txBody>
-      </p:sp>
-      <p:sp>
-        <p:nvSpPr>
-          <p:cNvPr id="4" name="Rectangle 3"/>
-          <p:cNvSpPr/>
-          <p:nvPr/>
-        </p:nvSpPr>
-        <p:spPr>
-          <a:xfrm>
-            <a:off x="457200" y="1051560"/>
-            <a:ext cx="10972800" cy="27432"/>
-          </a:xfrm>
-          <a:prstGeom prst="rect">
-            <a:avLst/>
-          </a:prstGeom>
-          <a:solidFill>
-            <a:srgbClr val="22627E"/>
-          </a:solidFill>
-          <a:ln>
-            <a:noFill/>
-          </a:ln>
-        </p:spPr>
-        <p:style>
-          <a:lnRef idx="1">
-            <a:schemeClr val="accent1"/>
-          </a:lnRef>
-          <a:fillRef idx="3">
-            <a:schemeClr val="accent1"/>
-          </a:fillRef>
-          <a:effectRef idx="2">
-            <a:schemeClr val="accent1"/>
-          </a:effectRef>
-          <a:fontRef idx="minor">
-            <a:schemeClr val="lt1"/>
-          </a:fontRef>
-        </p:style>
-        <p:txBody>
-          <a:bodyPr rtlCol="0" anchor="ctr"/>
-          <a:lstStyle/>
-          <a:p>
-            <a:pPr algn="ctr"/>
-          </a:p>
-        </p:txBody>
-      </p:sp>
-      <p:sp>
-        <p:nvSpPr>
-          <p:cNvPr id="5" name="TextBox 4"/>
+              <a:defRPr sz="4800" b="1">
+                <a:solidFill>
+                  <a:srgbClr val="FFFFFF"/>
+                </a:solidFill>
+                <a:latin typeface="Calibri"/>
+              </a:defRPr>
+            </a:pPr>
+            <a:r>
+              <a:t>Arquitecturas Hibridas</a:t>
+            </a:r>
+            <a:br/>
+            <a:r>
+              <a:t>con Multiples Redes</a:t>
+            </a:r>
+          </a:p>
+        </p:txBody>
+      </p:sp>
+      <p:sp>
+        <p:nvSpPr>
+          <p:cNvPr id="4" name="TextBox 3"/>
           <p:cNvSpPr txBox="1"/>
           <p:nvPr/>
         </p:nvSpPr>
         <p:spPr>
           <a:xfrm>
-            <a:off x="640080" y="1280160"/>
-            <a:ext cx="10515600" cy="5029200"/>
+            <a:off x="914400" y="4114800"/>
+            <a:ext cx="10058400" cy="1371600"/>
           </a:xfrm>
           <a:prstGeom prst="rect">
             <a:avLst/>
@@ -6733,152 +6922,19 @@
           <a:noFill/>
         </p:spPr>
         <p:txBody>
-          <a:bodyPr wrap="square">
-            <a:spAutoFit/>
-          </a:bodyPr>
-          <a:lstStyle/>
-          <a:p>
-            <a:pPr>
-              <a:spcAft>
-                <a:spcPts val="800"/>
-              </a:spcAft>
-              <a:defRPr sz="2000">
-                <a:solidFill>
-                  <a:srgbClr val="333333"/>
-                </a:solidFill>
-                <a:latin typeface="Calibri"/>
-              </a:defRPr>
-            </a:pPr>
-            <a:r>
-              <a:t>En el mundo real, una sola blockchain no resuelve todo</a:t>
-            </a:r>
-          </a:p>
-          <a:p>
-            <a:pPr>
-              <a:spcAft>
-                <a:spcPts val="800"/>
-              </a:spcAft>
-              <a:defRPr sz="2000">
-                <a:solidFill>
-                  <a:srgbClr val="333333"/>
-                </a:solidFill>
-                <a:latin typeface="Calibri"/>
-              </a:defRPr>
-            </a:pPr>
-            <a:r>
-              <a:t>Cada red tiene su fortaleza:</a:t>
-            </a:r>
-          </a:p>
-          <a:p>
-            <a:pPr lvl="1">
-              <a:spcAft>
-                <a:spcPts val="400"/>
-              </a:spcAft>
-              <a:defRPr sz="1700">
-                <a:solidFill>
-                  <a:srgbClr val="666666"/>
-                </a:solidFill>
-                <a:latin typeface="Calibri"/>
-              </a:defRPr>
-            </a:pPr>
-            <a:r>
-              <a:t>    Red publica (EBSI, Alastria): identidad, credenciales, confianza</a:t>
-            </a:r>
-          </a:p>
-          <a:p>
-            <a:pPr lvl="1">
-              <a:spcAft>
-                <a:spcPts val="400"/>
-              </a:spcAft>
-              <a:defRPr sz="1700">
-                <a:solidFill>
-                  <a:srgbClr val="666666"/>
-                </a:solidFill>
-                <a:latin typeface="Calibri"/>
-              </a:defRPr>
-            </a:pPr>
-            <a:r>
-              <a:t>    Red privada (Fabric): logica de negocio, transacciones, datos confidenciales</a:t>
-            </a:r>
-          </a:p>
-          <a:p>
-            <a:pPr lvl="1">
-              <a:spcAft>
-                <a:spcPts val="400"/>
-              </a:spcAft>
-              <a:defRPr sz="1700">
-                <a:solidFill>
-                  <a:srgbClr val="666666"/>
-                </a:solidFill>
-                <a:latin typeface="Calibri"/>
-              </a:defRPr>
-            </a:pPr>
-            <a:r>
-              <a:t>    Cada una gobernada por distintos actores con distintas reglas</a:t>
-            </a:r>
-          </a:p>
-          <a:p>
-            <a:pPr>
-              <a:spcAft>
-                <a:spcPts val="800"/>
-              </a:spcAft>
-              <a:defRPr sz="2000">
-                <a:solidFill>
-                  <a:srgbClr val="333333"/>
-                </a:solidFill>
-                <a:latin typeface="Calibri"/>
-              </a:defRPr>
-            </a:pPr>
-            <a:r>
-              <a:t>La arquitectura hibrida combina lo mejor de cada una:</a:t>
-            </a:r>
-          </a:p>
-          <a:p>
-            <a:pPr lvl="1">
-              <a:spcAft>
-                <a:spcPts val="400"/>
-              </a:spcAft>
-              <a:defRPr sz="1700">
-                <a:solidFill>
-                  <a:srgbClr val="666666"/>
-                </a:solidFill>
-                <a:latin typeface="Calibri"/>
-              </a:defRPr>
-            </a:pPr>
-            <a:r>
-              <a:t>    Identidad: interoperable, verificable por cualquiera, en red publica/consorcio</a:t>
-            </a:r>
-          </a:p>
-          <a:p>
-            <a:pPr lvl="1">
-              <a:spcAft>
-                <a:spcPts val="400"/>
-              </a:spcAft>
-              <a:defRPr sz="1700">
-                <a:solidFill>
-                  <a:srgbClr val="666666"/>
-                </a:solidFill>
-                <a:latin typeface="Calibri"/>
-              </a:defRPr>
-            </a:pPr>
-            <a:r>
-              <a:t>    Negocio: privado, rapido, solo entre los participantes, en Fabric</a:t>
-            </a:r>
-          </a:p>
-          <a:p>
-            <a:pPr>
-              <a:spcAft>
-                <a:spcPts val="800"/>
-              </a:spcAft>
-              <a:defRPr sz="2000">
-                <a:solidFill>
-                  <a:srgbClr val="333333"/>
-                </a:solidFill>
-                <a:latin typeface="Calibri"/>
-              </a:defRPr>
-            </a:pPr>
-            <a:r>
-              <a:t>Ejemplo: Alastria para identidad + Fabric para logica de negocio</a:t>
+          <a:bodyPr wrap="square"/>
+          <a:lstStyle/>
+          <a:p>
+            <a:pPr algn="l">
+              <a:defRPr sz="2400" b="0">
+                <a:solidFill>
+                  <a:srgbClr val="FFFFFF"/>
+                </a:solidFill>
+                <a:latin typeface="Calibri"/>
+              </a:defRPr>
+            </a:pPr>
+            <a:r>
+              <a:t>Identidad en una red, negocio en otra</a:t>
             </a:r>
           </a:p>
         </p:txBody>
@@ -6973,7 +7029,7 @@
               </a:defRPr>
             </a:pPr>
             <a:r>
-              <a:t>Arquitectura hibrida: Alastria + Fabric</a:t>
+              <a:t>¿Por que arquitecturas hibridas?</a:t>
             </a:r>
           </a:p>
         </p:txBody>
@@ -7023,57 +7079,14 @@
       </p:sp>
       <p:sp>
         <p:nvSpPr>
-          <p:cNvPr id="5" name="Rectangle 4"/>
-          <p:cNvSpPr/>
-          <p:nvPr/>
-        </p:nvSpPr>
-        <p:spPr>
-          <a:xfrm>
-            <a:off x="1371600" y="1371600"/>
-            <a:ext cx="9418320" cy="4114800"/>
-          </a:xfrm>
-          <a:prstGeom prst="rect">
-            <a:avLst/>
-          </a:prstGeom>
-          <a:solidFill>
-            <a:srgbClr val="F2F2F2"/>
-          </a:solidFill>
-          <a:ln>
-            <a:noFill/>
-          </a:ln>
-        </p:spPr>
-        <p:style>
-          <a:lnRef idx="1">
-            <a:schemeClr val="accent1"/>
-          </a:lnRef>
-          <a:fillRef idx="3">
-            <a:schemeClr val="accent1"/>
-          </a:fillRef>
-          <a:effectRef idx="2">
-            <a:schemeClr val="accent1"/>
-          </a:effectRef>
-          <a:fontRef idx="minor">
-            <a:schemeClr val="lt1"/>
-          </a:fontRef>
-        </p:style>
-        <p:txBody>
-          <a:bodyPr rtlCol="0" anchor="ctr"/>
-          <a:lstStyle/>
-          <a:p>
-            <a:pPr algn="ctr"/>
-          </a:p>
-        </p:txBody>
-      </p:sp>
-      <p:sp>
-        <p:nvSpPr>
-          <p:cNvPr id="6" name="TextBox 5"/>
+          <p:cNvPr id="5" name="TextBox 4"/>
           <p:cNvSpPr txBox="1"/>
           <p:nvPr/>
         </p:nvSpPr>
         <p:spPr>
           <a:xfrm>
-            <a:off x="1828800" y="2286000"/>
-            <a:ext cx="8503920" cy="1371600"/>
+            <a:off x="640080" y="1280160"/>
+            <a:ext cx="10515600" cy="5029200"/>
           </a:xfrm>
           <a:prstGeom prst="rect">
             <a:avLst/>
@@ -7081,130 +7094,152 @@
           <a:noFill/>
         </p:spPr>
         <p:txBody>
-          <a:bodyPr wrap="square"/>
-          <a:lstStyle/>
-          <a:p>
-            <a:pPr algn="ctr">
-              <a:defRPr sz="2400" b="0">
-                <a:solidFill>
-                  <a:srgbClr val="999999"/>
-                </a:solidFill>
-                <a:latin typeface="Calibri"/>
-              </a:defRPr>
-            </a:pPr>
-            <a:r>
-              <a:t>[Diagrama: Red Alastria (identidad, DIDs, VCs) conectada con Red Fabric (canales, chaincodes, ledger)]</a:t>
-            </a:r>
-          </a:p>
-        </p:txBody>
-      </p:sp>
-      <p:sp>
-        <p:nvSpPr>
-          <p:cNvPr id="7" name="Rectangle 6"/>
-          <p:cNvSpPr/>
-          <p:nvPr/>
-        </p:nvSpPr>
-        <p:spPr>
-          <a:xfrm>
-            <a:off x="1371600" y="3840480"/>
-            <a:ext cx="9418320" cy="320040"/>
-          </a:xfrm>
-          <a:prstGeom prst="rect">
-            <a:avLst/>
-          </a:prstGeom>
-          <a:solidFill>
-            <a:srgbClr val="7C3AED"/>
-          </a:solidFill>
-          <a:ln>
-            <a:noFill/>
-          </a:ln>
-        </p:spPr>
-        <p:style>
-          <a:lnRef idx="1">
-            <a:schemeClr val="accent1"/>
-          </a:lnRef>
-          <a:fillRef idx="3">
-            <a:schemeClr val="accent1"/>
-          </a:fillRef>
-          <a:effectRef idx="2">
-            <a:schemeClr val="accent1"/>
-          </a:effectRef>
-          <a:fontRef idx="minor">
-            <a:schemeClr val="lt1"/>
-          </a:fontRef>
-        </p:style>
-        <p:txBody>
-          <a:bodyPr rtlCol="0" anchor="ctr"/>
-          <a:lstStyle/>
-          <a:p>
-            <a:pPr algn="ctr"/>
-          </a:p>
-        </p:txBody>
-      </p:sp>
-      <p:sp>
-        <p:nvSpPr>
-          <p:cNvPr id="8" name="TextBox 7"/>
-          <p:cNvSpPr txBox="1"/>
-          <p:nvPr/>
-        </p:nvSpPr>
-        <p:spPr>
-          <a:xfrm>
-            <a:off x="1371600" y="3840480"/>
-            <a:ext cx="9418320" cy="320040"/>
-          </a:xfrm>
-          <a:prstGeom prst="rect">
-            <a:avLst/>
-          </a:prstGeom>
-          <a:noFill/>
-        </p:spPr>
-        <p:txBody>
-          <a:bodyPr wrap="square"/>
-          <a:lstStyle/>
-          <a:p>
-            <a:pPr algn="ctr">
-              <a:defRPr sz="1300" b="1">
-                <a:solidFill>
-                  <a:srgbClr val="FFFFFF"/>
-                </a:solidFill>
-                <a:latin typeface="Calibri"/>
-              </a:defRPr>
-            </a:pPr>
-            <a:r>
-              <a:t>Prompt para IA generativa:</a:t>
-            </a:r>
-          </a:p>
-        </p:txBody>
-      </p:sp>
-      <p:sp>
-        <p:nvSpPr>
-          <p:cNvPr id="9" name="TextBox 8"/>
-          <p:cNvSpPr txBox="1"/>
-          <p:nvPr/>
-        </p:nvSpPr>
-        <p:spPr>
-          <a:xfrm>
-            <a:off x="1645920" y="4297680"/>
-            <a:ext cx="8869680" cy="914400"/>
-          </a:xfrm>
-          <a:prstGeom prst="rect">
-            <a:avLst/>
-          </a:prstGeom>
-          <a:noFill/>
-        </p:spPr>
-        <p:txBody>
-          <a:bodyPr wrap="square"/>
-          <a:lstStyle/>
-          <a:p>
-            <a:pPr algn="l">
-              <a:defRPr sz="1400" b="0">
-                <a:solidFill>
-                  <a:srgbClr val="7C3AED"/>
-                </a:solidFill>
-                <a:latin typeface="Consolas"/>
-              </a:defRPr>
-            </a:pPr>
-            <a:r>
-              <a:t>Split architecture diagram: left side shows Alastria network with DID Registry and VC issuance (blue tones), right side shows Hyperledger Fabric network with channels, chaincodes, and private ledger (green tones). Bridge in the middle showing identity verification flow. Clean corporate style.</a:t>
+          <a:bodyPr wrap="square">
+            <a:spAutoFit/>
+          </a:bodyPr>
+          <a:lstStyle/>
+          <a:p>
+            <a:pPr>
+              <a:spcAft>
+                <a:spcPts val="800"/>
+              </a:spcAft>
+              <a:defRPr sz="2000">
+                <a:solidFill>
+                  <a:srgbClr val="333333"/>
+                </a:solidFill>
+                <a:latin typeface="Calibri"/>
+              </a:defRPr>
+            </a:pPr>
+            <a:r>
+              <a:t>En el mundo real, una sola blockchain no resuelve todo</a:t>
+            </a:r>
+          </a:p>
+          <a:p>
+            <a:pPr>
+              <a:spcAft>
+                <a:spcPts val="800"/>
+              </a:spcAft>
+              <a:defRPr sz="2000">
+                <a:solidFill>
+                  <a:srgbClr val="333333"/>
+                </a:solidFill>
+                <a:latin typeface="Calibri"/>
+              </a:defRPr>
+            </a:pPr>
+            <a:r>
+              <a:t>Cada red tiene su fortaleza:</a:t>
+            </a:r>
+          </a:p>
+          <a:p>
+            <a:pPr lvl="1">
+              <a:spcAft>
+                <a:spcPts val="400"/>
+              </a:spcAft>
+              <a:defRPr sz="1700">
+                <a:solidFill>
+                  <a:srgbClr val="666666"/>
+                </a:solidFill>
+                <a:latin typeface="Calibri"/>
+              </a:defRPr>
+            </a:pPr>
+            <a:r>
+              <a:t>    Red publica (EBSI, Alastria): identidad, credenciales, confianza</a:t>
+            </a:r>
+          </a:p>
+          <a:p>
+            <a:pPr lvl="1">
+              <a:spcAft>
+                <a:spcPts val="400"/>
+              </a:spcAft>
+              <a:defRPr sz="1700">
+                <a:solidFill>
+                  <a:srgbClr val="666666"/>
+                </a:solidFill>
+                <a:latin typeface="Calibri"/>
+              </a:defRPr>
+            </a:pPr>
+            <a:r>
+              <a:t>    Red privada (Fabric): logica de negocio, transacciones, datos confidenciales</a:t>
+            </a:r>
+          </a:p>
+          <a:p>
+            <a:pPr lvl="1">
+              <a:spcAft>
+                <a:spcPts val="400"/>
+              </a:spcAft>
+              <a:defRPr sz="1700">
+                <a:solidFill>
+                  <a:srgbClr val="666666"/>
+                </a:solidFill>
+                <a:latin typeface="Calibri"/>
+              </a:defRPr>
+            </a:pPr>
+            <a:r>
+              <a:t>    Cada una gobernada por distintos actores con distintas reglas</a:t>
+            </a:r>
+          </a:p>
+          <a:p>
+            <a:pPr>
+              <a:spcAft>
+                <a:spcPts val="800"/>
+              </a:spcAft>
+              <a:defRPr sz="2000">
+                <a:solidFill>
+                  <a:srgbClr val="333333"/>
+                </a:solidFill>
+                <a:latin typeface="Calibri"/>
+              </a:defRPr>
+            </a:pPr>
+            <a:r>
+              <a:t>La arquitectura hibrida combina lo mejor de cada una:</a:t>
+            </a:r>
+          </a:p>
+          <a:p>
+            <a:pPr lvl="1">
+              <a:spcAft>
+                <a:spcPts val="400"/>
+              </a:spcAft>
+              <a:defRPr sz="1700">
+                <a:solidFill>
+                  <a:srgbClr val="666666"/>
+                </a:solidFill>
+                <a:latin typeface="Calibri"/>
+              </a:defRPr>
+            </a:pPr>
+            <a:r>
+              <a:t>    Identidad: interoperable, verificable por cualquiera, en red publica/consorcio</a:t>
+            </a:r>
+          </a:p>
+          <a:p>
+            <a:pPr lvl="1">
+              <a:spcAft>
+                <a:spcPts val="400"/>
+              </a:spcAft>
+              <a:defRPr sz="1700">
+                <a:solidFill>
+                  <a:srgbClr val="666666"/>
+                </a:solidFill>
+                <a:latin typeface="Calibri"/>
+              </a:defRPr>
+            </a:pPr>
+            <a:r>
+              <a:t>    Negocio: privado, rapido, solo entre los participantes, en Fabric</a:t>
+            </a:r>
+          </a:p>
+          <a:p>
+            <a:pPr>
+              <a:spcAft>
+                <a:spcPts val="800"/>
+              </a:spcAft>
+              <a:defRPr sz="2000">
+                <a:solidFill>
+                  <a:srgbClr val="333333"/>
+                </a:solidFill>
+                <a:latin typeface="Calibri"/>
+              </a:defRPr>
+            </a:pPr>
+            <a:r>
+              <a:t>Ejemplo: Alastria para identidad + Fabric para logica de negocio</a:t>
             </a:r>
           </a:p>
         </p:txBody>
@@ -7299,7 +7334,7 @@
               </a:defRPr>
             </a:pPr>
             <a:r>
-              <a:t>Patron: verificar identidad externa en Fabric</a:t>
+              <a:t>Arquitectura hibrida: Alastria + Fabric</a:t>
             </a:r>
           </a:p>
         </p:txBody>
@@ -7349,14 +7384,57 @@
       </p:sp>
       <p:sp>
         <p:nvSpPr>
-          <p:cNvPr id="5" name="TextBox 4"/>
+          <p:cNvPr id="5" name="Rectangle 4"/>
+          <p:cNvSpPr/>
+          <p:nvPr/>
+        </p:nvSpPr>
+        <p:spPr>
+          <a:xfrm>
+            <a:off x="1371600" y="1371600"/>
+            <a:ext cx="9418320" cy="4114800"/>
+          </a:xfrm>
+          <a:prstGeom prst="rect">
+            <a:avLst/>
+          </a:prstGeom>
+          <a:solidFill>
+            <a:srgbClr val="F2F2F2"/>
+          </a:solidFill>
+          <a:ln>
+            <a:noFill/>
+          </a:ln>
+        </p:spPr>
+        <p:style>
+          <a:lnRef idx="1">
+            <a:schemeClr val="accent1"/>
+          </a:lnRef>
+          <a:fillRef idx="3">
+            <a:schemeClr val="accent1"/>
+          </a:fillRef>
+          <a:effectRef idx="2">
+            <a:schemeClr val="accent1"/>
+          </a:effectRef>
+          <a:fontRef idx="minor">
+            <a:schemeClr val="lt1"/>
+          </a:fontRef>
+        </p:style>
+        <p:txBody>
+          <a:bodyPr rtlCol="0" anchor="ctr"/>
+          <a:lstStyle/>
+          <a:p>
+            <a:pPr algn="ctr"/>
+          </a:p>
+        </p:txBody>
+      </p:sp>
+      <p:sp>
+        <p:nvSpPr>
+          <p:cNvPr id="6" name="TextBox 5"/>
           <p:cNvSpPr txBox="1"/>
           <p:nvPr/>
         </p:nvSpPr>
         <p:spPr>
           <a:xfrm>
-            <a:off x="640080" y="1280160"/>
-            <a:ext cx="10515600" cy="5029200"/>
+            <a:off x="1828800" y="2286000"/>
+            <a:ext cx="8503920" cy="1371600"/>
           </a:xfrm>
           <a:prstGeom prst="rect">
             <a:avLst/>
@@ -7364,168 +7442,130 @@
           <a:noFill/>
         </p:spPr>
         <p:txBody>
-          <a:bodyPr wrap="square">
-            <a:spAutoFit/>
-          </a:bodyPr>
-          <a:lstStyle/>
-          <a:p>
-            <a:pPr>
-              <a:spcAft>
-                <a:spcPts val="800"/>
-              </a:spcAft>
-              <a:defRPr sz="2000">
-                <a:solidFill>
-                  <a:srgbClr val="333333"/>
-                </a:solidFill>
-                <a:latin typeface="Calibri"/>
-              </a:defRPr>
-            </a:pPr>
-            <a:r>
-              <a:t>El cliente presenta una VP (Verifiable Presentation) a la aplicacion</a:t>
-            </a:r>
-          </a:p>
-          <a:p>
-            <a:pPr>
-              <a:spcAft>
-                <a:spcPts val="800"/>
-              </a:spcAft>
-              <a:defRPr sz="2000">
-                <a:solidFill>
-                  <a:srgbClr val="333333"/>
-                </a:solidFill>
-                <a:latin typeface="Calibri"/>
-              </a:defRPr>
-            </a:pPr>
-            <a:r>
-              <a:t>La aplicacion verifica la VP contra la red de identidad (Alastria/EBSI)</a:t>
-            </a:r>
-          </a:p>
-          <a:p>
-            <a:pPr>
-              <a:spcAft>
-                <a:spcPts val="800"/>
-              </a:spcAft>
-              <a:defRPr sz="2000">
-                <a:solidFill>
-                  <a:srgbClr val="333333"/>
-                </a:solidFill>
-                <a:latin typeface="Calibri"/>
-              </a:defRPr>
-            </a:pPr>
-            <a:r>
-              <a:t>Si la VP es valida, la aplicacion invoca el chaincode en Fabric</a:t>
-            </a:r>
-          </a:p>
-          <a:p>
-            <a:pPr>
-              <a:spcAft>
-                <a:spcPts val="800"/>
-              </a:spcAft>
-              <a:defRPr sz="2000">
-                <a:solidFill>
-                  <a:srgbClr val="333333"/>
-                </a:solidFill>
-                <a:latin typeface="Calibri"/>
-              </a:defRPr>
-            </a:pPr>
-            <a:r>
-              <a:t>El chaincode puede registrar el DID del cliente como referencia</a:t>
-            </a:r>
-          </a:p>
-          <a:p>
-            <a:pPr>
-              <a:spcAft>
-                <a:spcPts val="800"/>
-              </a:spcAft>
-              <a:defRPr sz="2000">
-                <a:solidFill>
-                  <a:srgbClr val="333333"/>
-                </a:solidFill>
-                <a:latin typeface="Calibri"/>
-              </a:defRPr>
-            </a:pPr>
-            <a:r>
-              <a:t>Flujo:</a:t>
-            </a:r>
-          </a:p>
-          <a:p>
-            <a:pPr lvl="1">
-              <a:spcAft>
-                <a:spcPts val="400"/>
-              </a:spcAft>
-              <a:defRPr sz="1700">
-                <a:solidFill>
-                  <a:srgbClr val="666666"/>
-                </a:solidFill>
-                <a:latin typeface="Calibri"/>
-              </a:defRPr>
-            </a:pPr>
-            <a:r>
-              <a:t>    1. Cliente -&gt; App: presenta VP con VC de KYC</a:t>
-            </a:r>
-          </a:p>
-          <a:p>
-            <a:pPr lvl="1">
-              <a:spcAft>
-                <a:spcPts val="400"/>
-              </a:spcAft>
-              <a:defRPr sz="1700">
-                <a:solidFill>
-                  <a:srgbClr val="666666"/>
-                </a:solidFill>
-                <a:latin typeface="Calibri"/>
-              </a:defRPr>
-            </a:pPr>
-            <a:r>
-              <a:t>    2. App -&gt; Alastria: ¿es valida esta VP? ¿el issuer es de confianza?</a:t>
-            </a:r>
-          </a:p>
-          <a:p>
-            <a:pPr lvl="1">
-              <a:spcAft>
-                <a:spcPts val="400"/>
-              </a:spcAft>
-              <a:defRPr sz="1700">
-                <a:solidFill>
-                  <a:srgbClr val="666666"/>
-                </a:solidFill>
-                <a:latin typeface="Calibri"/>
-              </a:defRPr>
-            </a:pPr>
-            <a:r>
-              <a:t>    3. Alastria -&gt; App: si, valida y no revocada</a:t>
-            </a:r>
-          </a:p>
-          <a:p>
-            <a:pPr lvl="1">
-              <a:spcAft>
-                <a:spcPts val="400"/>
-              </a:spcAft>
-              <a:defRPr sz="1700">
-                <a:solidFill>
-                  <a:srgbClr val="666666"/>
-                </a:solidFill>
-                <a:latin typeface="Calibri"/>
-              </a:defRPr>
-            </a:pPr>
-            <a:r>
-              <a:t>    4. App -&gt; Fabric: RegisterClient(did:ala:quor:0x123..., 'Javier Garcia')</a:t>
-            </a:r>
-          </a:p>
-          <a:p>
-            <a:pPr lvl="1">
-              <a:spcAft>
-                <a:spcPts val="400"/>
-              </a:spcAft>
-              <a:defRPr sz="1700">
-                <a:solidFill>
-                  <a:srgbClr val="666666"/>
-                </a:solidFill>
-                <a:latin typeface="Calibri"/>
-              </a:defRPr>
-            </a:pPr>
-            <a:r>
-              <a:t>    5. Fabric: registra al cliente y puede operar en el canal</a:t>
+          <a:bodyPr wrap="square"/>
+          <a:lstStyle/>
+          <a:p>
+            <a:pPr algn="ctr">
+              <a:defRPr sz="2400" b="0">
+                <a:solidFill>
+                  <a:srgbClr val="999999"/>
+                </a:solidFill>
+                <a:latin typeface="Calibri"/>
+              </a:defRPr>
+            </a:pPr>
+            <a:r>
+              <a:t>[Diagrama: Red Alastria (identidad, DIDs, VCs) conectada con Red Fabric (canales, chaincodes, ledger)]</a:t>
+            </a:r>
+          </a:p>
+        </p:txBody>
+      </p:sp>
+      <p:sp>
+        <p:nvSpPr>
+          <p:cNvPr id="7" name="Rectangle 6"/>
+          <p:cNvSpPr/>
+          <p:nvPr/>
+        </p:nvSpPr>
+        <p:spPr>
+          <a:xfrm>
+            <a:off x="1371600" y="3840480"/>
+            <a:ext cx="9418320" cy="320040"/>
+          </a:xfrm>
+          <a:prstGeom prst="rect">
+            <a:avLst/>
+          </a:prstGeom>
+          <a:solidFill>
+            <a:srgbClr val="7C3AED"/>
+          </a:solidFill>
+          <a:ln>
+            <a:noFill/>
+          </a:ln>
+        </p:spPr>
+        <p:style>
+          <a:lnRef idx="1">
+            <a:schemeClr val="accent1"/>
+          </a:lnRef>
+          <a:fillRef idx="3">
+            <a:schemeClr val="accent1"/>
+          </a:fillRef>
+          <a:effectRef idx="2">
+            <a:schemeClr val="accent1"/>
+          </a:effectRef>
+          <a:fontRef idx="minor">
+            <a:schemeClr val="lt1"/>
+          </a:fontRef>
+        </p:style>
+        <p:txBody>
+          <a:bodyPr rtlCol="0" anchor="ctr"/>
+          <a:lstStyle/>
+          <a:p>
+            <a:pPr algn="ctr"/>
+          </a:p>
+        </p:txBody>
+      </p:sp>
+      <p:sp>
+        <p:nvSpPr>
+          <p:cNvPr id="8" name="TextBox 7"/>
+          <p:cNvSpPr txBox="1"/>
+          <p:nvPr/>
+        </p:nvSpPr>
+        <p:spPr>
+          <a:xfrm>
+            <a:off x="1371600" y="3840480"/>
+            <a:ext cx="9418320" cy="320040"/>
+          </a:xfrm>
+          <a:prstGeom prst="rect">
+            <a:avLst/>
+          </a:prstGeom>
+          <a:noFill/>
+        </p:spPr>
+        <p:txBody>
+          <a:bodyPr wrap="square"/>
+          <a:lstStyle/>
+          <a:p>
+            <a:pPr algn="ctr">
+              <a:defRPr sz="1300" b="1">
+                <a:solidFill>
+                  <a:srgbClr val="FFFFFF"/>
+                </a:solidFill>
+                <a:latin typeface="Calibri"/>
+              </a:defRPr>
+            </a:pPr>
+            <a:r>
+              <a:t>Prompt para IA generativa:</a:t>
+            </a:r>
+          </a:p>
+        </p:txBody>
+      </p:sp>
+      <p:sp>
+        <p:nvSpPr>
+          <p:cNvPr id="9" name="TextBox 8"/>
+          <p:cNvSpPr txBox="1"/>
+          <p:nvPr/>
+        </p:nvSpPr>
+        <p:spPr>
+          <a:xfrm>
+            <a:off x="1645920" y="4297680"/>
+            <a:ext cx="8869680" cy="914400"/>
+          </a:xfrm>
+          <a:prstGeom prst="rect">
+            <a:avLst/>
+          </a:prstGeom>
+          <a:noFill/>
+        </p:spPr>
+        <p:txBody>
+          <a:bodyPr wrap="square"/>
+          <a:lstStyle/>
+          <a:p>
+            <a:pPr algn="l">
+              <a:defRPr sz="1400" b="0">
+                <a:solidFill>
+                  <a:srgbClr val="7C3AED"/>
+                </a:solidFill>
+                <a:latin typeface="Consolas"/>
+              </a:defRPr>
+            </a:pPr>
+            <a:r>
+              <a:t>Split architecture diagram: left side shows Alastria network with DID Registry and VC issuance (blue tones), right side shows Hyperledger Fabric network with channels, chaincodes, and private ledger (green tones). Bridge in the middle showing identity verification flow. Clean corporate style.</a:t>
             </a:r>
           </a:p>
         </p:txBody>
@@ -7620,7 +7660,7 @@
               </a:defRPr>
             </a:pPr>
             <a:r>
-              <a:t>DID/VC vs X.509/MSP en Fabric</a:t>
+              <a:t>Patron: verificar identidad externa en Fabric</a:t>
             </a:r>
           </a:p>
         </p:txBody>
@@ -7702,7 +7742,7 @@
               </a:defRPr>
             </a:pPr>
             <a:r>
-              <a:t>Fabric usa nativamente certificados X.509 emitidos por una Fabric CA</a:t>
+              <a:t>El cliente presenta una VP (Verifiable Presentation) a la aplicacion</a:t>
             </a:r>
           </a:p>
           <a:p>
@@ -7718,7 +7758,7 @@
               </a:defRPr>
             </a:pPr>
             <a:r>
-              <a:t>Los DIDs/VCs son un modelo diferente y complementario</a:t>
+              <a:t>La aplicacion verifica la VP contra la red de identidad (Alastria/EBSI)</a:t>
             </a:r>
           </a:p>
           <a:p>
@@ -7734,7 +7774,39 @@
               </a:defRPr>
             </a:pPr>
             <a:r>
-              <a:t>Comparativa:</a:t>
+              <a:t>Si la VP es valida, la aplicacion invoca el chaincode en Fabric</a:t>
+            </a:r>
+          </a:p>
+          <a:p>
+            <a:pPr>
+              <a:spcAft>
+                <a:spcPts val="800"/>
+              </a:spcAft>
+              <a:defRPr sz="2000">
+                <a:solidFill>
+                  <a:srgbClr val="333333"/>
+                </a:solidFill>
+                <a:latin typeface="Calibri"/>
+              </a:defRPr>
+            </a:pPr>
+            <a:r>
+              <a:t>El chaincode puede registrar el DID del cliente como referencia</a:t>
+            </a:r>
+          </a:p>
+          <a:p>
+            <a:pPr>
+              <a:spcAft>
+                <a:spcPts val="800"/>
+              </a:spcAft>
+              <a:defRPr sz="2000">
+                <a:solidFill>
+                  <a:srgbClr val="333333"/>
+                </a:solidFill>
+                <a:latin typeface="Calibri"/>
+              </a:defRPr>
+            </a:pPr>
+            <a:r>
+              <a:t>Flujo:</a:t>
             </a:r>
           </a:p>
           <a:p>
@@ -7750,7 +7822,7 @@
               </a:defRPr>
             </a:pPr>
             <a:r>
-              <a:t>    X.509 (Fabric nativo): emitido por la CA de cada org, valido solo dentro de la red Fabric</a:t>
+              <a:t>    1. Cliente -&gt; App: presenta VP con VC de KYC</a:t>
             </a:r>
           </a:p>
           <a:p>
@@ -7766,7 +7838,7 @@
               </a:defRPr>
             </a:pPr>
             <a:r>
-              <a:t>    DID (Alastria/EBSI): emitido por el propio sujeto, verificable en cualquier red</a:t>
+              <a:t>    2. App -&gt; Alastria: ¿es valida esta VP? ¿el issuer es de confianza?</a:t>
             </a:r>
           </a:p>
           <a:p>
@@ -7782,7 +7854,7 @@
               </a:defRPr>
             </a:pPr>
             <a:r>
-              <a:t>    X.509: identifica peers, orderers, admins (infraestructura)</a:t>
+              <a:t>    3. Alastria -&gt; App: si, valida y no revocada</a:t>
             </a:r>
           </a:p>
           <a:p>
@@ -7798,7 +7870,7 @@
               </a:defRPr>
             </a:pPr>
             <a:r>
-              <a:t>    DID/VC: identifica personas, empresas, credenciales (capa de negocio)</a:t>
+              <a:t>    4. App -&gt; Fabric: RegisterClient(did:ala:quor:0x123..., 'Javier Garcia')</a:t>
             </a:r>
           </a:p>
           <a:p>
@@ -7814,7 +7886,7 @@
               </a:defRPr>
             </a:pPr>
             <a:r>
-              <a:t>    No se reemplazan: X.509 para la infraestructura Fabric, DID/VC para los usuarios finales</a:t>
+              <a:t>    5. Fabric: registra al cliente y puede operar en el canal</a:t>
             </a:r>
           </a:p>
         </p:txBody>
@@ -7828,6 +7900,295 @@
 </file>
 
 <file path=ppt/slides/slide25.xml><?xml version="1.0" encoding="utf-8"?>
+<p:sld xmlns:a="http://schemas.openxmlformats.org/drawingml/2006/main" xmlns:p="http://schemas.openxmlformats.org/presentationml/2006/main" xmlns:r="http://schemas.openxmlformats.org/officeDocument/2006/relationships">
+  <p:cSld>
+    <p:spTree>
+      <p:nvGrpSpPr>
+        <p:cNvPr id="1" name=""/>
+        <p:cNvGrpSpPr/>
+        <p:nvPr/>
+      </p:nvGrpSpPr>
+      <p:grpSpPr/>
+      <p:sp>
+        <p:nvSpPr>
+          <p:cNvPr id="2" name="Rectangle 1"/>
+          <p:cNvSpPr/>
+          <p:nvPr/>
+        </p:nvSpPr>
+        <p:spPr>
+          <a:xfrm>
+            <a:off x="0" y="0"/>
+            <a:ext cx="12188952" cy="73152"/>
+          </a:xfrm>
+          <a:prstGeom prst="rect">
+            <a:avLst/>
+          </a:prstGeom>
+          <a:solidFill>
+            <a:srgbClr val="22627E"/>
+          </a:solidFill>
+          <a:ln>
+            <a:noFill/>
+          </a:ln>
+        </p:spPr>
+        <p:style>
+          <a:lnRef idx="1">
+            <a:schemeClr val="accent1"/>
+          </a:lnRef>
+          <a:fillRef idx="3">
+            <a:schemeClr val="accent1"/>
+          </a:fillRef>
+          <a:effectRef idx="2">
+            <a:schemeClr val="accent1"/>
+          </a:effectRef>
+          <a:fontRef idx="minor">
+            <a:schemeClr val="lt1"/>
+          </a:fontRef>
+        </p:style>
+        <p:txBody>
+          <a:bodyPr rtlCol="0" anchor="ctr"/>
+          <a:lstStyle/>
+          <a:p>
+            <a:pPr algn="ctr"/>
+          </a:p>
+        </p:txBody>
+      </p:sp>
+      <p:sp>
+        <p:nvSpPr>
+          <p:cNvPr id="3" name="TextBox 2"/>
+          <p:cNvSpPr txBox="1"/>
+          <p:nvPr/>
+        </p:nvSpPr>
+        <p:spPr>
+          <a:xfrm>
+            <a:off x="457200" y="274320"/>
+            <a:ext cx="10972800" cy="731520"/>
+          </a:xfrm>
+          <a:prstGeom prst="rect">
+            <a:avLst/>
+          </a:prstGeom>
+          <a:noFill/>
+        </p:spPr>
+        <p:txBody>
+          <a:bodyPr wrap="square"/>
+          <a:lstStyle/>
+          <a:p>
+            <a:pPr algn="l">
+              <a:defRPr sz="3200" b="1">
+                <a:solidFill>
+                  <a:srgbClr val="22627E"/>
+                </a:solidFill>
+                <a:latin typeface="Calibri"/>
+              </a:defRPr>
+            </a:pPr>
+            <a:r>
+              <a:t>DID/VC vs X.509/MSP en Fabric</a:t>
+            </a:r>
+          </a:p>
+        </p:txBody>
+      </p:sp>
+      <p:sp>
+        <p:nvSpPr>
+          <p:cNvPr id="4" name="Rectangle 3"/>
+          <p:cNvSpPr/>
+          <p:nvPr/>
+        </p:nvSpPr>
+        <p:spPr>
+          <a:xfrm>
+            <a:off x="457200" y="1051560"/>
+            <a:ext cx="10972800" cy="27432"/>
+          </a:xfrm>
+          <a:prstGeom prst="rect">
+            <a:avLst/>
+          </a:prstGeom>
+          <a:solidFill>
+            <a:srgbClr val="22627E"/>
+          </a:solidFill>
+          <a:ln>
+            <a:noFill/>
+          </a:ln>
+        </p:spPr>
+        <p:style>
+          <a:lnRef idx="1">
+            <a:schemeClr val="accent1"/>
+          </a:lnRef>
+          <a:fillRef idx="3">
+            <a:schemeClr val="accent1"/>
+          </a:fillRef>
+          <a:effectRef idx="2">
+            <a:schemeClr val="accent1"/>
+          </a:effectRef>
+          <a:fontRef idx="minor">
+            <a:schemeClr val="lt1"/>
+          </a:fontRef>
+        </p:style>
+        <p:txBody>
+          <a:bodyPr rtlCol="0" anchor="ctr"/>
+          <a:lstStyle/>
+          <a:p>
+            <a:pPr algn="ctr"/>
+          </a:p>
+        </p:txBody>
+      </p:sp>
+      <p:sp>
+        <p:nvSpPr>
+          <p:cNvPr id="5" name="TextBox 4"/>
+          <p:cNvSpPr txBox="1"/>
+          <p:nvPr/>
+        </p:nvSpPr>
+        <p:spPr>
+          <a:xfrm>
+            <a:off x="640080" y="1280160"/>
+            <a:ext cx="10515600" cy="5029200"/>
+          </a:xfrm>
+          <a:prstGeom prst="rect">
+            <a:avLst/>
+          </a:prstGeom>
+          <a:noFill/>
+        </p:spPr>
+        <p:txBody>
+          <a:bodyPr wrap="square">
+            <a:spAutoFit/>
+          </a:bodyPr>
+          <a:lstStyle/>
+          <a:p>
+            <a:pPr>
+              <a:spcAft>
+                <a:spcPts val="800"/>
+              </a:spcAft>
+              <a:defRPr sz="2000">
+                <a:solidFill>
+                  <a:srgbClr val="333333"/>
+                </a:solidFill>
+                <a:latin typeface="Calibri"/>
+              </a:defRPr>
+            </a:pPr>
+            <a:r>
+              <a:t>Fabric usa nativamente certificados X.509 emitidos por una Fabric CA</a:t>
+            </a:r>
+          </a:p>
+          <a:p>
+            <a:pPr>
+              <a:spcAft>
+                <a:spcPts val="800"/>
+              </a:spcAft>
+              <a:defRPr sz="2000">
+                <a:solidFill>
+                  <a:srgbClr val="333333"/>
+                </a:solidFill>
+                <a:latin typeface="Calibri"/>
+              </a:defRPr>
+            </a:pPr>
+            <a:r>
+              <a:t>Los DIDs/VCs son un modelo diferente y complementario</a:t>
+            </a:r>
+          </a:p>
+          <a:p>
+            <a:pPr>
+              <a:spcAft>
+                <a:spcPts val="800"/>
+              </a:spcAft>
+              <a:defRPr sz="2000">
+                <a:solidFill>
+                  <a:srgbClr val="333333"/>
+                </a:solidFill>
+                <a:latin typeface="Calibri"/>
+              </a:defRPr>
+            </a:pPr>
+            <a:r>
+              <a:t>Comparativa:</a:t>
+            </a:r>
+          </a:p>
+          <a:p>
+            <a:pPr lvl="1">
+              <a:spcAft>
+                <a:spcPts val="400"/>
+              </a:spcAft>
+              <a:defRPr sz="1700">
+                <a:solidFill>
+                  <a:srgbClr val="666666"/>
+                </a:solidFill>
+                <a:latin typeface="Calibri"/>
+              </a:defRPr>
+            </a:pPr>
+            <a:r>
+              <a:t>    X.509 (Fabric nativo): emitido por la CA de cada org, valido solo dentro de la red Fabric</a:t>
+            </a:r>
+          </a:p>
+          <a:p>
+            <a:pPr lvl="1">
+              <a:spcAft>
+                <a:spcPts val="400"/>
+              </a:spcAft>
+              <a:defRPr sz="1700">
+                <a:solidFill>
+                  <a:srgbClr val="666666"/>
+                </a:solidFill>
+                <a:latin typeface="Calibri"/>
+              </a:defRPr>
+            </a:pPr>
+            <a:r>
+              <a:t>    DID (Alastria/EBSI): emitido por el propio sujeto, verificable en cualquier red</a:t>
+            </a:r>
+          </a:p>
+          <a:p>
+            <a:pPr lvl="1">
+              <a:spcAft>
+                <a:spcPts val="400"/>
+              </a:spcAft>
+              <a:defRPr sz="1700">
+                <a:solidFill>
+                  <a:srgbClr val="666666"/>
+                </a:solidFill>
+                <a:latin typeface="Calibri"/>
+              </a:defRPr>
+            </a:pPr>
+            <a:r>
+              <a:t>    X.509: identifica peers, orderers, admins (infraestructura)</a:t>
+            </a:r>
+          </a:p>
+          <a:p>
+            <a:pPr lvl="1">
+              <a:spcAft>
+                <a:spcPts val="400"/>
+              </a:spcAft>
+              <a:defRPr sz="1700">
+                <a:solidFill>
+                  <a:srgbClr val="666666"/>
+                </a:solidFill>
+                <a:latin typeface="Calibri"/>
+              </a:defRPr>
+            </a:pPr>
+            <a:r>
+              <a:t>    DID/VC: identifica personas, empresas, credenciales (capa de negocio)</a:t>
+            </a:r>
+          </a:p>
+          <a:p>
+            <a:pPr lvl="1">
+              <a:spcAft>
+                <a:spcPts val="400"/>
+              </a:spcAft>
+              <a:defRPr sz="1700">
+                <a:solidFill>
+                  <a:srgbClr val="666666"/>
+                </a:solidFill>
+                <a:latin typeface="Calibri"/>
+              </a:defRPr>
+            </a:pPr>
+            <a:r>
+              <a:t>    No se reemplazan: X.509 para la infraestructura Fabric, DID/VC para los usuarios finales</a:t>
+            </a:r>
+          </a:p>
+        </p:txBody>
+      </p:sp>
+    </p:spTree>
+  </p:cSld>
+  <p:clrMapOvr>
+    <a:masterClrMapping/>
+  </p:clrMapOvr>
+</p:sld>
+</file>
+
+<file path=ppt/slides/slide26.xml><?xml version="1.0" encoding="utf-8"?>
 <p:sld xmlns:a="http://schemas.openxmlformats.org/drawingml/2006/main" xmlns:p="http://schemas.openxmlformats.org/presentationml/2006/main" xmlns:r="http://schemas.openxmlformats.org/officeDocument/2006/relationships">
   <p:cSld>
     <p:spTree>
@@ -8548,446 +8909,6 @@
 </p:sld>
 </file>
 
-<file path=ppt/slides/slide26.xml><?xml version="1.0" encoding="utf-8"?>
-<p:sld xmlns:a="http://schemas.openxmlformats.org/drawingml/2006/main" xmlns:p="http://schemas.openxmlformats.org/presentationml/2006/main" xmlns:r="http://schemas.openxmlformats.org/officeDocument/2006/relationships">
-  <p:cSld>
-    <p:spTree>
-      <p:nvGrpSpPr>
-        <p:cNvPr id="1" name=""/>
-        <p:cNvGrpSpPr/>
-        <p:nvPr/>
-      </p:nvGrpSpPr>
-      <p:grpSpPr/>
-      <p:sp>
-        <p:nvSpPr>
-          <p:cNvPr id="2" name="Rectangle 1"/>
-          <p:cNvSpPr/>
-          <p:nvPr/>
-        </p:nvSpPr>
-        <p:spPr>
-          <a:xfrm>
-            <a:off x="0" y="0"/>
-            <a:ext cx="12188952" cy="73152"/>
-          </a:xfrm>
-          <a:prstGeom prst="rect">
-            <a:avLst/>
-          </a:prstGeom>
-          <a:solidFill>
-            <a:srgbClr val="7C3AED"/>
-          </a:solidFill>
-          <a:ln>
-            <a:noFill/>
-          </a:ln>
-        </p:spPr>
-        <p:style>
-          <a:lnRef idx="1">
-            <a:schemeClr val="accent1"/>
-          </a:lnRef>
-          <a:fillRef idx="3">
-            <a:schemeClr val="accent1"/>
-          </a:fillRef>
-          <a:effectRef idx="2">
-            <a:schemeClr val="accent1"/>
-          </a:effectRef>
-          <a:fontRef idx="minor">
-            <a:schemeClr val="lt1"/>
-          </a:fontRef>
-        </p:style>
-        <p:txBody>
-          <a:bodyPr rtlCol="0" anchor="ctr"/>
-          <a:lstStyle/>
-          <a:p>
-            <a:pPr algn="ctr"/>
-          </a:p>
-        </p:txBody>
-      </p:sp>
-      <p:sp>
-        <p:nvSpPr>
-          <p:cNvPr id="3" name="Rectangle 2"/>
-          <p:cNvSpPr/>
-          <p:nvPr/>
-        </p:nvSpPr>
-        <p:spPr>
-          <a:xfrm>
-            <a:off x="457200" y="274320"/>
-            <a:ext cx="3200400" cy="457200"/>
-          </a:xfrm>
-          <a:prstGeom prst="rect">
-            <a:avLst/>
-          </a:prstGeom>
-          <a:solidFill>
-            <a:srgbClr val="7C3AED"/>
-          </a:solidFill>
-          <a:ln>
-            <a:noFill/>
-          </a:ln>
-        </p:spPr>
-        <p:style>
-          <a:lnRef idx="1">
-            <a:schemeClr val="accent1"/>
-          </a:lnRef>
-          <a:fillRef idx="3">
-            <a:schemeClr val="accent1"/>
-          </a:fillRef>
-          <a:effectRef idx="2">
-            <a:schemeClr val="accent1"/>
-          </a:effectRef>
-          <a:fontRef idx="minor">
-            <a:schemeClr val="lt1"/>
-          </a:fontRef>
-        </p:style>
-        <p:txBody>
-          <a:bodyPr rtlCol="0" anchor="ctr"/>
-          <a:lstStyle/>
-          <a:p>
-            <a:pPr algn="ctr"/>
-          </a:p>
-        </p:txBody>
-      </p:sp>
-      <p:sp>
-        <p:nvSpPr>
-          <p:cNvPr id="4" name="TextBox 3"/>
-          <p:cNvSpPr txBox="1"/>
-          <p:nvPr/>
-        </p:nvSpPr>
-        <p:spPr>
-          <a:xfrm>
-            <a:off x="457200" y="274320"/>
-            <a:ext cx="3200400" cy="457200"/>
-          </a:xfrm>
-          <a:prstGeom prst="rect">
-            <a:avLst/>
-          </a:prstGeom>
-          <a:noFill/>
-        </p:spPr>
-        <p:txBody>
-          <a:bodyPr wrap="square"/>
-          <a:lstStyle/>
-          <a:p>
-            <a:pPr algn="ctr">
-              <a:defRPr sz="1800" b="1">
-                <a:solidFill>
-                  <a:srgbClr val="FFFFFF"/>
-                </a:solidFill>
-                <a:latin typeface="Calibri"/>
-              </a:defRPr>
-            </a:pPr>
-            <a:r>
-              <a:t>CULTURA GENERAL</a:t>
-            </a:r>
-          </a:p>
-        </p:txBody>
-      </p:sp>
-      <p:sp>
-        <p:nvSpPr>
-          <p:cNvPr id="5" name="TextBox 4"/>
-          <p:cNvSpPr txBox="1"/>
-          <p:nvPr/>
-        </p:nvSpPr>
-        <p:spPr>
-          <a:xfrm>
-            <a:off x="3931920" y="228600"/>
-            <a:ext cx="7772400" cy="731520"/>
-          </a:xfrm>
-          <a:prstGeom prst="rect">
-            <a:avLst/>
-          </a:prstGeom>
-          <a:noFill/>
-        </p:spPr>
-        <p:txBody>
-          <a:bodyPr wrap="square"/>
-          <a:lstStyle/>
-          <a:p>
-            <a:pPr algn="l">
-              <a:defRPr sz="2800" b="1">
-                <a:solidFill>
-                  <a:srgbClr val="333333"/>
-                </a:solidFill>
-                <a:latin typeface="Calibri"/>
-              </a:defRPr>
-            </a:pPr>
-            <a:r>
-              <a:t>El DNI electronico espanol: una historia de adopcion fallida</a:t>
-            </a:r>
-          </a:p>
-        </p:txBody>
-      </p:sp>
-      <p:sp>
-        <p:nvSpPr>
-          <p:cNvPr id="6" name="Rectangle 5"/>
-          <p:cNvSpPr/>
-          <p:nvPr/>
-        </p:nvSpPr>
-        <p:spPr>
-          <a:xfrm>
-            <a:off x="457200" y="1051560"/>
-            <a:ext cx="10972800" cy="27432"/>
-          </a:xfrm>
-          <a:prstGeom prst="rect">
-            <a:avLst/>
-          </a:prstGeom>
-          <a:solidFill>
-            <a:srgbClr val="7C3AED"/>
-          </a:solidFill>
-          <a:ln>
-            <a:noFill/>
-          </a:ln>
-        </p:spPr>
-        <p:style>
-          <a:lnRef idx="1">
-            <a:schemeClr val="accent1"/>
-          </a:lnRef>
-          <a:fillRef idx="3">
-            <a:schemeClr val="accent1"/>
-          </a:fillRef>
-          <a:effectRef idx="2">
-            <a:schemeClr val="accent1"/>
-          </a:effectRef>
-          <a:fontRef idx="minor">
-            <a:schemeClr val="lt1"/>
-          </a:fontRef>
-        </p:style>
-        <p:txBody>
-          <a:bodyPr rtlCol="0" anchor="ctr"/>
-          <a:lstStyle/>
-          <a:p>
-            <a:pPr algn="ctr"/>
-          </a:p>
-        </p:txBody>
-      </p:sp>
-      <p:sp>
-        <p:nvSpPr>
-          <p:cNvPr id="7" name="TextBox 6"/>
-          <p:cNvSpPr txBox="1"/>
-          <p:nvPr/>
-        </p:nvSpPr>
-        <p:spPr>
-          <a:xfrm>
-            <a:off x="640080" y="1371600"/>
-            <a:ext cx="10515600" cy="5029200"/>
-          </a:xfrm>
-          <a:prstGeom prst="rect">
-            <a:avLst/>
-          </a:prstGeom>
-          <a:noFill/>
-        </p:spPr>
-        <p:txBody>
-          <a:bodyPr wrap="square">
-            <a:spAutoFit/>
-          </a:bodyPr>
-          <a:lstStyle/>
-          <a:p>
-            <a:pPr>
-              <a:spcAft>
-                <a:spcPts val="1000"/>
-              </a:spcAft>
-              <a:defRPr sz="2000">
-                <a:solidFill>
-                  <a:srgbClr val="333333"/>
-                </a:solidFill>
-                <a:latin typeface="Calibri"/>
-              </a:defRPr>
-            </a:pPr>
-            <a:r>
-              <a:t>Espana fue pionera en Europa con el DNI electronico (DNIe) en 2006.</a:t>
-            </a:r>
-          </a:p>
-          <a:p>
-            <a:pPr>
-              <a:spcAft>
-                <a:spcPts val="1000"/>
-              </a:spcAft>
-              <a:defRPr sz="2000">
-                <a:solidFill>
-                  <a:srgbClr val="333333"/>
-                </a:solidFill>
-                <a:latin typeface="Calibri"/>
-              </a:defRPr>
-            </a:pPr>
-            <a:r>
-              <a:t>Incluia un chip con certificado digital para firmar documentos y autenticarse online.</a:t>
-            </a:r>
-          </a:p>
-          <a:p>
-            <a:pPr>
-              <a:spcAft>
-                <a:spcPts val="1000"/>
-              </a:spcAft>
-              <a:defRPr sz="2000">
-                <a:solidFill>
-                  <a:srgbClr val="333333"/>
-                </a:solidFill>
-                <a:latin typeface="Calibri"/>
-              </a:defRPr>
-            </a:pPr>
-            <a:r>
-              <a:t>La idea era revolucionaria: cada ciudadano con identidad digital en el bolsillo.</a:t>
-            </a:r>
-          </a:p>
-          <a:p>
-            <a:pPr>
-              <a:spcAft>
-                <a:spcPts val="1000"/>
-              </a:spcAft>
-              <a:defRPr sz="2000">
-                <a:solidFill>
-                  <a:srgbClr val="333333"/>
-                </a:solidFill>
-                <a:latin typeface="Calibri"/>
-              </a:defRPr>
-            </a:pPr>
-          </a:p>
-          <a:p>
-            <a:pPr>
-              <a:spcAft>
-                <a:spcPts val="1000"/>
-              </a:spcAft>
-              <a:defRPr sz="2000">
-                <a:solidFill>
-                  <a:srgbClr val="333333"/>
-                </a:solidFill>
-                <a:latin typeface="Calibri"/>
-              </a:defRPr>
-            </a:pPr>
-            <a:r>
-              <a:t>¿Que paso?</a:t>
-            </a:r>
-          </a:p>
-          <a:p>
-            <a:pPr>
-              <a:spcAft>
-                <a:spcPts val="1000"/>
-              </a:spcAft>
-              <a:defRPr sz="2000">
-                <a:solidFill>
-                  <a:srgbClr val="333333"/>
-                </a:solidFill>
-                <a:latin typeface="Calibri"/>
-              </a:defRPr>
-            </a:pPr>
-            <a:r>
-              <a:t>  - Los lectores de tarjeta eran caros y dificiles de instalar</a:t>
-            </a:r>
-          </a:p>
-          <a:p>
-            <a:pPr>
-              <a:spcAft>
-                <a:spcPts val="1000"/>
-              </a:spcAft>
-              <a:defRPr sz="2000">
-                <a:solidFill>
-                  <a:srgbClr val="333333"/>
-                </a:solidFill>
-                <a:latin typeface="Calibri"/>
-              </a:defRPr>
-            </a:pPr>
-            <a:r>
-              <a:t>  - El software de firma era complejo y fallaba en muchos navegadores</a:t>
-            </a:r>
-          </a:p>
-          <a:p>
-            <a:pPr>
-              <a:spcAft>
-                <a:spcPts val="1000"/>
-              </a:spcAft>
-              <a:defRPr sz="2000">
-                <a:solidFill>
-                  <a:srgbClr val="333333"/>
-                </a:solidFill>
-                <a:latin typeface="Calibri"/>
-              </a:defRPr>
-            </a:pPr>
-            <a:r>
-              <a:t>  - La renovacion del certificado requeria ir a la comisaria</a:t>
-            </a:r>
-          </a:p>
-          <a:p>
-            <a:pPr>
-              <a:spcAft>
-                <a:spcPts val="1000"/>
-              </a:spcAft>
-              <a:defRPr sz="2000">
-                <a:solidFill>
-                  <a:srgbClr val="333333"/>
-                </a:solidFill>
-                <a:latin typeface="Calibri"/>
-              </a:defRPr>
-            </a:pPr>
-            <a:r>
-              <a:t>  - Pocos servicios publicos lo soportaban de forma fluida</a:t>
-            </a:r>
-          </a:p>
-          <a:p>
-            <a:pPr>
-              <a:spcAft>
-                <a:spcPts val="1000"/>
-              </a:spcAft>
-              <a:defRPr sz="2000">
-                <a:solidFill>
-                  <a:srgbClr val="333333"/>
-                </a:solidFill>
-                <a:latin typeface="Calibri"/>
-              </a:defRPr>
-            </a:pPr>
-            <a:r>
-              <a:t>  - La adopcion fue minima: menos del 5% de la poblacion lo uso alguna vez</a:t>
-            </a:r>
-          </a:p>
-          <a:p>
-            <a:pPr>
-              <a:spcAft>
-                <a:spcPts val="1000"/>
-              </a:spcAft>
-              <a:defRPr sz="2000">
-                <a:solidFill>
-                  <a:srgbClr val="333333"/>
-                </a:solidFill>
-                <a:latin typeface="Calibri"/>
-              </a:defRPr>
-            </a:pPr>
-          </a:p>
-          <a:p>
-            <a:pPr>
-              <a:spcAft>
-                <a:spcPts val="1000"/>
-              </a:spcAft>
-              <a:defRPr sz="2000">
-                <a:solidFill>
-                  <a:srgbClr val="333333"/>
-                </a:solidFill>
-                <a:latin typeface="Calibri"/>
-              </a:defRPr>
-            </a:pPr>
-            <a:r>
-              <a:t>Leccion: la tecnologia estaba lista, pero la UX no. Exactamente el mismo riesgo</a:t>
-            </a:r>
-          </a:p>
-          <a:p>
-            <a:pPr>
-              <a:spcAft>
-                <a:spcPts val="1000"/>
-              </a:spcAft>
-              <a:defRPr sz="2000">
-                <a:solidFill>
-                  <a:srgbClr val="333333"/>
-                </a:solidFill>
-                <a:latin typeface="Calibri"/>
-              </a:defRPr>
-            </a:pPr>
-            <a:r>
-              <a:t>que corre hoy la identidad descentralizada si no se resuelve la experiencia de usuario.</a:t>
-            </a:r>
-          </a:p>
-        </p:txBody>
-      </p:sp>
-    </p:spTree>
-  </p:cSld>
-  <p:clrMapOvr>
-    <a:masterClrMapping/>
-  </p:clrMapOvr>
-</p:sld>
-</file>
-
 <file path=ppt/slides/slide27.xml><?xml version="1.0" encoding="utf-8"?>
 <p:sld xmlns:a="http://schemas.openxmlformats.org/drawingml/2006/main" xmlns:p="http://schemas.openxmlformats.org/presentationml/2006/main" xmlns:r="http://schemas.openxmlformats.org/officeDocument/2006/relationships">
   <p:cSld>
@@ -9013,7 +8934,7 @@
             <a:avLst/>
           </a:prstGeom>
           <a:solidFill>
-            <a:srgbClr val="0D9448"/>
+            <a:srgbClr val="7C3AED"/>
           </a:solidFill>
           <a:ln>
             <a:noFill/>
@@ -9050,13 +8971,13 @@
         <p:spPr>
           <a:xfrm>
             <a:off x="457200" y="274320"/>
-            <a:ext cx="2286000" cy="457200"/>
+            <a:ext cx="3200400" cy="457200"/>
           </a:xfrm>
           <a:prstGeom prst="rect">
             <a:avLst/>
           </a:prstGeom>
           <a:solidFill>
-            <a:srgbClr val="0D9448"/>
+            <a:srgbClr val="7C3AED"/>
           </a:solidFill>
           <a:ln>
             <a:noFill/>
@@ -9093,7 +9014,7 @@
         <p:spPr>
           <a:xfrm>
             <a:off x="457200" y="274320"/>
-            <a:ext cx="2286000" cy="457200"/>
+            <a:ext cx="3200400" cy="457200"/>
           </a:xfrm>
           <a:prstGeom prst="rect">
             <a:avLst/>
@@ -9113,7 +9034,7 @@
               </a:defRPr>
             </a:pPr>
             <a:r>
-              <a:t>PRACTICA</a:t>
+              <a:t>CULTURA GENERAL</a:t>
             </a:r>
           </a:p>
         </p:txBody>
@@ -9126,8 +9047,8 @@
         </p:nvSpPr>
         <p:spPr>
           <a:xfrm>
-            <a:off x="3017520" y="274320"/>
-            <a:ext cx="8686800" cy="731520"/>
+            <a:off x="3931920" y="228600"/>
+            <a:ext cx="7772400" cy="731520"/>
           </a:xfrm>
           <a:prstGeom prst="rect">
             <a:avLst/>
@@ -9139,15 +9060,15 @@
           <a:lstStyle/>
           <a:p>
             <a:pPr algn="l">
-              <a:defRPr sz="3000" b="1">
-                <a:solidFill>
-                  <a:srgbClr val="333333"/>
-                </a:solidFill>
-                <a:latin typeface="Calibri"/>
-              </a:defRPr>
-            </a:pPr>
-            <a:r>
-              <a:t>Disenar una arquitectura hibrida</a:t>
+              <a:defRPr sz="2800" b="1">
+                <a:solidFill>
+                  <a:srgbClr val="333333"/>
+                </a:solidFill>
+                <a:latin typeface="Calibri"/>
+              </a:defRPr>
+            </a:pPr>
+            <a:r>
+              <a:t>El DNI electronico espanol: una historia de adopcion fallida</a:t>
             </a:r>
           </a:p>
         </p:txBody>
@@ -9167,7 +9088,7 @@
             <a:avLst/>
           </a:prstGeom>
           <a:solidFill>
-            <a:srgbClr val="0D9448"/>
+            <a:srgbClr val="7C3AED"/>
           </a:solidFill>
           <a:ln>
             <a:noFill/>
@@ -9229,7 +9150,7 @@
               </a:defRPr>
             </a:pPr>
             <a:r>
-              <a:t>Objetivo: disenar la arquitectura de identidad para un caso real</a:t>
+              <a:t>Espana fue pionera en Europa con el DNI electronico (DNIe) en 2006.</a:t>
             </a:r>
           </a:p>
           <a:p>
@@ -9244,6 +9165,9 @@
                 <a:latin typeface="Calibri"/>
               </a:defRPr>
             </a:pPr>
+            <a:r>
+              <a:t>Incluia un chip con certificado digital para firmar documentos y autenticarse online.</a:t>
+            </a:r>
           </a:p>
           <a:p>
             <a:pPr>
@@ -9258,7 +9182,7 @@
               </a:defRPr>
             </a:pPr>
             <a:r>
-              <a:t>Escenario: Un consorcio de 3 hospitales quiere compartir historiales medicos.</a:t>
+              <a:t>La idea era revolucionaria: cada ciudadano con identidad digital en el bolsillo.</a:t>
             </a:r>
           </a:p>
           <a:p>
@@ -9273,9 +9197,6 @@
                 <a:latin typeface="Calibri"/>
               </a:defRPr>
             </a:pPr>
-            <a:r>
-              <a:t>Los pacientes deben controlar quien accede a sus datos.</a:t>
-            </a:r>
           </a:p>
           <a:p>
             <a:pPr>
@@ -9290,7 +9211,7 @@
               </a:defRPr>
             </a:pPr>
             <a:r>
-              <a:t>Los medicos necesitan credenciales verificables de su colegio profesional.</a:t>
+              <a:t>¿Que paso?</a:t>
             </a:r>
           </a:p>
           <a:p>
@@ -9305,6 +9226,9 @@
                 <a:latin typeface="Calibri"/>
               </a:defRPr>
             </a:pPr>
+            <a:r>
+              <a:t>  - Los lectores de tarjeta eran caros y dificiles de instalar</a:t>
+            </a:r>
           </a:p>
           <a:p>
             <a:pPr>
@@ -9319,7 +9243,7 @@
               </a:defRPr>
             </a:pPr>
             <a:r>
-              <a:t>Grupos de 3-4 personas. Decidir:</a:t>
+              <a:t>  - El software de firma era complejo y fallaba en muchos navegadores</a:t>
             </a:r>
           </a:p>
           <a:p>
@@ -9335,7 +9259,7 @@
               </a:defRPr>
             </a:pPr>
             <a:r>
-              <a:t>  1. ¿Que red usariais para identidad? (Alastria, EBSI, Fabric CA, otra)</a:t>
+              <a:t>  - La renovacion del certificado requeria ir a la comisaria</a:t>
             </a:r>
           </a:p>
           <a:p>
@@ -9351,7 +9275,7 @@
               </a:defRPr>
             </a:pPr>
             <a:r>
-              <a:t>  2. ¿Que red para la logica de negocio? (Fabric, Besu, otra)</a:t>
+              <a:t>  - Pocos servicios publicos lo soportaban de forma fluida</a:t>
             </a:r>
           </a:p>
           <a:p>
@@ -9367,7 +9291,7 @@
               </a:defRPr>
             </a:pPr>
             <a:r>
-              <a:t>  3. ¿Que credenciales necesitan los pacientes? ¿Y los medicos?</a:t>
+              <a:t>  - La adopcion fue minima: menos del 5% de la poblacion lo uso alguna vez</a:t>
             </a:r>
           </a:p>
           <a:p>
@@ -9382,9 +9306,6 @@
                 <a:latin typeface="Calibri"/>
               </a:defRPr>
             </a:pPr>
-            <a:r>
-              <a:t>  4. ¿Como verificaria el Hospital B una credencial emitida por el Hospital A?</a:t>
-            </a:r>
           </a:p>
           <a:p>
             <a:pPr>
@@ -9399,7 +9320,7 @@
               </a:defRPr>
             </a:pPr>
             <a:r>
-              <a:t>  5. ¿Donde se almacenan los datos medicos? (on-chain, off-chain, IPFS...)</a:t>
+              <a:t>Leccion: la tecnologia estaba lista, pero la UX no. Exactamente el mismo riesgo</a:t>
             </a:r>
           </a:p>
           <a:p>
@@ -9414,21 +9335,8 @@
                 <a:latin typeface="Calibri"/>
               </a:defRPr>
             </a:pPr>
-          </a:p>
-          <a:p>
-            <a:pPr>
-              <a:spcAft>
-                <a:spcPts val="1000"/>
-              </a:spcAft>
-              <a:defRPr sz="2000">
-                <a:solidFill>
-                  <a:srgbClr val="333333"/>
-                </a:solidFill>
-                <a:latin typeface="Calibri"/>
-              </a:defRPr>
-            </a:pPr>
-            <a:r>
-              <a:t>Tiempo: 25 minutos. Presentar diagrama + justificacion.</a:t>
+            <a:r>
+              <a:t>que corre hoy la identidad descentralizada si no se resuelve la experiencia de usuario.</a:t>
             </a:r>
           </a:p>
         </p:txBody>
@@ -9466,7 +9374,7 @@
             <a:avLst/>
           </a:prstGeom>
           <a:solidFill>
-            <a:srgbClr val="EC0000"/>
+            <a:srgbClr val="0D9448"/>
           </a:solidFill>
           <a:ln>
             <a:noFill/>
@@ -9503,13 +9411,13 @@
         <p:spPr>
           <a:xfrm>
             <a:off x="457200" y="274320"/>
-            <a:ext cx="1645920" cy="457200"/>
+            <a:ext cx="2286000" cy="457200"/>
           </a:xfrm>
           <a:prstGeom prst="rect">
             <a:avLst/>
           </a:prstGeom>
           <a:solidFill>
-            <a:srgbClr val="EC0000"/>
+            <a:srgbClr val="0D9448"/>
           </a:solidFill>
           <a:ln>
             <a:noFill/>
@@ -9546,7 +9454,7 @@
         <p:spPr>
           <a:xfrm>
             <a:off x="457200" y="274320"/>
-            <a:ext cx="1645920" cy="457200"/>
+            <a:ext cx="2286000" cy="457200"/>
           </a:xfrm>
           <a:prstGeom prst="rect">
             <a:avLst/>
@@ -9566,7 +9474,7 @@
               </a:defRPr>
             </a:pPr>
             <a:r>
-              <a:t>DEBATE</a:t>
+              <a:t>PRACTICA</a:t>
             </a:r>
           </a:p>
         </p:txBody>
@@ -9579,8 +9487,8 @@
         </p:nvSpPr>
         <p:spPr>
           <a:xfrm>
-            <a:off x="2377440" y="274320"/>
-            <a:ext cx="9144000" cy="731520"/>
+            <a:off x="3017520" y="274320"/>
+            <a:ext cx="8686800" cy="731520"/>
           </a:xfrm>
           <a:prstGeom prst="rect">
             <a:avLst/>
@@ -9600,7 +9508,7 @@
               </a:defRPr>
             </a:pPr>
             <a:r>
-              <a:t>Cierre del modulo de identidad</a:t>
+              <a:t>Disenar una arquitectura hibrida</a:t>
             </a:r>
           </a:p>
         </p:txBody>
@@ -9620,7 +9528,7 @@
             <a:avLst/>
           </a:prstGeom>
           <a:solidFill>
-            <a:srgbClr val="EC0000"/>
+            <a:srgbClr val="0D9448"/>
           </a:solidFill>
           <a:ln>
             <a:noFill/>
@@ -9672,81 +9580,216 @@
           <a:p>
             <a:pPr>
               <a:spcAft>
-                <a:spcPts val="1600"/>
-              </a:spcAft>
-              <a:defRPr sz="2200">
-                <a:solidFill>
-                  <a:srgbClr val="333333"/>
-                </a:solidFill>
-                <a:latin typeface="Calibri"/>
-              </a:defRPr>
-            </a:pPr>
-            <a:r>
-              <a:t>1. ¿Alastria, EBSI o una solucion propia? ¿Que elegiriais para vuestra empresa y por que?</a:t>
-            </a:r>
-          </a:p>
-          <a:p>
-            <a:pPr>
-              <a:spcAft>
-                <a:spcPts val="1600"/>
-              </a:spcAft>
-              <a:defRPr sz="2200">
-                <a:solidFill>
-                  <a:srgbClr val="333333"/>
-                </a:solidFill>
-                <a:latin typeface="Calibri"/>
-              </a:defRPr>
-            </a:pPr>
-            <a:r>
-              <a:t>2. ¿Tiene sentido que la identidad sea autosoberana si el Estado sigue emitiendo los documentos oficiales?</a:t>
-            </a:r>
-          </a:p>
-          <a:p>
-            <a:pPr>
-              <a:spcAft>
-                <a:spcPts val="1600"/>
-              </a:spcAft>
-              <a:defRPr sz="2200">
-                <a:solidFill>
-                  <a:srgbClr val="333333"/>
-                </a:solidFill>
-                <a:latin typeface="Calibri"/>
-              </a:defRPr>
-            </a:pPr>
-            <a:r>
-              <a:t>3. ¿Cuando usariais X.509 de Fabric y cuando DIDs/VCs? ¿Pueden convivir?</a:t>
-            </a:r>
-          </a:p>
-          <a:p>
-            <a:pPr>
-              <a:spcAft>
-                <a:spcPts val="1600"/>
-              </a:spcAft>
-              <a:defRPr sz="2200">
-                <a:solidFill>
-                  <a:srgbClr val="333333"/>
-                </a:solidFill>
-                <a:latin typeface="Calibri"/>
-              </a:defRPr>
-            </a:pPr>
-            <a:r>
-              <a:t>4. ¿Cual es el mayor obstaculo para la adopcion de la identidad descentralizada?</a:t>
-            </a:r>
-          </a:p>
-          <a:p>
-            <a:pPr>
-              <a:spcAft>
-                <a:spcPts val="1600"/>
-              </a:spcAft>
-              <a:defRPr sz="2200">
-                <a:solidFill>
-                  <a:srgbClr val="333333"/>
-                </a:solidFill>
-                <a:latin typeface="Calibri"/>
-              </a:defRPr>
-            </a:pPr>
-            <a:r>
-              <a:t>5. ¿Creeis que en 5 anos tendremos todos un wallet de identidad en el movil?</a:t>
+                <a:spcPts val="1000"/>
+              </a:spcAft>
+              <a:defRPr sz="2000">
+                <a:solidFill>
+                  <a:srgbClr val="333333"/>
+                </a:solidFill>
+                <a:latin typeface="Calibri"/>
+              </a:defRPr>
+            </a:pPr>
+            <a:r>
+              <a:t>Objetivo: disenar la arquitectura de identidad para un caso real</a:t>
+            </a:r>
+          </a:p>
+          <a:p>
+            <a:pPr>
+              <a:spcAft>
+                <a:spcPts val="1000"/>
+              </a:spcAft>
+              <a:defRPr sz="2000">
+                <a:solidFill>
+                  <a:srgbClr val="333333"/>
+                </a:solidFill>
+                <a:latin typeface="Calibri"/>
+              </a:defRPr>
+            </a:pPr>
+          </a:p>
+          <a:p>
+            <a:pPr>
+              <a:spcAft>
+                <a:spcPts val="1000"/>
+              </a:spcAft>
+              <a:defRPr sz="2000">
+                <a:solidFill>
+                  <a:srgbClr val="333333"/>
+                </a:solidFill>
+                <a:latin typeface="Calibri"/>
+              </a:defRPr>
+            </a:pPr>
+            <a:r>
+              <a:t>Escenario: Un consorcio de 3 hospitales quiere compartir historiales medicos.</a:t>
+            </a:r>
+          </a:p>
+          <a:p>
+            <a:pPr>
+              <a:spcAft>
+                <a:spcPts val="1000"/>
+              </a:spcAft>
+              <a:defRPr sz="2000">
+                <a:solidFill>
+                  <a:srgbClr val="333333"/>
+                </a:solidFill>
+                <a:latin typeface="Calibri"/>
+              </a:defRPr>
+            </a:pPr>
+            <a:r>
+              <a:t>Los pacientes deben controlar quien accede a sus datos.</a:t>
+            </a:r>
+          </a:p>
+          <a:p>
+            <a:pPr>
+              <a:spcAft>
+                <a:spcPts val="1000"/>
+              </a:spcAft>
+              <a:defRPr sz="2000">
+                <a:solidFill>
+                  <a:srgbClr val="333333"/>
+                </a:solidFill>
+                <a:latin typeface="Calibri"/>
+              </a:defRPr>
+            </a:pPr>
+            <a:r>
+              <a:t>Los medicos necesitan credenciales verificables de su colegio profesional.</a:t>
+            </a:r>
+          </a:p>
+          <a:p>
+            <a:pPr>
+              <a:spcAft>
+                <a:spcPts val="1000"/>
+              </a:spcAft>
+              <a:defRPr sz="2000">
+                <a:solidFill>
+                  <a:srgbClr val="333333"/>
+                </a:solidFill>
+                <a:latin typeface="Calibri"/>
+              </a:defRPr>
+            </a:pPr>
+          </a:p>
+          <a:p>
+            <a:pPr>
+              <a:spcAft>
+                <a:spcPts val="1000"/>
+              </a:spcAft>
+              <a:defRPr sz="2000">
+                <a:solidFill>
+                  <a:srgbClr val="333333"/>
+                </a:solidFill>
+                <a:latin typeface="Calibri"/>
+              </a:defRPr>
+            </a:pPr>
+            <a:r>
+              <a:t>Grupos de 3-4 personas. Decidir:</a:t>
+            </a:r>
+          </a:p>
+          <a:p>
+            <a:pPr>
+              <a:spcAft>
+                <a:spcPts val="1000"/>
+              </a:spcAft>
+              <a:defRPr sz="2000">
+                <a:solidFill>
+                  <a:srgbClr val="333333"/>
+                </a:solidFill>
+                <a:latin typeface="Calibri"/>
+              </a:defRPr>
+            </a:pPr>
+            <a:r>
+              <a:t>  1. ¿Que red usariais para identidad? (Alastria, EBSI, Fabric CA, otra)</a:t>
+            </a:r>
+          </a:p>
+          <a:p>
+            <a:pPr>
+              <a:spcAft>
+                <a:spcPts val="1000"/>
+              </a:spcAft>
+              <a:defRPr sz="2000">
+                <a:solidFill>
+                  <a:srgbClr val="333333"/>
+                </a:solidFill>
+                <a:latin typeface="Calibri"/>
+              </a:defRPr>
+            </a:pPr>
+            <a:r>
+              <a:t>  2. ¿Que red para la logica de negocio? (Fabric, Besu, otra)</a:t>
+            </a:r>
+          </a:p>
+          <a:p>
+            <a:pPr>
+              <a:spcAft>
+                <a:spcPts val="1000"/>
+              </a:spcAft>
+              <a:defRPr sz="2000">
+                <a:solidFill>
+                  <a:srgbClr val="333333"/>
+                </a:solidFill>
+                <a:latin typeface="Calibri"/>
+              </a:defRPr>
+            </a:pPr>
+            <a:r>
+              <a:t>  3. ¿Que credenciales necesitan los pacientes? ¿Y los medicos?</a:t>
+            </a:r>
+          </a:p>
+          <a:p>
+            <a:pPr>
+              <a:spcAft>
+                <a:spcPts val="1000"/>
+              </a:spcAft>
+              <a:defRPr sz="2000">
+                <a:solidFill>
+                  <a:srgbClr val="333333"/>
+                </a:solidFill>
+                <a:latin typeface="Calibri"/>
+              </a:defRPr>
+            </a:pPr>
+            <a:r>
+              <a:t>  4. ¿Como verificaria el Hospital B una credencial emitida por el Hospital A?</a:t>
+            </a:r>
+          </a:p>
+          <a:p>
+            <a:pPr>
+              <a:spcAft>
+                <a:spcPts val="1000"/>
+              </a:spcAft>
+              <a:defRPr sz="2000">
+                <a:solidFill>
+                  <a:srgbClr val="333333"/>
+                </a:solidFill>
+                <a:latin typeface="Calibri"/>
+              </a:defRPr>
+            </a:pPr>
+            <a:r>
+              <a:t>  5. ¿Donde se almacenan los datos medicos? (on-chain, off-chain, IPFS...)</a:t>
+            </a:r>
+          </a:p>
+          <a:p>
+            <a:pPr>
+              <a:spcAft>
+                <a:spcPts val="1000"/>
+              </a:spcAft>
+              <a:defRPr sz="2000">
+                <a:solidFill>
+                  <a:srgbClr val="333333"/>
+                </a:solidFill>
+                <a:latin typeface="Calibri"/>
+              </a:defRPr>
+            </a:pPr>
+          </a:p>
+          <a:p>
+            <a:pPr>
+              <a:spcAft>
+                <a:spcPts val="1000"/>
+              </a:spcAft>
+              <a:defRPr sz="2000">
+                <a:solidFill>
+                  <a:srgbClr val="333333"/>
+                </a:solidFill>
+                <a:latin typeface="Calibri"/>
+              </a:defRPr>
+            </a:pPr>
+            <a:r>
+              <a:t>Tiempo: 25 minutos. Presentar diagrama + justificacion.</a:t>
             </a:r>
           </a:p>
         </p:txBody>
@@ -9778,13 +9821,13 @@
         <p:spPr>
           <a:xfrm>
             <a:off x="0" y="0"/>
-            <a:ext cx="12188952" cy="6858000"/>
+            <a:ext cx="12188952" cy="73152"/>
           </a:xfrm>
           <a:prstGeom prst="rect">
             <a:avLst/>
           </a:prstGeom>
           <a:solidFill>
-            <a:srgbClr val="22627E"/>
+            <a:srgbClr val="EC0000"/>
           </a:solidFill>
           <a:ln>
             <a:noFill/>
@@ -9814,54 +9857,20 @@
       </p:sp>
       <p:sp>
         <p:nvSpPr>
-          <p:cNvPr id="3" name="TextBox 2"/>
-          <p:cNvSpPr txBox="1"/>
+          <p:cNvPr id="3" name="Rectangle 2"/>
+          <p:cNvSpPr/>
           <p:nvPr/>
         </p:nvSpPr>
         <p:spPr>
           <a:xfrm>
             <a:off x="457200" y="274320"/>
-            <a:ext cx="10972800" cy="731520"/>
-          </a:xfrm>
-          <a:prstGeom prst="rect">
-            <a:avLst/>
-          </a:prstGeom>
-          <a:noFill/>
-        </p:spPr>
-        <p:txBody>
-          <a:bodyPr wrap="square"/>
-          <a:lstStyle/>
-          <a:p>
-            <a:pPr algn="l">
-              <a:defRPr sz="3600" b="1">
-                <a:solidFill>
-                  <a:srgbClr val="FFFFFF"/>
-                </a:solidFill>
-                <a:latin typeface="Calibri"/>
-              </a:defRPr>
-            </a:pPr>
-            <a:r>
-              <a:t>Repaso del modulo: Identidad Digital</a:t>
-            </a:r>
-          </a:p>
-        </p:txBody>
-      </p:sp>
-      <p:sp>
-        <p:nvSpPr>
-          <p:cNvPr id="4" name="Rectangle 3"/>
-          <p:cNvSpPr/>
-          <p:nvPr/>
-        </p:nvSpPr>
-        <p:spPr>
-          <a:xfrm>
-            <a:off x="457200" y="1051560"/>
-            <a:ext cx="10972800" cy="27432"/>
+            <a:ext cx="1645920" cy="457200"/>
           </a:xfrm>
           <a:prstGeom prst="rect">
             <a:avLst/>
           </a:prstGeom>
           <a:solidFill>
-            <a:srgbClr val="FFFFFF"/>
+            <a:srgbClr val="EC0000"/>
           </a:solidFill>
           <a:ln>
             <a:noFill/>
@@ -9891,7 +9900,118 @@
       </p:sp>
       <p:sp>
         <p:nvSpPr>
+          <p:cNvPr id="4" name="TextBox 3"/>
+          <p:cNvSpPr txBox="1"/>
+          <p:nvPr/>
+        </p:nvSpPr>
+        <p:spPr>
+          <a:xfrm>
+            <a:off x="457200" y="274320"/>
+            <a:ext cx="1645920" cy="457200"/>
+          </a:xfrm>
+          <a:prstGeom prst="rect">
+            <a:avLst/>
+          </a:prstGeom>
+          <a:noFill/>
+        </p:spPr>
+        <p:txBody>
+          <a:bodyPr wrap="square"/>
+          <a:lstStyle/>
+          <a:p>
+            <a:pPr algn="ctr">
+              <a:defRPr sz="1800" b="1">
+                <a:solidFill>
+                  <a:srgbClr val="FFFFFF"/>
+                </a:solidFill>
+                <a:latin typeface="Calibri"/>
+              </a:defRPr>
+            </a:pPr>
+            <a:r>
+              <a:t>DEBATE</a:t>
+            </a:r>
+          </a:p>
+        </p:txBody>
+      </p:sp>
+      <p:sp>
+        <p:nvSpPr>
           <p:cNvPr id="5" name="TextBox 4"/>
+          <p:cNvSpPr txBox="1"/>
+          <p:nvPr/>
+        </p:nvSpPr>
+        <p:spPr>
+          <a:xfrm>
+            <a:off x="2377440" y="274320"/>
+            <a:ext cx="9144000" cy="731520"/>
+          </a:xfrm>
+          <a:prstGeom prst="rect">
+            <a:avLst/>
+          </a:prstGeom>
+          <a:noFill/>
+        </p:spPr>
+        <p:txBody>
+          <a:bodyPr wrap="square"/>
+          <a:lstStyle/>
+          <a:p>
+            <a:pPr algn="l">
+              <a:defRPr sz="3000" b="1">
+                <a:solidFill>
+                  <a:srgbClr val="333333"/>
+                </a:solidFill>
+                <a:latin typeface="Calibri"/>
+              </a:defRPr>
+            </a:pPr>
+            <a:r>
+              <a:t>Cierre del modulo de identidad</a:t>
+            </a:r>
+          </a:p>
+        </p:txBody>
+      </p:sp>
+      <p:sp>
+        <p:nvSpPr>
+          <p:cNvPr id="6" name="Rectangle 5"/>
+          <p:cNvSpPr/>
+          <p:nvPr/>
+        </p:nvSpPr>
+        <p:spPr>
+          <a:xfrm>
+            <a:off x="457200" y="1051560"/>
+            <a:ext cx="10972800" cy="27432"/>
+          </a:xfrm>
+          <a:prstGeom prst="rect">
+            <a:avLst/>
+          </a:prstGeom>
+          <a:solidFill>
+            <a:srgbClr val="EC0000"/>
+          </a:solidFill>
+          <a:ln>
+            <a:noFill/>
+          </a:ln>
+        </p:spPr>
+        <p:style>
+          <a:lnRef idx="1">
+            <a:schemeClr val="accent1"/>
+          </a:lnRef>
+          <a:fillRef idx="3">
+            <a:schemeClr val="accent1"/>
+          </a:fillRef>
+          <a:effectRef idx="2">
+            <a:schemeClr val="accent1"/>
+          </a:effectRef>
+          <a:fontRef idx="minor">
+            <a:schemeClr val="lt1"/>
+          </a:fontRef>
+        </p:style>
+        <p:txBody>
+          <a:bodyPr rtlCol="0" anchor="ctr"/>
+          <a:lstStyle/>
+          <a:p>
+            <a:pPr algn="ctr"/>
+          </a:p>
+        </p:txBody>
+      </p:sp>
+      <p:sp>
+        <p:nvSpPr>
+          <p:cNvPr id="7" name="TextBox 6"/>
           <p:cNvSpPr txBox="1"/>
           <p:nvPr/>
         </p:nvSpPr>
@@ -9913,129 +10033,81 @@
           <a:p>
             <a:pPr>
               <a:spcAft>
-                <a:spcPts val="1000"/>
-              </a:spcAft>
-              <a:defRPr sz="2000">
-                <a:solidFill>
-                  <a:srgbClr val="FFFFFF"/>
-                </a:solidFill>
-                <a:latin typeface="Calibri"/>
-              </a:defRPr>
-            </a:pPr>
-            <a:r>
-              <a:t>1. ¿Que es EBSI y que relacion tiene con eIDAS 2?</a:t>
-            </a:r>
-          </a:p>
-          <a:p>
-            <a:pPr>
-              <a:spcAft>
-                <a:spcPts val="1000"/>
-              </a:spcAft>
-              <a:defRPr sz="2000">
-                <a:solidFill>
-                  <a:srgbClr val="FFFFFF"/>
-                </a:solidFill>
-                <a:latin typeface="Calibri"/>
-              </a:defRPr>
-            </a:pPr>
-            <a:r>
-              <a:t>2. ¿Que es Alastria y que redes opera?</a:t>
-            </a:r>
-          </a:p>
-          <a:p>
-            <a:pPr>
-              <a:spcAft>
-                <a:spcPts val="1000"/>
-              </a:spcAft>
-              <a:defRPr sz="2000">
-                <a:solidFill>
-                  <a:srgbClr val="FFFFFF"/>
-                </a:solidFill>
-                <a:latin typeface="Calibri"/>
-              </a:defRPr>
-            </a:pPr>
-            <a:r>
-              <a:t>3. ¿Que es Alastria ID y en que se basa?</a:t>
-            </a:r>
-          </a:p>
-          <a:p>
-            <a:pPr>
-              <a:spcAft>
-                <a:spcPts val="1000"/>
-              </a:spcAft>
-              <a:defRPr sz="2000">
-                <a:solidFill>
-                  <a:srgbClr val="FFFFFF"/>
-                </a:solidFill>
-                <a:latin typeface="Calibri"/>
-              </a:defRPr>
-            </a:pPr>
-            <a:r>
-              <a:t>4. Describe el flujo de emision y verificacion de una VC en Alastria</a:t>
-            </a:r>
-          </a:p>
-          <a:p>
-            <a:pPr>
-              <a:spcAft>
-                <a:spcPts val="1000"/>
-              </a:spcAft>
-              <a:defRPr sz="2000">
-                <a:solidFill>
-                  <a:srgbClr val="FFFFFF"/>
-                </a:solidFill>
-                <a:latin typeface="Calibri"/>
-              </a:defRPr>
-            </a:pPr>
-            <a:r>
-              <a:t>5. Da un ejemplo real de integracion de VCs en una empresa</a:t>
-            </a:r>
-          </a:p>
-          <a:p>
-            <a:pPr>
-              <a:spcAft>
-                <a:spcPts val="1000"/>
-              </a:spcAft>
-              <a:defRPr sz="2000">
-                <a:solidFill>
-                  <a:srgbClr val="FFFFFF"/>
-                </a:solidFill>
-                <a:latin typeface="Calibri"/>
-              </a:defRPr>
-            </a:pPr>
-            <a:r>
-              <a:t>6. ¿Que es una arquitectura hibrida y por que tiene sentido?</a:t>
-            </a:r>
-          </a:p>
-          <a:p>
-            <a:pPr>
-              <a:spcAft>
-                <a:spcPts val="1000"/>
-              </a:spcAft>
-              <a:defRPr sz="2000">
-                <a:solidFill>
-                  <a:srgbClr val="FFFFFF"/>
-                </a:solidFill>
-                <a:latin typeface="Calibri"/>
-              </a:defRPr>
-            </a:pPr>
-            <a:r>
-              <a:t>7. ¿Cual es la diferencia entre X.509 de Fabric y un DID?</a:t>
-            </a:r>
-          </a:p>
-          <a:p>
-            <a:pPr>
-              <a:spcAft>
-                <a:spcPts val="1000"/>
-              </a:spcAft>
-              <a:defRPr sz="2000">
-                <a:solidFill>
-                  <a:srgbClr val="FFFFFF"/>
-                </a:solidFill>
-                <a:latin typeface="Calibri"/>
-              </a:defRPr>
-            </a:pPr>
-            <a:r>
-              <a:t>8. ¿Cuando usarias cada uno?</a:t>
+                <a:spcPts val="1600"/>
+              </a:spcAft>
+              <a:defRPr sz="2200">
+                <a:solidFill>
+                  <a:srgbClr val="333333"/>
+                </a:solidFill>
+                <a:latin typeface="Calibri"/>
+              </a:defRPr>
+            </a:pPr>
+            <a:r>
+              <a:t>1. ¿Alastria, EBSI o una solucion propia? ¿Que elegiriais para vuestra empresa y por que?</a:t>
+            </a:r>
+          </a:p>
+          <a:p>
+            <a:pPr>
+              <a:spcAft>
+                <a:spcPts val="1600"/>
+              </a:spcAft>
+              <a:defRPr sz="2200">
+                <a:solidFill>
+                  <a:srgbClr val="333333"/>
+                </a:solidFill>
+                <a:latin typeface="Calibri"/>
+              </a:defRPr>
+            </a:pPr>
+            <a:r>
+              <a:t>2. ¿Tiene sentido que la identidad sea autosoberana si el Estado sigue emitiendo los documentos oficiales?</a:t>
+            </a:r>
+          </a:p>
+          <a:p>
+            <a:pPr>
+              <a:spcAft>
+                <a:spcPts val="1600"/>
+              </a:spcAft>
+              <a:defRPr sz="2200">
+                <a:solidFill>
+                  <a:srgbClr val="333333"/>
+                </a:solidFill>
+                <a:latin typeface="Calibri"/>
+              </a:defRPr>
+            </a:pPr>
+            <a:r>
+              <a:t>3. ¿Cuando usariais X.509 de Fabric y cuando DIDs/VCs? ¿Pueden convivir?</a:t>
+            </a:r>
+          </a:p>
+          <a:p>
+            <a:pPr>
+              <a:spcAft>
+                <a:spcPts val="1600"/>
+              </a:spcAft>
+              <a:defRPr sz="2200">
+                <a:solidFill>
+                  <a:srgbClr val="333333"/>
+                </a:solidFill>
+                <a:latin typeface="Calibri"/>
+              </a:defRPr>
+            </a:pPr>
+            <a:r>
+              <a:t>4. ¿Cual es el mayor obstaculo para la adopcion de la identidad descentralizada?</a:t>
+            </a:r>
+          </a:p>
+          <a:p>
+            <a:pPr>
+              <a:spcAft>
+                <a:spcPts val="1600"/>
+              </a:spcAft>
+              <a:defRPr sz="2200">
+                <a:solidFill>
+                  <a:srgbClr val="333333"/>
+                </a:solidFill>
+                <a:latin typeface="Calibri"/>
+              </a:defRPr>
+            </a:pPr>
+            <a:r>
+              <a:t>5. ¿Creeis que en 5 anos tendremos todos un wallet de identidad en el movil?</a:t>
             </a:r>
           </a:p>
         </p:txBody>
@@ -10357,6 +10429,295 @@
             </a:pPr>
             <a:r>
               <a:t>    Registro de auditoria para cumplimiento normativo</a:t>
+            </a:r>
+          </a:p>
+        </p:txBody>
+      </p:sp>
+    </p:spTree>
+  </p:cSld>
+  <p:clrMapOvr>
+    <a:masterClrMapping/>
+  </p:clrMapOvr>
+</p:sld>
+</file>
+
+<file path=ppt/slides/slide30.xml><?xml version="1.0" encoding="utf-8"?>
+<p:sld xmlns:a="http://schemas.openxmlformats.org/drawingml/2006/main" xmlns:p="http://schemas.openxmlformats.org/presentationml/2006/main" xmlns:r="http://schemas.openxmlformats.org/officeDocument/2006/relationships">
+  <p:cSld>
+    <p:spTree>
+      <p:nvGrpSpPr>
+        <p:cNvPr id="1" name=""/>
+        <p:cNvGrpSpPr/>
+        <p:nvPr/>
+      </p:nvGrpSpPr>
+      <p:grpSpPr/>
+      <p:sp>
+        <p:nvSpPr>
+          <p:cNvPr id="2" name="Rectangle 1"/>
+          <p:cNvSpPr/>
+          <p:nvPr/>
+        </p:nvSpPr>
+        <p:spPr>
+          <a:xfrm>
+            <a:off x="0" y="0"/>
+            <a:ext cx="12188952" cy="6858000"/>
+          </a:xfrm>
+          <a:prstGeom prst="rect">
+            <a:avLst/>
+          </a:prstGeom>
+          <a:solidFill>
+            <a:srgbClr val="22627E"/>
+          </a:solidFill>
+          <a:ln>
+            <a:noFill/>
+          </a:ln>
+        </p:spPr>
+        <p:style>
+          <a:lnRef idx="1">
+            <a:schemeClr val="accent1"/>
+          </a:lnRef>
+          <a:fillRef idx="3">
+            <a:schemeClr val="accent1"/>
+          </a:fillRef>
+          <a:effectRef idx="2">
+            <a:schemeClr val="accent1"/>
+          </a:effectRef>
+          <a:fontRef idx="minor">
+            <a:schemeClr val="lt1"/>
+          </a:fontRef>
+        </p:style>
+        <p:txBody>
+          <a:bodyPr rtlCol="0" anchor="ctr"/>
+          <a:lstStyle/>
+          <a:p>
+            <a:pPr algn="ctr"/>
+          </a:p>
+        </p:txBody>
+      </p:sp>
+      <p:sp>
+        <p:nvSpPr>
+          <p:cNvPr id="3" name="TextBox 2"/>
+          <p:cNvSpPr txBox="1"/>
+          <p:nvPr/>
+        </p:nvSpPr>
+        <p:spPr>
+          <a:xfrm>
+            <a:off x="457200" y="274320"/>
+            <a:ext cx="10972800" cy="731520"/>
+          </a:xfrm>
+          <a:prstGeom prst="rect">
+            <a:avLst/>
+          </a:prstGeom>
+          <a:noFill/>
+        </p:spPr>
+        <p:txBody>
+          <a:bodyPr wrap="square"/>
+          <a:lstStyle/>
+          <a:p>
+            <a:pPr algn="l">
+              <a:defRPr sz="3600" b="1">
+                <a:solidFill>
+                  <a:srgbClr val="FFFFFF"/>
+                </a:solidFill>
+                <a:latin typeface="Calibri"/>
+              </a:defRPr>
+            </a:pPr>
+            <a:r>
+              <a:t>Repaso del modulo: Identidad Digital</a:t>
+            </a:r>
+          </a:p>
+        </p:txBody>
+      </p:sp>
+      <p:sp>
+        <p:nvSpPr>
+          <p:cNvPr id="4" name="Rectangle 3"/>
+          <p:cNvSpPr/>
+          <p:nvPr/>
+        </p:nvSpPr>
+        <p:spPr>
+          <a:xfrm>
+            <a:off x="457200" y="1051560"/>
+            <a:ext cx="10972800" cy="27432"/>
+          </a:xfrm>
+          <a:prstGeom prst="rect">
+            <a:avLst/>
+          </a:prstGeom>
+          <a:solidFill>
+            <a:srgbClr val="FFFFFF"/>
+          </a:solidFill>
+          <a:ln>
+            <a:noFill/>
+          </a:ln>
+        </p:spPr>
+        <p:style>
+          <a:lnRef idx="1">
+            <a:schemeClr val="accent1"/>
+          </a:lnRef>
+          <a:fillRef idx="3">
+            <a:schemeClr val="accent1"/>
+          </a:fillRef>
+          <a:effectRef idx="2">
+            <a:schemeClr val="accent1"/>
+          </a:effectRef>
+          <a:fontRef idx="minor">
+            <a:schemeClr val="lt1"/>
+          </a:fontRef>
+        </p:style>
+        <p:txBody>
+          <a:bodyPr rtlCol="0" anchor="ctr"/>
+          <a:lstStyle/>
+          <a:p>
+            <a:pPr algn="ctr"/>
+          </a:p>
+        </p:txBody>
+      </p:sp>
+      <p:sp>
+        <p:nvSpPr>
+          <p:cNvPr id="5" name="TextBox 4"/>
+          <p:cNvSpPr txBox="1"/>
+          <p:nvPr/>
+        </p:nvSpPr>
+        <p:spPr>
+          <a:xfrm>
+            <a:off x="640080" y="1371600"/>
+            <a:ext cx="10515600" cy="5029200"/>
+          </a:xfrm>
+          <a:prstGeom prst="rect">
+            <a:avLst/>
+          </a:prstGeom>
+          <a:noFill/>
+        </p:spPr>
+        <p:txBody>
+          <a:bodyPr wrap="square">
+            <a:spAutoFit/>
+          </a:bodyPr>
+          <a:lstStyle/>
+          <a:p>
+            <a:pPr>
+              <a:spcAft>
+                <a:spcPts val="1000"/>
+              </a:spcAft>
+              <a:defRPr sz="2000">
+                <a:solidFill>
+                  <a:srgbClr val="FFFFFF"/>
+                </a:solidFill>
+                <a:latin typeface="Calibri"/>
+              </a:defRPr>
+            </a:pPr>
+            <a:r>
+              <a:t>1. ¿Que es EBSI y que relacion tiene con eIDAS 2?</a:t>
+            </a:r>
+          </a:p>
+          <a:p>
+            <a:pPr>
+              <a:spcAft>
+                <a:spcPts val="1000"/>
+              </a:spcAft>
+              <a:defRPr sz="2000">
+                <a:solidFill>
+                  <a:srgbClr val="FFFFFF"/>
+                </a:solidFill>
+                <a:latin typeface="Calibri"/>
+              </a:defRPr>
+            </a:pPr>
+            <a:r>
+              <a:t>2. ¿Que es Alastria y que redes opera?</a:t>
+            </a:r>
+          </a:p>
+          <a:p>
+            <a:pPr>
+              <a:spcAft>
+                <a:spcPts val="1000"/>
+              </a:spcAft>
+              <a:defRPr sz="2000">
+                <a:solidFill>
+                  <a:srgbClr val="FFFFFF"/>
+                </a:solidFill>
+                <a:latin typeface="Calibri"/>
+              </a:defRPr>
+            </a:pPr>
+            <a:r>
+              <a:t>3. ¿Que es Alastria ID y en que se basa?</a:t>
+            </a:r>
+          </a:p>
+          <a:p>
+            <a:pPr>
+              <a:spcAft>
+                <a:spcPts val="1000"/>
+              </a:spcAft>
+              <a:defRPr sz="2000">
+                <a:solidFill>
+                  <a:srgbClr val="FFFFFF"/>
+                </a:solidFill>
+                <a:latin typeface="Calibri"/>
+              </a:defRPr>
+            </a:pPr>
+            <a:r>
+              <a:t>4. Describe el flujo de emision y verificacion de una VC en Alastria</a:t>
+            </a:r>
+          </a:p>
+          <a:p>
+            <a:pPr>
+              <a:spcAft>
+                <a:spcPts val="1000"/>
+              </a:spcAft>
+              <a:defRPr sz="2000">
+                <a:solidFill>
+                  <a:srgbClr val="FFFFFF"/>
+                </a:solidFill>
+                <a:latin typeface="Calibri"/>
+              </a:defRPr>
+            </a:pPr>
+            <a:r>
+              <a:t>5. Da un ejemplo real de integracion de VCs en una empresa</a:t>
+            </a:r>
+          </a:p>
+          <a:p>
+            <a:pPr>
+              <a:spcAft>
+                <a:spcPts val="1000"/>
+              </a:spcAft>
+              <a:defRPr sz="2000">
+                <a:solidFill>
+                  <a:srgbClr val="FFFFFF"/>
+                </a:solidFill>
+                <a:latin typeface="Calibri"/>
+              </a:defRPr>
+            </a:pPr>
+            <a:r>
+              <a:t>6. ¿Que es una arquitectura hibrida y por que tiene sentido?</a:t>
+            </a:r>
+          </a:p>
+          <a:p>
+            <a:pPr>
+              <a:spcAft>
+                <a:spcPts val="1000"/>
+              </a:spcAft>
+              <a:defRPr sz="2000">
+                <a:solidFill>
+                  <a:srgbClr val="FFFFFF"/>
+                </a:solidFill>
+                <a:latin typeface="Calibri"/>
+              </a:defRPr>
+            </a:pPr>
+            <a:r>
+              <a:t>7. ¿Cual es la diferencia entre X.509 de Fabric y un DID?</a:t>
+            </a:r>
+          </a:p>
+          <a:p>
+            <a:pPr>
+              <a:spcAft>
+                <a:spcPts val="1000"/>
+              </a:spcAft>
+              <a:defRPr sz="2000">
+                <a:solidFill>
+                  <a:srgbClr val="FFFFFF"/>
+                </a:solidFill>
+                <a:latin typeface="Calibri"/>
+              </a:defRPr>
+            </a:pPr>
+            <a:r>
+              <a:t>8. ¿Cuando usarias cada uno?</a:t>
             </a:r>
           </a:p>
         </p:txBody>

</xml_diff>

<commit_message>
Reorganizar slides: mover Anexo Certificados a Módulo 6, actualizar presentaciones
- Mover Anexo Certificados académicos de Módulo 1 a Módulo 6
- Añadir presentación Gestión de proyectos al Módulo 6
- Añadir presentación Identidad Digital al Módulo 5
- Actualizar presentaciones de Módulos 1 y 5
- Eliminar complemento de gestión (integrado en la principal)

Co-Authored-By: Claude Opus 4.6 (1M context) <noreply@anthropic.com>
</commit_message>
<xml_diff>
--- a/docs/slides/Modulo 5/identidad_digital_parte2.pptx
+++ b/docs/slides/Modulo 5/identidad_digital_parte2.pptx
@@ -5,38 +5,38 @@
     <p:sldMasterId id="2147483648" r:id="rId1"/>
   </p:sldMasterIdLst>
   <p:sldIdLst>
-    <p:sldId id="256" r:id="rId7"/>
-    <p:sldId id="257" r:id="rId8"/>
-    <p:sldId id="258" r:id="rId9"/>
-    <p:sldId id="259" r:id="rId10"/>
-    <p:sldId id="260" r:id="rId11"/>
-    <p:sldId id="261" r:id="rId12"/>
-    <p:sldId id="262" r:id="rId13"/>
-    <p:sldId id="263" r:id="rId14"/>
-    <p:sldId id="264" r:id="rId15"/>
-    <p:sldId id="265" r:id="rId16"/>
-    <p:sldId id="266" r:id="rId17"/>
-    <p:sldId id="267" r:id="rId18"/>
-    <p:sldId id="268" r:id="rId19"/>
-    <p:sldId id="269" r:id="rId20"/>
-    <p:sldId id="270" r:id="rId21"/>
-    <p:sldId id="271" r:id="rId22"/>
-    <p:sldId id="272" r:id="rId23"/>
-    <p:sldId id="273" r:id="rId24"/>
-    <p:sldId id="274" r:id="rId25"/>
-    <p:sldId id="275" r:id="rId26"/>
-    <p:sldId id="276" r:id="rId27"/>
-    <p:sldId id="277" r:id="rId28"/>
-    <p:sldId id="278" r:id="rId29"/>
-    <p:sldId id="279" r:id="rId30"/>
-    <p:sldId id="280" r:id="rId31"/>
-    <p:sldId id="281" r:id="rId32"/>
-    <p:sldId id="282" r:id="rId33"/>
-    <p:sldId id="283" r:id="rId34"/>
-    <p:sldId id="284" r:id="rId35"/>
-    <p:sldId id="285" r:id="rId36"/>
+    <p:sldId id="256" r:id="rId2"/>
+    <p:sldId id="257" r:id="rId3"/>
+    <p:sldId id="258" r:id="rId4"/>
+    <p:sldId id="259" r:id="rId5"/>
+    <p:sldId id="260" r:id="rId6"/>
+    <p:sldId id="261" r:id="rId7"/>
+    <p:sldId id="262" r:id="rId8"/>
+    <p:sldId id="263" r:id="rId9"/>
+    <p:sldId id="264" r:id="rId10"/>
+    <p:sldId id="265" r:id="rId11"/>
+    <p:sldId id="266" r:id="rId12"/>
+    <p:sldId id="267" r:id="rId13"/>
+    <p:sldId id="268" r:id="rId14"/>
+    <p:sldId id="269" r:id="rId15"/>
+    <p:sldId id="270" r:id="rId16"/>
+    <p:sldId id="271" r:id="rId17"/>
+    <p:sldId id="272" r:id="rId18"/>
+    <p:sldId id="273" r:id="rId19"/>
+    <p:sldId id="274" r:id="rId20"/>
+    <p:sldId id="275" r:id="rId21"/>
+    <p:sldId id="276" r:id="rId22"/>
+    <p:sldId id="277" r:id="rId23"/>
+    <p:sldId id="278" r:id="rId24"/>
+    <p:sldId id="279" r:id="rId25"/>
+    <p:sldId id="280" r:id="rId26"/>
+    <p:sldId id="281" r:id="rId27"/>
+    <p:sldId id="282" r:id="rId28"/>
+    <p:sldId id="283" r:id="rId29"/>
+    <p:sldId id="284" r:id="rId30"/>
+    <p:sldId id="285" r:id="rId31"/>
   </p:sldIdLst>
-  <p:sldSz cx="12188952" cy="6858000" type="screen4x3"/>
+  <p:sldSz cx="12188825" cy="6858000"/>
   <p:notesSz cx="6858000" cy="9144000"/>
   <p:defaultTextStyle>
     <a:defPPr>
@@ -133,6 +133,22 @@
       </a:defRPr>
     </a:lvl9pPr>
   </p:defaultTextStyle>
+  <p:extLst>
+    <p:ext uri="{EFAFB233-063F-42B5-8137-9DF3F51BA10A}">
+      <p15:sldGuideLst xmlns:p15="http://schemas.microsoft.com/office/powerpoint/2012/main">
+        <p15:guide id="1" orient="horz" pos="2160">
+          <p15:clr>
+            <a:srgbClr val="A4A3A4"/>
+          </p15:clr>
+        </p15:guide>
+        <p15:guide id="2" pos="2880">
+          <p15:clr>
+            <a:srgbClr val="A4A3A4"/>
+          </p15:clr>
+        </p15:guide>
+      </p15:sldGuideLst>
+    </p:ext>
+  </p:extLst>
 </p:presentation>
 </file>
 
@@ -174,10 +190,9 @@
           <a:lstStyle/>
           <a:p>
             <a:r>
-              <a:rPr lang="en-US" smtClean="0"/>
+              <a:rPr lang="en-US"/>
               <a:t>Click to edit Master title style</a:t>
             </a:r>
-            <a:endParaRPr lang="en-US"/>
           </a:p>
         </p:txBody>
       </p:sp>
@@ -293,10 +308,9 @@
           </a:lstStyle>
           <a:p>
             <a:r>
-              <a:rPr lang="en-US" smtClean="0"/>
+              <a:rPr lang="en-US"/>
               <a:t>Click to edit Master subtitle style</a:t>
             </a:r>
-            <a:endParaRPr lang="en-US"/>
           </a:p>
         </p:txBody>
       </p:sp>
@@ -317,7 +331,7 @@
           <a:p>
             <a:fld id="{5BCAD085-E8A6-8845-BD4E-CB4CCA059FC4}" type="datetimeFigureOut">
               <a:rPr lang="en-US" smtClean="0"/>
-              <a:t>1/27/13</a:t>
+              <a:t>4/16/2026</a:t>
             </a:fld>
             <a:endParaRPr lang="en-US"/>
           </a:p>
@@ -359,7 +373,7 @@
           <a:p>
             <a:fld id="{C1FF6DA9-008F-8B48-92A6-B652298478BF}" type="slidenum">
               <a:rPr lang="en-US" smtClean="0"/>
-              <a:t>‹#›</a:t>
+              <a:t>‹Nº›</a:t>
             </a:fld>
             <a:endParaRPr lang="en-US"/>
           </a:p>
@@ -411,10 +425,9 @@
           <a:lstStyle/>
           <a:p>
             <a:r>
-              <a:rPr lang="en-US" smtClean="0"/>
+              <a:rPr lang="en-US"/>
               <a:t>Click to edit Master title style</a:t>
             </a:r>
-            <a:endParaRPr lang="en-US"/>
           </a:p>
         </p:txBody>
       </p:sp>
@@ -435,38 +448,37 @@
           <a:p>
             <a:pPr lvl="0"/>
             <a:r>
-              <a:rPr lang="en-US" smtClean="0"/>
+              <a:rPr lang="en-US"/>
               <a:t>Click to edit Master text styles</a:t>
             </a:r>
           </a:p>
           <a:p>
             <a:pPr lvl="1"/>
             <a:r>
-              <a:rPr lang="en-US" smtClean="0"/>
+              <a:rPr lang="en-US"/>
               <a:t>Second level</a:t>
             </a:r>
           </a:p>
           <a:p>
             <a:pPr lvl="2"/>
             <a:r>
-              <a:rPr lang="en-US" smtClean="0"/>
+              <a:rPr lang="en-US"/>
               <a:t>Third level</a:t>
             </a:r>
           </a:p>
           <a:p>
             <a:pPr lvl="3"/>
             <a:r>
-              <a:rPr lang="en-US" smtClean="0"/>
+              <a:rPr lang="en-US"/>
               <a:t>Fourth level</a:t>
             </a:r>
           </a:p>
           <a:p>
             <a:pPr lvl="4"/>
             <a:r>
-              <a:rPr lang="en-US" smtClean="0"/>
+              <a:rPr lang="en-US"/>
               <a:t>Fifth level</a:t>
             </a:r>
-            <a:endParaRPr lang="en-US"/>
           </a:p>
         </p:txBody>
       </p:sp>
@@ -487,7 +499,7 @@
           <a:p>
             <a:fld id="{5BCAD085-E8A6-8845-BD4E-CB4CCA059FC4}" type="datetimeFigureOut">
               <a:rPr lang="en-US" smtClean="0"/>
-              <a:t>1/27/13</a:t>
+              <a:t>4/16/2026</a:t>
             </a:fld>
             <a:endParaRPr lang="en-US"/>
           </a:p>
@@ -529,7 +541,7 @@
           <a:p>
             <a:fld id="{C1FF6DA9-008F-8B48-92A6-B652298478BF}" type="slidenum">
               <a:rPr lang="en-US" smtClean="0"/>
-              <a:t>‹#›</a:t>
+              <a:t>‹Nº›</a:t>
             </a:fld>
             <a:endParaRPr lang="en-US"/>
           </a:p>
@@ -586,10 +598,9 @@
           <a:lstStyle/>
           <a:p>
             <a:r>
-              <a:rPr lang="en-US" smtClean="0"/>
+              <a:rPr lang="en-US"/>
               <a:t>Click to edit Master title style</a:t>
             </a:r>
-            <a:endParaRPr lang="en-US"/>
           </a:p>
         </p:txBody>
       </p:sp>
@@ -615,38 +626,37 @@
           <a:p>
             <a:pPr lvl="0"/>
             <a:r>
-              <a:rPr lang="en-US" smtClean="0"/>
+              <a:rPr lang="en-US"/>
               <a:t>Click to edit Master text styles</a:t>
             </a:r>
           </a:p>
           <a:p>
             <a:pPr lvl="1"/>
             <a:r>
-              <a:rPr lang="en-US" smtClean="0"/>
+              <a:rPr lang="en-US"/>
               <a:t>Second level</a:t>
             </a:r>
           </a:p>
           <a:p>
             <a:pPr lvl="2"/>
             <a:r>
-              <a:rPr lang="en-US" smtClean="0"/>
+              <a:rPr lang="en-US"/>
               <a:t>Third level</a:t>
             </a:r>
           </a:p>
           <a:p>
             <a:pPr lvl="3"/>
             <a:r>
-              <a:rPr lang="en-US" smtClean="0"/>
+              <a:rPr lang="en-US"/>
               <a:t>Fourth level</a:t>
             </a:r>
           </a:p>
           <a:p>
             <a:pPr lvl="4"/>
             <a:r>
-              <a:rPr lang="en-US" smtClean="0"/>
+              <a:rPr lang="en-US"/>
               <a:t>Fifth level</a:t>
             </a:r>
-            <a:endParaRPr lang="en-US"/>
           </a:p>
         </p:txBody>
       </p:sp>
@@ -667,7 +677,7 @@
           <a:p>
             <a:fld id="{5BCAD085-E8A6-8845-BD4E-CB4CCA059FC4}" type="datetimeFigureOut">
               <a:rPr lang="en-US" smtClean="0"/>
-              <a:t>1/27/13</a:t>
+              <a:t>4/16/2026</a:t>
             </a:fld>
             <a:endParaRPr lang="en-US"/>
           </a:p>
@@ -709,7 +719,7 @@
           <a:p>
             <a:fld id="{C1FF6DA9-008F-8B48-92A6-B652298478BF}" type="slidenum">
               <a:rPr lang="en-US" smtClean="0"/>
-              <a:t>‹#›</a:t>
+              <a:t>‹Nº›</a:t>
             </a:fld>
             <a:endParaRPr lang="en-US"/>
           </a:p>
@@ -761,10 +771,9 @@
           <a:lstStyle/>
           <a:p>
             <a:r>
-              <a:rPr lang="en-US" smtClean="0"/>
+              <a:rPr lang="en-US"/>
               <a:t>Click to edit Master title style</a:t>
             </a:r>
-            <a:endParaRPr lang="en-US"/>
           </a:p>
         </p:txBody>
       </p:sp>
@@ -785,38 +794,37 @@
           <a:p>
             <a:pPr lvl="0"/>
             <a:r>
-              <a:rPr lang="en-US" smtClean="0"/>
+              <a:rPr lang="en-US"/>
               <a:t>Click to edit Master text styles</a:t>
             </a:r>
           </a:p>
           <a:p>
             <a:pPr lvl="1"/>
             <a:r>
-              <a:rPr lang="en-US" smtClean="0"/>
+              <a:rPr lang="en-US"/>
               <a:t>Second level</a:t>
             </a:r>
           </a:p>
           <a:p>
             <a:pPr lvl="2"/>
             <a:r>
-              <a:rPr lang="en-US" smtClean="0"/>
+              <a:rPr lang="en-US"/>
               <a:t>Third level</a:t>
             </a:r>
           </a:p>
           <a:p>
             <a:pPr lvl="3"/>
             <a:r>
-              <a:rPr lang="en-US" smtClean="0"/>
+              <a:rPr lang="en-US"/>
               <a:t>Fourth level</a:t>
             </a:r>
           </a:p>
           <a:p>
             <a:pPr lvl="4"/>
             <a:r>
-              <a:rPr lang="en-US" smtClean="0"/>
+              <a:rPr lang="en-US"/>
               <a:t>Fifth level</a:t>
             </a:r>
-            <a:endParaRPr lang="en-US"/>
           </a:p>
         </p:txBody>
       </p:sp>
@@ -837,7 +845,7 @@
           <a:p>
             <a:fld id="{5BCAD085-E8A6-8845-BD4E-CB4CCA059FC4}" type="datetimeFigureOut">
               <a:rPr lang="en-US" smtClean="0"/>
-              <a:t>1/27/13</a:t>
+              <a:t>4/16/2026</a:t>
             </a:fld>
             <a:endParaRPr lang="en-US"/>
           </a:p>
@@ -879,7 +887,7 @@
           <a:p>
             <a:fld id="{C1FF6DA9-008F-8B48-92A6-B652298478BF}" type="slidenum">
               <a:rPr lang="en-US" smtClean="0"/>
-              <a:t>‹#›</a:t>
+              <a:t>‹Nº›</a:t>
             </a:fld>
             <a:endParaRPr lang="en-US"/>
           </a:p>
@@ -940,10 +948,9 @@
           </a:lstStyle>
           <a:p>
             <a:r>
-              <a:rPr lang="en-US" smtClean="0"/>
+              <a:rPr lang="en-US"/>
               <a:t>Click to edit Master title style</a:t>
             </a:r>
-            <a:endParaRPr lang="en-US"/>
           </a:p>
         </p:txBody>
       </p:sp>
@@ -1060,7 +1067,7 @@
           <a:p>
             <a:pPr lvl="0"/>
             <a:r>
-              <a:rPr lang="en-US" smtClean="0"/>
+              <a:rPr lang="en-US"/>
               <a:t>Click to edit Master text styles</a:t>
             </a:r>
           </a:p>
@@ -1083,7 +1090,7 @@
           <a:p>
             <a:fld id="{5BCAD085-E8A6-8845-BD4E-CB4CCA059FC4}" type="datetimeFigureOut">
               <a:rPr lang="en-US" smtClean="0"/>
-              <a:t>1/27/13</a:t>
+              <a:t>4/16/2026</a:t>
             </a:fld>
             <a:endParaRPr lang="en-US"/>
           </a:p>
@@ -1125,7 +1132,7 @@
           <a:p>
             <a:fld id="{C1FF6DA9-008F-8B48-92A6-B652298478BF}" type="slidenum">
               <a:rPr lang="en-US" smtClean="0"/>
-              <a:t>‹#›</a:t>
+              <a:t>‹Nº›</a:t>
             </a:fld>
             <a:endParaRPr lang="en-US"/>
           </a:p>
@@ -1177,10 +1184,9 @@
           <a:lstStyle/>
           <a:p>
             <a:r>
-              <a:rPr lang="en-US" smtClean="0"/>
+              <a:rPr lang="en-US"/>
               <a:t>Click to edit Master title style</a:t>
             </a:r>
-            <a:endParaRPr lang="en-US"/>
           </a:p>
         </p:txBody>
       </p:sp>
@@ -1234,38 +1240,37 @@
           <a:p>
             <a:pPr lvl="0"/>
             <a:r>
-              <a:rPr lang="en-US" smtClean="0"/>
+              <a:rPr lang="en-US"/>
               <a:t>Click to edit Master text styles</a:t>
             </a:r>
           </a:p>
           <a:p>
             <a:pPr lvl="1"/>
             <a:r>
-              <a:rPr lang="en-US" smtClean="0"/>
+              <a:rPr lang="en-US"/>
               <a:t>Second level</a:t>
             </a:r>
           </a:p>
           <a:p>
             <a:pPr lvl="2"/>
             <a:r>
-              <a:rPr lang="en-US" smtClean="0"/>
+              <a:rPr lang="en-US"/>
               <a:t>Third level</a:t>
             </a:r>
           </a:p>
           <a:p>
             <a:pPr lvl="3"/>
             <a:r>
-              <a:rPr lang="en-US" smtClean="0"/>
+              <a:rPr lang="en-US"/>
               <a:t>Fourth level</a:t>
             </a:r>
           </a:p>
           <a:p>
             <a:pPr lvl="4"/>
             <a:r>
-              <a:rPr lang="en-US" smtClean="0"/>
+              <a:rPr lang="en-US"/>
               <a:t>Fifth level</a:t>
             </a:r>
-            <a:endParaRPr lang="en-US"/>
           </a:p>
         </p:txBody>
       </p:sp>
@@ -1319,38 +1324,37 @@
           <a:p>
             <a:pPr lvl="0"/>
             <a:r>
-              <a:rPr lang="en-US" smtClean="0"/>
+              <a:rPr lang="en-US"/>
               <a:t>Click to edit Master text styles</a:t>
             </a:r>
           </a:p>
           <a:p>
             <a:pPr lvl="1"/>
             <a:r>
-              <a:rPr lang="en-US" smtClean="0"/>
+              <a:rPr lang="en-US"/>
               <a:t>Second level</a:t>
             </a:r>
           </a:p>
           <a:p>
             <a:pPr lvl="2"/>
             <a:r>
-              <a:rPr lang="en-US" smtClean="0"/>
+              <a:rPr lang="en-US"/>
               <a:t>Third level</a:t>
             </a:r>
           </a:p>
           <a:p>
             <a:pPr lvl="3"/>
             <a:r>
-              <a:rPr lang="en-US" smtClean="0"/>
+              <a:rPr lang="en-US"/>
               <a:t>Fourth level</a:t>
             </a:r>
           </a:p>
           <a:p>
             <a:pPr lvl="4"/>
             <a:r>
-              <a:rPr lang="en-US" smtClean="0"/>
+              <a:rPr lang="en-US"/>
               <a:t>Fifth level</a:t>
             </a:r>
-            <a:endParaRPr lang="en-US"/>
           </a:p>
         </p:txBody>
       </p:sp>
@@ -1371,7 +1375,7 @@
           <a:p>
             <a:fld id="{5BCAD085-E8A6-8845-BD4E-CB4CCA059FC4}" type="datetimeFigureOut">
               <a:rPr lang="en-US" smtClean="0"/>
-              <a:t>1/27/13</a:t>
+              <a:t>4/16/2026</a:t>
             </a:fld>
             <a:endParaRPr lang="en-US"/>
           </a:p>
@@ -1413,7 +1417,7 @@
           <a:p>
             <a:fld id="{C1FF6DA9-008F-8B48-92A6-B652298478BF}" type="slidenum">
               <a:rPr lang="en-US" smtClean="0"/>
-              <a:t>‹#›</a:t>
+              <a:t>‹Nº›</a:t>
             </a:fld>
             <a:endParaRPr lang="en-US"/>
           </a:p>
@@ -1469,10 +1473,9 @@
           </a:lstStyle>
           <a:p>
             <a:r>
-              <a:rPr lang="en-US" smtClean="0"/>
+              <a:rPr lang="en-US"/>
               <a:t>Click to edit Master title style</a:t>
             </a:r>
-            <a:endParaRPr lang="en-US"/>
           </a:p>
         </p:txBody>
       </p:sp>
@@ -1535,7 +1538,7 @@
           <a:p>
             <a:pPr lvl="0"/>
             <a:r>
-              <a:rPr lang="en-US" smtClean="0"/>
+              <a:rPr lang="en-US"/>
               <a:t>Click to edit Master text styles</a:t>
             </a:r>
           </a:p>
@@ -1591,38 +1594,37 @@
           <a:p>
             <a:pPr lvl="0"/>
             <a:r>
-              <a:rPr lang="en-US" smtClean="0"/>
+              <a:rPr lang="en-US"/>
               <a:t>Click to edit Master text styles</a:t>
             </a:r>
           </a:p>
           <a:p>
             <a:pPr lvl="1"/>
             <a:r>
-              <a:rPr lang="en-US" smtClean="0"/>
+              <a:rPr lang="en-US"/>
               <a:t>Second level</a:t>
             </a:r>
           </a:p>
           <a:p>
             <a:pPr lvl="2"/>
             <a:r>
-              <a:rPr lang="en-US" smtClean="0"/>
+              <a:rPr lang="en-US"/>
               <a:t>Third level</a:t>
             </a:r>
           </a:p>
           <a:p>
             <a:pPr lvl="3"/>
             <a:r>
-              <a:rPr lang="en-US" smtClean="0"/>
+              <a:rPr lang="en-US"/>
               <a:t>Fourth level</a:t>
             </a:r>
           </a:p>
           <a:p>
             <a:pPr lvl="4"/>
             <a:r>
-              <a:rPr lang="en-US" smtClean="0"/>
+              <a:rPr lang="en-US"/>
               <a:t>Fifth level</a:t>
             </a:r>
-            <a:endParaRPr lang="en-US"/>
           </a:p>
         </p:txBody>
       </p:sp>
@@ -1685,7 +1687,7 @@
           <a:p>
             <a:pPr lvl="0"/>
             <a:r>
-              <a:rPr lang="en-US" smtClean="0"/>
+              <a:rPr lang="en-US"/>
               <a:t>Click to edit Master text styles</a:t>
             </a:r>
           </a:p>
@@ -1741,38 +1743,37 @@
           <a:p>
             <a:pPr lvl="0"/>
             <a:r>
-              <a:rPr lang="en-US" smtClean="0"/>
+              <a:rPr lang="en-US"/>
               <a:t>Click to edit Master text styles</a:t>
             </a:r>
           </a:p>
           <a:p>
             <a:pPr lvl="1"/>
             <a:r>
-              <a:rPr lang="en-US" smtClean="0"/>
+              <a:rPr lang="en-US"/>
               <a:t>Second level</a:t>
             </a:r>
           </a:p>
           <a:p>
             <a:pPr lvl="2"/>
             <a:r>
-              <a:rPr lang="en-US" smtClean="0"/>
+              <a:rPr lang="en-US"/>
               <a:t>Third level</a:t>
             </a:r>
           </a:p>
           <a:p>
             <a:pPr lvl="3"/>
             <a:r>
-              <a:rPr lang="en-US" smtClean="0"/>
+              <a:rPr lang="en-US"/>
               <a:t>Fourth level</a:t>
             </a:r>
           </a:p>
           <a:p>
             <a:pPr lvl="4"/>
             <a:r>
-              <a:rPr lang="en-US" smtClean="0"/>
+              <a:rPr lang="en-US"/>
               <a:t>Fifth level</a:t>
             </a:r>
-            <a:endParaRPr lang="en-US"/>
           </a:p>
         </p:txBody>
       </p:sp>
@@ -1793,7 +1794,7 @@
           <a:p>
             <a:fld id="{5BCAD085-E8A6-8845-BD4E-CB4CCA059FC4}" type="datetimeFigureOut">
               <a:rPr lang="en-US" smtClean="0"/>
-              <a:t>1/27/13</a:t>
+              <a:t>4/16/2026</a:t>
             </a:fld>
             <a:endParaRPr lang="en-US"/>
           </a:p>
@@ -1835,7 +1836,7 @@
           <a:p>
             <a:fld id="{C1FF6DA9-008F-8B48-92A6-B652298478BF}" type="slidenum">
               <a:rPr lang="en-US" smtClean="0"/>
-              <a:t>‹#›</a:t>
+              <a:t>‹Nº›</a:t>
             </a:fld>
             <a:endParaRPr lang="en-US"/>
           </a:p>
@@ -1887,10 +1888,9 @@
           <a:lstStyle/>
           <a:p>
             <a:r>
-              <a:rPr lang="en-US" smtClean="0"/>
+              <a:rPr lang="en-US"/>
               <a:t>Click to edit Master title style</a:t>
             </a:r>
-            <a:endParaRPr lang="en-US"/>
           </a:p>
         </p:txBody>
       </p:sp>
@@ -1911,7 +1911,7 @@
           <a:p>
             <a:fld id="{5BCAD085-E8A6-8845-BD4E-CB4CCA059FC4}" type="datetimeFigureOut">
               <a:rPr lang="en-US" smtClean="0"/>
-              <a:t>1/27/13</a:t>
+              <a:t>4/16/2026</a:t>
             </a:fld>
             <a:endParaRPr lang="en-US"/>
           </a:p>
@@ -1953,7 +1953,7 @@
           <a:p>
             <a:fld id="{C1FF6DA9-008F-8B48-92A6-B652298478BF}" type="slidenum">
               <a:rPr lang="en-US" smtClean="0"/>
-              <a:t>‹#›</a:t>
+              <a:t>‹Nº›</a:t>
             </a:fld>
             <a:endParaRPr lang="en-US"/>
           </a:p>
@@ -2006,7 +2006,7 @@
           <a:p>
             <a:fld id="{5BCAD085-E8A6-8845-BD4E-CB4CCA059FC4}" type="datetimeFigureOut">
               <a:rPr lang="en-US" smtClean="0"/>
-              <a:t>1/27/13</a:t>
+              <a:t>4/16/2026</a:t>
             </a:fld>
             <a:endParaRPr lang="en-US"/>
           </a:p>
@@ -2048,7 +2048,7 @@
           <a:p>
             <a:fld id="{C1FF6DA9-008F-8B48-92A6-B652298478BF}" type="slidenum">
               <a:rPr lang="en-US" smtClean="0"/>
-              <a:t>‹#›</a:t>
+              <a:t>‹Nº›</a:t>
             </a:fld>
             <a:endParaRPr lang="en-US"/>
           </a:p>
@@ -2109,10 +2109,9 @@
           </a:lstStyle>
           <a:p>
             <a:r>
-              <a:rPr lang="en-US" smtClean="0"/>
+              <a:rPr lang="en-US"/>
               <a:t>Click to edit Master title style</a:t>
             </a:r>
-            <a:endParaRPr lang="en-US"/>
           </a:p>
         </p:txBody>
       </p:sp>
@@ -2166,38 +2165,37 @@
           <a:p>
             <a:pPr lvl="0"/>
             <a:r>
-              <a:rPr lang="en-US" smtClean="0"/>
+              <a:rPr lang="en-US"/>
               <a:t>Click to edit Master text styles</a:t>
             </a:r>
           </a:p>
           <a:p>
             <a:pPr lvl="1"/>
             <a:r>
-              <a:rPr lang="en-US" smtClean="0"/>
+              <a:rPr lang="en-US"/>
               <a:t>Second level</a:t>
             </a:r>
           </a:p>
           <a:p>
             <a:pPr lvl="2"/>
             <a:r>
-              <a:rPr lang="en-US" smtClean="0"/>
+              <a:rPr lang="en-US"/>
               <a:t>Third level</a:t>
             </a:r>
           </a:p>
           <a:p>
             <a:pPr lvl="3"/>
             <a:r>
-              <a:rPr lang="en-US" smtClean="0"/>
+              <a:rPr lang="en-US"/>
               <a:t>Fourth level</a:t>
             </a:r>
           </a:p>
           <a:p>
             <a:pPr lvl="4"/>
             <a:r>
-              <a:rPr lang="en-US" smtClean="0"/>
+              <a:rPr lang="en-US"/>
               <a:t>Fifth level</a:t>
             </a:r>
-            <a:endParaRPr lang="en-US"/>
           </a:p>
         </p:txBody>
       </p:sp>
@@ -2260,7 +2258,7 @@
           <a:p>
             <a:pPr lvl="0"/>
             <a:r>
-              <a:rPr lang="en-US" smtClean="0"/>
+              <a:rPr lang="en-US"/>
               <a:t>Click to edit Master text styles</a:t>
             </a:r>
           </a:p>
@@ -2283,7 +2281,7 @@
           <a:p>
             <a:fld id="{5BCAD085-E8A6-8845-BD4E-CB4CCA059FC4}" type="datetimeFigureOut">
               <a:rPr lang="en-US" smtClean="0"/>
-              <a:t>1/27/13</a:t>
+              <a:t>4/16/2026</a:t>
             </a:fld>
             <a:endParaRPr lang="en-US"/>
           </a:p>
@@ -2325,7 +2323,7 @@
           <a:p>
             <a:fld id="{C1FF6DA9-008F-8B48-92A6-B652298478BF}" type="slidenum">
               <a:rPr lang="en-US" smtClean="0"/>
-              <a:t>‹#›</a:t>
+              <a:t>‹Nº›</a:t>
             </a:fld>
             <a:endParaRPr lang="en-US"/>
           </a:p>
@@ -2386,10 +2384,9 @@
           </a:lstStyle>
           <a:p>
             <a:r>
-              <a:rPr lang="en-US" smtClean="0"/>
+              <a:rPr lang="en-US"/>
               <a:t>Click to edit Master title style</a:t>
             </a:r>
-            <a:endParaRPr lang="en-US"/>
           </a:p>
         </p:txBody>
       </p:sp>
@@ -2513,7 +2510,7 @@
           <a:p>
             <a:pPr lvl="0"/>
             <a:r>
-              <a:rPr lang="en-US" smtClean="0"/>
+              <a:rPr lang="en-US"/>
               <a:t>Click to edit Master text styles</a:t>
             </a:r>
           </a:p>
@@ -2536,7 +2533,7 @@
           <a:p>
             <a:fld id="{5BCAD085-E8A6-8845-BD4E-CB4CCA059FC4}" type="datetimeFigureOut">
               <a:rPr lang="en-US" smtClean="0"/>
-              <a:t>1/27/13</a:t>
+              <a:t>4/16/2026</a:t>
             </a:fld>
             <a:endParaRPr lang="en-US"/>
           </a:p>
@@ -2578,7 +2575,7 @@
           <a:p>
             <a:fld id="{C1FF6DA9-008F-8B48-92A6-B652298478BF}" type="slidenum">
               <a:rPr lang="en-US" smtClean="0"/>
-              <a:t>‹#›</a:t>
+              <a:t>‹Nº›</a:t>
             </a:fld>
             <a:endParaRPr lang="en-US"/>
           </a:p>
@@ -2645,10 +2642,9 @@
           <a:lstStyle/>
           <a:p>
             <a:r>
-              <a:rPr lang="en-US" smtClean="0"/>
+              <a:rPr lang="en-US"/>
               <a:t>Click to edit Master title style</a:t>
             </a:r>
-            <a:endParaRPr lang="en-US"/>
           </a:p>
         </p:txBody>
       </p:sp>
@@ -2679,38 +2675,37 @@
           <a:p>
             <a:pPr lvl="0"/>
             <a:r>
-              <a:rPr lang="en-US" smtClean="0"/>
+              <a:rPr lang="en-US"/>
               <a:t>Click to edit Master text styles</a:t>
             </a:r>
           </a:p>
           <a:p>
             <a:pPr lvl="1"/>
             <a:r>
-              <a:rPr lang="en-US" smtClean="0"/>
+              <a:rPr lang="en-US"/>
               <a:t>Second level</a:t>
             </a:r>
           </a:p>
           <a:p>
             <a:pPr lvl="2"/>
             <a:r>
-              <a:rPr lang="en-US" smtClean="0"/>
+              <a:rPr lang="en-US"/>
               <a:t>Third level</a:t>
             </a:r>
           </a:p>
           <a:p>
             <a:pPr lvl="3"/>
             <a:r>
-              <a:rPr lang="en-US" smtClean="0"/>
+              <a:rPr lang="en-US"/>
               <a:t>Fourth level</a:t>
             </a:r>
           </a:p>
           <a:p>
             <a:pPr lvl="4"/>
             <a:r>
-              <a:rPr lang="en-US" smtClean="0"/>
+              <a:rPr lang="en-US"/>
               <a:t>Fifth level</a:t>
             </a:r>
-            <a:endParaRPr lang="en-US"/>
           </a:p>
         </p:txBody>
       </p:sp>
@@ -2749,7 +2744,7 @@
           <a:p>
             <a:fld id="{5BCAD085-E8A6-8845-BD4E-CB4CCA059FC4}" type="datetimeFigureOut">
               <a:rPr lang="en-US" smtClean="0"/>
-              <a:t>1/27/13</a:t>
+              <a:t>4/16/2026</a:t>
             </a:fld>
             <a:endParaRPr lang="en-US"/>
           </a:p>
@@ -2827,7 +2822,7 @@
           <a:p>
             <a:fld id="{C1FF6DA9-008F-8B48-92A6-B652298478BF}" type="slidenum">
               <a:rPr lang="en-US" smtClean="0"/>
-              <a:t>‹#›</a:t>
+              <a:t>‹Nº›</a:t>
             </a:fld>
             <a:endParaRPr lang="en-US"/>
           </a:p>
@@ -3108,7 +3103,7 @@
 </file>
 
 <file path=ppt/slides/slide1.xml><?xml version="1.0" encoding="utf-8"?>
-<p:sld xmlns:a="http://schemas.openxmlformats.org/drawingml/2006/main" xmlns:p="http://schemas.openxmlformats.org/presentationml/2006/main" xmlns:r="http://schemas.openxmlformats.org/officeDocument/2006/relationships">
+<p:sld xmlns:a="http://schemas.openxmlformats.org/drawingml/2006/main" xmlns:r="http://schemas.openxmlformats.org/officeDocument/2006/relationships" xmlns:p="http://schemas.openxmlformats.org/presentationml/2006/main">
   <p:cSld>
     <p:spTree>
       <p:nvGrpSpPr>
@@ -3116,7 +3111,14 @@
         <p:cNvGrpSpPr/>
         <p:nvPr/>
       </p:nvGrpSpPr>
-      <p:grpSpPr/>
+      <p:grpSpPr>
+        <a:xfrm>
+          <a:off x="0" y="0"/>
+          <a:ext cx="0" cy="0"/>
+          <a:chOff x="0" y="0"/>
+          <a:chExt cx="0" cy="0"/>
+        </a:xfrm>
+      </p:grpSpPr>
       <p:sp>
         <p:nvSpPr>
           <p:cNvPr id="2" name="Rectangle 1"/>
@@ -3157,6 +3159,7 @@
           <a:lstStyle/>
           <a:p>
             <a:pPr algn="ctr"/>
+            <a:endParaRPr/>
           </a:p>
         </p:txBody>
       </p:sp>
@@ -3200,6 +3203,7 @@
           <a:lstStyle/>
           <a:p>
             <a:pPr algn="ctr"/>
+            <a:endParaRPr/>
           </a:p>
         </p:txBody>
       </p:sp>
@@ -3322,7 +3326,7 @@
 </file>
 
 <file path=ppt/slides/slide10.xml><?xml version="1.0" encoding="utf-8"?>
-<p:sld xmlns:a="http://schemas.openxmlformats.org/drawingml/2006/main" xmlns:p="http://schemas.openxmlformats.org/presentationml/2006/main" xmlns:r="http://schemas.openxmlformats.org/officeDocument/2006/relationships">
+<p:sld xmlns:a="http://schemas.openxmlformats.org/drawingml/2006/main" xmlns:r="http://schemas.openxmlformats.org/officeDocument/2006/relationships" xmlns:p="http://schemas.openxmlformats.org/presentationml/2006/main">
   <p:cSld>
     <p:spTree>
       <p:nvGrpSpPr>
@@ -3330,7 +3334,14 @@
         <p:cNvGrpSpPr/>
         <p:nvPr/>
       </p:nvGrpSpPr>
-      <p:grpSpPr/>
+      <p:grpSpPr>
+        <a:xfrm>
+          <a:off x="0" y="0"/>
+          <a:ext cx="0" cy="0"/>
+          <a:chOff x="0" y="0"/>
+          <a:chExt cx="0" cy="0"/>
+        </a:xfrm>
+      </p:grpSpPr>
       <p:sp>
         <p:nvSpPr>
           <p:cNvPr id="2" name="Rectangle 1"/>
@@ -3371,6 +3382,7 @@
           <a:lstStyle/>
           <a:p>
             <a:pPr algn="ctr"/>
+            <a:endParaRPr/>
           </a:p>
         </p:txBody>
       </p:sp>
@@ -3448,197 +3460,40 @@
           <a:lstStyle/>
           <a:p>
             <a:pPr algn="ctr"/>
-          </a:p>
-        </p:txBody>
-      </p:sp>
-      <p:sp>
-        <p:nvSpPr>
-          <p:cNvPr id="5" name="Rectangle 4"/>
-          <p:cNvSpPr/>
+            <a:endParaRPr/>
+          </a:p>
+        </p:txBody>
+      </p:sp>
+      <p:pic>
+        <p:nvPicPr>
+          <p:cNvPr id="11" name="Imagen 10">
+            <a:extLst>
+              <a:ext uri="{FF2B5EF4-FFF2-40B4-BE49-F238E27FC236}">
+                <a16:creationId xmlns:a16="http://schemas.microsoft.com/office/drawing/2014/main" id="{F63444B4-0EE5-8545-279D-EE12A4F4D36A}"/>
+              </a:ext>
+            </a:extLst>
+          </p:cNvPr>
+          <p:cNvPicPr>
+            <a:picLocks noChangeAspect="1"/>
+          </p:cNvPicPr>
           <p:nvPr/>
-        </p:nvSpPr>
-        <p:spPr>
-          <a:xfrm>
-            <a:off x="1371600" y="1371600"/>
-            <a:ext cx="9418320" cy="4114800"/>
-          </a:xfrm>
-          <a:prstGeom prst="rect">
-            <a:avLst/>
-          </a:prstGeom>
-          <a:solidFill>
-            <a:srgbClr val="F2F2F2"/>
-          </a:solidFill>
-          <a:ln>
-            <a:noFill/>
-          </a:ln>
-        </p:spPr>
-        <p:style>
-          <a:lnRef idx="1">
-            <a:schemeClr val="accent1"/>
-          </a:lnRef>
-          <a:fillRef idx="3">
-            <a:schemeClr val="accent1"/>
-          </a:fillRef>
-          <a:effectRef idx="2">
-            <a:schemeClr val="accent1"/>
-          </a:effectRef>
-          <a:fontRef idx="minor">
-            <a:schemeClr val="lt1"/>
-          </a:fontRef>
-        </p:style>
-        <p:txBody>
-          <a:bodyPr rtlCol="0" anchor="ctr"/>
-          <a:lstStyle/>
-          <a:p>
-            <a:pPr algn="ctr"/>
-          </a:p>
-        </p:txBody>
-      </p:sp>
-      <p:sp>
-        <p:nvSpPr>
-          <p:cNvPr id="6" name="TextBox 5"/>
-          <p:cNvSpPr txBox="1"/>
-          <p:nvPr/>
-        </p:nvSpPr>
-        <p:spPr>
-          <a:xfrm>
-            <a:off x="1828800" y="2286000"/>
-            <a:ext cx="8503920" cy="1371600"/>
-          </a:xfrm>
-          <a:prstGeom prst="rect">
-            <a:avLst/>
-          </a:prstGeom>
-          <a:noFill/>
-        </p:spPr>
-        <p:txBody>
-          <a:bodyPr wrap="square"/>
-          <a:lstStyle/>
-          <a:p>
-            <a:pPr algn="ctr">
-              <a:defRPr sz="2400" b="0">
-                <a:solidFill>
-                  <a:srgbClr val="999999"/>
-                </a:solidFill>
-                <a:latin typeface="Calibri"/>
-              </a:defRPr>
-            </a:pPr>
-            <a:r>
-              <a:t>[Diagrama: Red T y Red B como infraestructura, Alastria ID como capa de identidad, miembros conectados]</a:t>
-            </a:r>
-          </a:p>
-        </p:txBody>
-      </p:sp>
-      <p:sp>
-        <p:nvSpPr>
-          <p:cNvPr id="7" name="Rectangle 6"/>
-          <p:cNvSpPr/>
-          <p:nvPr/>
-        </p:nvSpPr>
-        <p:spPr>
-          <a:xfrm>
-            <a:off x="1371600" y="3840480"/>
-            <a:ext cx="9418320" cy="320040"/>
-          </a:xfrm>
-          <a:prstGeom prst="rect">
-            <a:avLst/>
-          </a:prstGeom>
-          <a:solidFill>
-            <a:srgbClr val="7C3AED"/>
-          </a:solidFill>
-          <a:ln>
-            <a:noFill/>
-          </a:ln>
-        </p:spPr>
-        <p:style>
-          <a:lnRef idx="1">
-            <a:schemeClr val="accent1"/>
-          </a:lnRef>
-          <a:fillRef idx="3">
-            <a:schemeClr val="accent1"/>
-          </a:fillRef>
-          <a:effectRef idx="2">
-            <a:schemeClr val="accent1"/>
-          </a:effectRef>
-          <a:fontRef idx="minor">
-            <a:schemeClr val="lt1"/>
-          </a:fontRef>
-        </p:style>
-        <p:txBody>
-          <a:bodyPr rtlCol="0" anchor="ctr"/>
-          <a:lstStyle/>
-          <a:p>
-            <a:pPr algn="ctr"/>
-          </a:p>
-        </p:txBody>
-      </p:sp>
-      <p:sp>
-        <p:nvSpPr>
-          <p:cNvPr id="8" name="TextBox 7"/>
-          <p:cNvSpPr txBox="1"/>
-          <p:nvPr/>
-        </p:nvSpPr>
-        <p:spPr>
-          <a:xfrm>
-            <a:off x="1371600" y="3840480"/>
-            <a:ext cx="9418320" cy="320040"/>
-          </a:xfrm>
-          <a:prstGeom prst="rect">
-            <a:avLst/>
-          </a:prstGeom>
-          <a:noFill/>
-        </p:spPr>
-        <p:txBody>
-          <a:bodyPr wrap="square"/>
-          <a:lstStyle/>
-          <a:p>
-            <a:pPr algn="ctr">
-              <a:defRPr sz="1300" b="1">
-                <a:solidFill>
-                  <a:srgbClr val="FFFFFF"/>
-                </a:solidFill>
-                <a:latin typeface="Calibri"/>
-              </a:defRPr>
-            </a:pPr>
-            <a:r>
-              <a:t>Prompt para IA generativa:</a:t>
-            </a:r>
-          </a:p>
-        </p:txBody>
-      </p:sp>
-      <p:sp>
-        <p:nvSpPr>
-          <p:cNvPr id="9" name="TextBox 8"/>
-          <p:cNvSpPr txBox="1"/>
-          <p:nvPr/>
-        </p:nvSpPr>
-        <p:spPr>
-          <a:xfrm>
-            <a:off x="1645920" y="4297680"/>
-            <a:ext cx="8869680" cy="914400"/>
-          </a:xfrm>
-          <a:prstGeom prst="rect">
-            <a:avLst/>
-          </a:prstGeom>
-          <a:noFill/>
-        </p:spPr>
-        <p:txBody>
-          <a:bodyPr wrap="square"/>
-          <a:lstStyle/>
-          <a:p>
-            <a:pPr algn="l">
-              <a:defRPr sz="1400" b="0">
-                <a:solidFill>
-                  <a:srgbClr val="7C3AED"/>
-                </a:solidFill>
-                <a:latin typeface="Consolas"/>
-              </a:defRPr>
-            </a:pPr>
-            <a:r>
-              <a:t>Ecosystem diagram of Alastria consortium: two blockchain networks (Red T based on Quorum, Red B based on Hyperledger Besu) as infrastructure layer. Alastria ID as identity layer on top. Member organizations (banks, telcos, energy companies, universities) connected around the edges. Clean corporate style, Spanish flag colors accent.</a:t>
-            </a:r>
-          </a:p>
-        </p:txBody>
-      </p:sp>
+        </p:nvPicPr>
+        <p:blipFill>
+          <a:blip r:embed="rId2"/>
+          <a:stretch>
+            <a:fillRect/>
+          </a:stretch>
+        </p:blipFill>
+        <p:spPr>
+          <a:xfrm>
+            <a:off x="2491915" y="1463221"/>
+            <a:ext cx="7204994" cy="4894820"/>
+          </a:xfrm>
+          <a:prstGeom prst="rect">
+            <a:avLst/>
+          </a:prstGeom>
+        </p:spPr>
+      </p:pic>
     </p:spTree>
   </p:cSld>
   <p:clrMapOvr>
@@ -3648,7 +3503,7 @@
 </file>
 
 <file path=ppt/slides/slide11.xml><?xml version="1.0" encoding="utf-8"?>
-<p:sld xmlns:a="http://schemas.openxmlformats.org/drawingml/2006/main" xmlns:p="http://schemas.openxmlformats.org/presentationml/2006/main" xmlns:r="http://schemas.openxmlformats.org/officeDocument/2006/relationships">
+<p:sld xmlns:a="http://schemas.openxmlformats.org/drawingml/2006/main" xmlns:r="http://schemas.openxmlformats.org/officeDocument/2006/relationships" xmlns:p="http://schemas.openxmlformats.org/presentationml/2006/main">
   <p:cSld>
     <p:spTree>
       <p:nvGrpSpPr>
@@ -3656,7 +3511,14 @@
         <p:cNvGrpSpPr/>
         <p:nvPr/>
       </p:nvGrpSpPr>
-      <p:grpSpPr/>
+      <p:grpSpPr>
+        <a:xfrm>
+          <a:off x="0" y="0"/>
+          <a:ext cx="0" cy="0"/>
+          <a:chOff x="0" y="0"/>
+          <a:chExt cx="0" cy="0"/>
+        </a:xfrm>
+      </p:grpSpPr>
       <p:sp>
         <p:nvSpPr>
           <p:cNvPr id="2" name="Rectangle 1"/>
@@ -3697,6 +3559,7 @@
           <a:lstStyle/>
           <a:p>
             <a:pPr algn="ctr"/>
+            <a:endParaRPr/>
           </a:p>
         </p:txBody>
       </p:sp>
@@ -3774,6 +3637,7 @@
           <a:lstStyle/>
           <a:p>
             <a:pPr algn="ctr"/>
+            <a:endParaRPr/>
           </a:p>
         </p:txBody>
       </p:sp>
@@ -3969,7 +3833,7 @@
 </file>
 
 <file path=ppt/slides/slide12.xml><?xml version="1.0" encoding="utf-8"?>
-<p:sld xmlns:a="http://schemas.openxmlformats.org/drawingml/2006/main" xmlns:p="http://schemas.openxmlformats.org/presentationml/2006/main" xmlns:r="http://schemas.openxmlformats.org/officeDocument/2006/relationships">
+<p:sld xmlns:a="http://schemas.openxmlformats.org/drawingml/2006/main" xmlns:r="http://schemas.openxmlformats.org/officeDocument/2006/relationships" xmlns:p="http://schemas.openxmlformats.org/presentationml/2006/main">
   <p:cSld>
     <p:spTree>
       <p:nvGrpSpPr>
@@ -3977,7 +3841,14 @@
         <p:cNvGrpSpPr/>
         <p:nvPr/>
       </p:nvGrpSpPr>
-      <p:grpSpPr/>
+      <p:grpSpPr>
+        <a:xfrm>
+          <a:off x="0" y="0"/>
+          <a:ext cx="0" cy="0"/>
+          <a:chOff x="0" y="0"/>
+          <a:chExt cx="0" cy="0"/>
+        </a:xfrm>
+      </p:grpSpPr>
       <p:sp>
         <p:nvSpPr>
           <p:cNvPr id="2" name="Rectangle 1"/>
@@ -4018,6 +3889,7 @@
           <a:lstStyle/>
           <a:p>
             <a:pPr algn="ctr"/>
+            <a:endParaRPr/>
           </a:p>
         </p:txBody>
       </p:sp>
@@ -4095,6 +3967,7 @@
           <a:lstStyle/>
           <a:p>
             <a:pPr algn="ctr"/>
+            <a:endParaRPr/>
           </a:p>
         </p:txBody>
       </p:sp>
@@ -4226,7 +4099,7 @@
 </file>
 
 <file path=ppt/slides/slide13.xml><?xml version="1.0" encoding="utf-8"?>
-<p:sld xmlns:a="http://schemas.openxmlformats.org/drawingml/2006/main" xmlns:p="http://schemas.openxmlformats.org/presentationml/2006/main" xmlns:r="http://schemas.openxmlformats.org/officeDocument/2006/relationships">
+<p:sld xmlns:a="http://schemas.openxmlformats.org/drawingml/2006/main" xmlns:r="http://schemas.openxmlformats.org/officeDocument/2006/relationships" xmlns:p="http://schemas.openxmlformats.org/presentationml/2006/main">
   <p:cSld>
     <p:spTree>
       <p:nvGrpSpPr>
@@ -4234,7 +4107,14 @@
         <p:cNvGrpSpPr/>
         <p:nvPr/>
       </p:nvGrpSpPr>
-      <p:grpSpPr/>
+      <p:grpSpPr>
+        <a:xfrm>
+          <a:off x="0" y="0"/>
+          <a:ext cx="0" cy="0"/>
+          <a:chOff x="0" y="0"/>
+          <a:chExt cx="0" cy="0"/>
+        </a:xfrm>
+      </p:grpSpPr>
       <p:sp>
         <p:nvSpPr>
           <p:cNvPr id="2" name="Rectangle 1"/>
@@ -4275,6 +4155,7 @@
           <a:lstStyle/>
           <a:p>
             <a:pPr algn="ctr"/>
+            <a:endParaRPr/>
           </a:p>
         </p:txBody>
       </p:sp>
@@ -4352,6 +4233,7 @@
           <a:lstStyle/>
           <a:p>
             <a:pPr algn="ctr"/>
+            <a:endParaRPr/>
           </a:p>
         </p:txBody>
       </p:sp>
@@ -4484,6 +4366,7 @@
                 <a:latin typeface="Calibri"/>
               </a:defRPr>
             </a:pPr>
+            <a:endParaRPr/>
           </a:p>
           <a:p>
             <a:pPr>
@@ -4528,7 +4411,7 @@
 </file>
 
 <file path=ppt/slides/slide14.xml><?xml version="1.0" encoding="utf-8"?>
-<p:sld xmlns:a="http://schemas.openxmlformats.org/drawingml/2006/main" xmlns:p="http://schemas.openxmlformats.org/presentationml/2006/main" xmlns:r="http://schemas.openxmlformats.org/officeDocument/2006/relationships">
+<p:sld xmlns:a="http://schemas.openxmlformats.org/drawingml/2006/main" xmlns:r="http://schemas.openxmlformats.org/officeDocument/2006/relationships" xmlns:p="http://schemas.openxmlformats.org/presentationml/2006/main">
   <p:cSld>
     <p:spTree>
       <p:nvGrpSpPr>
@@ -4536,7 +4419,14 @@
         <p:cNvGrpSpPr/>
         <p:nvPr/>
       </p:nvGrpSpPr>
-      <p:grpSpPr/>
+      <p:grpSpPr>
+        <a:xfrm>
+          <a:off x="0" y="0"/>
+          <a:ext cx="0" cy="0"/>
+          <a:chOff x="0" y="0"/>
+          <a:chExt cx="0" cy="0"/>
+        </a:xfrm>
+      </p:grpSpPr>
       <p:sp>
         <p:nvSpPr>
           <p:cNvPr id="2" name="Rectangle 1"/>
@@ -4577,6 +4467,7 @@
           <a:lstStyle/>
           <a:p>
             <a:pPr algn="ctr"/>
+            <a:endParaRPr/>
           </a:p>
         </p:txBody>
       </p:sp>
@@ -4620,6 +4511,7 @@
           <a:lstStyle/>
           <a:p>
             <a:pPr algn="ctr"/>
+            <a:endParaRPr/>
           </a:p>
         </p:txBody>
       </p:sp>
@@ -4731,6 +4623,7 @@
           <a:lstStyle/>
           <a:p>
             <a:pPr algn="ctr"/>
+            <a:endParaRPr/>
           </a:p>
         </p:txBody>
       </p:sp>
@@ -4783,6 +4676,7 @@
                 <a:latin typeface="Calibri"/>
               </a:defRPr>
             </a:pPr>
+            <a:endParaRPr/>
           </a:p>
           <a:p>
             <a:pPr>
@@ -4892,6 +4786,7 @@
                 <a:latin typeface="Calibri"/>
               </a:defRPr>
             </a:pPr>
+            <a:endParaRPr/>
           </a:p>
           <a:p>
             <a:pPr>
@@ -4920,7 +4815,7 @@
 </file>
 
 <file path=ppt/slides/slide15.xml><?xml version="1.0" encoding="utf-8"?>
-<p:sld xmlns:a="http://schemas.openxmlformats.org/drawingml/2006/main" xmlns:p="http://schemas.openxmlformats.org/presentationml/2006/main" xmlns:r="http://schemas.openxmlformats.org/officeDocument/2006/relationships">
+<p:sld xmlns:a="http://schemas.openxmlformats.org/drawingml/2006/main" xmlns:r="http://schemas.openxmlformats.org/officeDocument/2006/relationships" xmlns:p="http://schemas.openxmlformats.org/presentationml/2006/main">
   <p:cSld>
     <p:spTree>
       <p:nvGrpSpPr>
@@ -4928,7 +4823,14 @@
         <p:cNvGrpSpPr/>
         <p:nvPr/>
       </p:nvGrpSpPr>
-      <p:grpSpPr/>
+      <p:grpSpPr>
+        <a:xfrm>
+          <a:off x="0" y="0"/>
+          <a:ext cx="0" cy="0"/>
+          <a:chOff x="0" y="0"/>
+          <a:chExt cx="0" cy="0"/>
+        </a:xfrm>
+      </p:grpSpPr>
       <p:sp>
         <p:nvSpPr>
           <p:cNvPr id="2" name="Rectangle 1"/>
@@ -4969,6 +4871,7 @@
           <a:lstStyle/>
           <a:p>
             <a:pPr algn="ctr"/>
+            <a:endParaRPr/>
           </a:p>
         </p:txBody>
       </p:sp>
@@ -5046,6 +4949,7 @@
           <a:lstStyle/>
           <a:p>
             <a:pPr algn="ctr"/>
+            <a:endParaRPr/>
           </a:p>
         </p:txBody>
       </p:sp>
@@ -5058,7 +4962,7 @@
         <p:spPr>
           <a:xfrm>
             <a:off x="640080" y="1280160"/>
-            <a:ext cx="10515600" cy="5029200"/>
+            <a:ext cx="10515600" cy="4524315"/>
           </a:xfrm>
           <a:prstGeom prst="rect">
             <a:avLst/>
@@ -5083,7 +4987,40 @@
               </a:defRPr>
             </a:pPr>
             <a:r>
-              <a:t>1. Alex Puig, CTO de Everis (ahora NTT Data) y primer presidente de Alastria.</a:t>
+              <a:rPr sz="1600" dirty="0"/>
+              <a:t>1. Alex Puig, CTO de </a:t>
+            </a:r>
+            <a:r>
+              <a:rPr sz="1600" dirty="0" err="1"/>
+              <a:t>Everis</a:t>
+            </a:r>
+            <a:r>
+              <a:rPr sz="1600" dirty="0"/>
+              <a:t> (</a:t>
+            </a:r>
+            <a:r>
+              <a:rPr sz="1600" dirty="0" err="1"/>
+              <a:t>ahora</a:t>
+            </a:r>
+            <a:r>
+              <a:rPr sz="1600" dirty="0"/>
+              <a:t> NTT Data) y primer </a:t>
+            </a:r>
+            <a:r>
+              <a:rPr sz="1600" dirty="0" err="1"/>
+              <a:t>presidente</a:t>
+            </a:r>
+            <a:r>
+              <a:rPr sz="1600" dirty="0"/>
+              <a:t> de </a:t>
+            </a:r>
+            <a:r>
+              <a:rPr sz="1600" dirty="0" err="1"/>
+              <a:t>Alastria</a:t>
+            </a:r>
+            <a:r>
+              <a:rPr sz="1600" dirty="0"/>
+              <a:t>.</a:t>
             </a:r>
           </a:p>
           <a:p>
@@ -5099,7 +5036,56 @@
               </a:defRPr>
             </a:pPr>
             <a:r>
-              <a:t>   Impulso la creacion del consorcio junto con otros directivos del sector fintech y blockchain espanol.</a:t>
+              <a:rPr sz="1600" dirty="0"/>
+              <a:t>   </a:t>
+            </a:r>
+            <a:r>
+              <a:rPr sz="1600" dirty="0" err="1"/>
+              <a:t>Impulso</a:t>
+            </a:r>
+            <a:r>
+              <a:rPr sz="1600" dirty="0"/>
+              <a:t> la </a:t>
+            </a:r>
+            <a:r>
+              <a:rPr sz="1600" dirty="0" err="1"/>
+              <a:t>creacion</a:t>
+            </a:r>
+            <a:r>
+              <a:rPr sz="1600" dirty="0"/>
+              <a:t> del </a:t>
+            </a:r>
+            <a:r>
+              <a:rPr sz="1600" dirty="0" err="1"/>
+              <a:t>consorcio</a:t>
+            </a:r>
+            <a:r>
+              <a:rPr sz="1600" dirty="0"/>
+              <a:t> junto con </a:t>
+            </a:r>
+            <a:r>
+              <a:rPr sz="1600" dirty="0" err="1"/>
+              <a:t>otros</a:t>
+            </a:r>
+            <a:r>
+              <a:rPr sz="1600" dirty="0"/>
+              <a:t> </a:t>
+            </a:r>
+            <a:r>
+              <a:rPr sz="1600" dirty="0" err="1"/>
+              <a:t>directivos</a:t>
+            </a:r>
+            <a:r>
+              <a:rPr sz="1600" dirty="0"/>
+              <a:t> del sector fintech y blockchain </a:t>
+            </a:r>
+            <a:r>
+              <a:rPr sz="1600" dirty="0" err="1"/>
+              <a:t>espanol</a:t>
+            </a:r>
+            <a:r>
+              <a:rPr sz="1600" dirty="0"/>
+              <a:t>.</a:t>
             </a:r>
           </a:p>
           <a:p>
@@ -5114,6 +5100,7 @@
                 <a:latin typeface="Calibri"/>
               </a:defRPr>
             </a:pPr>
+            <a:endParaRPr sz="1600" dirty="0"/>
           </a:p>
           <a:p>
             <a:pPr>
@@ -5128,7 +5115,40 @@
               </a:defRPr>
             </a:pPr>
             <a:r>
-              <a:t>2. Se presento en el Mobile World Congress (MWC) de Barcelona en 2017.</a:t>
+              <a:rPr sz="1600" dirty="0"/>
+              <a:t>2. Se </a:t>
+            </a:r>
+            <a:r>
+              <a:rPr sz="1600" dirty="0" err="1"/>
+              <a:t>presento</a:t>
+            </a:r>
+            <a:r>
+              <a:rPr sz="1600" dirty="0"/>
+              <a:t> </a:t>
+            </a:r>
+            <a:r>
+              <a:rPr sz="1600" dirty="0" err="1"/>
+              <a:t>en</a:t>
+            </a:r>
+            <a:r>
+              <a:rPr sz="1600" dirty="0"/>
+              <a:t> </a:t>
+            </a:r>
+            <a:r>
+              <a:rPr sz="1600" dirty="0" err="1"/>
+              <a:t>el</a:t>
+            </a:r>
+            <a:r>
+              <a:rPr sz="1600" dirty="0"/>
+              <a:t> Mobile World Congress (MWC) de Barcelona </a:t>
+            </a:r>
+            <a:r>
+              <a:rPr sz="1600" dirty="0" err="1"/>
+              <a:t>en</a:t>
+            </a:r>
+            <a:r>
+              <a:rPr sz="1600" dirty="0"/>
+              <a:t> 2017.</a:t>
             </a:r>
           </a:p>
           <a:p>
@@ -5143,6 +5163,7 @@
                 <a:latin typeface="Calibri"/>
               </a:defRPr>
             </a:pPr>
+            <a:endParaRPr sz="1600" dirty="0"/>
           </a:p>
           <a:p>
             <a:pPr>
@@ -5157,7 +5178,48 @@
               </a:defRPr>
             </a:pPr>
             <a:r>
-              <a:t>3. Alastria se fundo con 70 miembros fundadores en 2017.</a:t>
+              <a:rPr sz="1600" dirty="0"/>
+              <a:t>3. </a:t>
+            </a:r>
+            <a:r>
+              <a:rPr sz="1600" dirty="0" err="1"/>
+              <a:t>Alastria</a:t>
+            </a:r>
+            <a:r>
+              <a:rPr sz="1600" dirty="0"/>
+              <a:t> se </a:t>
+            </a:r>
+            <a:r>
+              <a:rPr sz="1600" dirty="0" err="1"/>
+              <a:t>fundo</a:t>
+            </a:r>
+            <a:r>
+              <a:rPr sz="1600" dirty="0"/>
+              <a:t> con 70 </a:t>
+            </a:r>
+            <a:r>
+              <a:rPr sz="1600" dirty="0" err="1"/>
+              <a:t>miembros</a:t>
+            </a:r>
+            <a:r>
+              <a:rPr sz="1600" dirty="0"/>
+              <a:t> </a:t>
+            </a:r>
+            <a:r>
+              <a:rPr sz="1600" dirty="0" err="1"/>
+              <a:t>fundadores</a:t>
+            </a:r>
+            <a:r>
+              <a:rPr sz="1600" dirty="0"/>
+              <a:t> </a:t>
+            </a:r>
+            <a:r>
+              <a:rPr sz="1600" dirty="0" err="1"/>
+              <a:t>en</a:t>
+            </a:r>
+            <a:r>
+              <a:rPr sz="1600" dirty="0"/>
+              <a:t> 2017.</a:t>
             </a:r>
           </a:p>
           <a:p>
@@ -5173,7 +5235,40 @@
               </a:defRPr>
             </a:pPr>
             <a:r>
-              <a:t>   Actualmente cuenta con mas de 500 entidades miembro.</a:t>
+              <a:rPr sz="1600" dirty="0"/>
+              <a:t>   </a:t>
+            </a:r>
+            <a:r>
+              <a:rPr sz="1600" dirty="0" err="1"/>
+              <a:t>Actualmente</a:t>
+            </a:r>
+            <a:r>
+              <a:rPr sz="1600" dirty="0"/>
+              <a:t> </a:t>
+            </a:r>
+            <a:r>
+              <a:rPr sz="1600" dirty="0" err="1"/>
+              <a:t>cuenta</a:t>
+            </a:r>
+            <a:r>
+              <a:rPr sz="1600" dirty="0"/>
+              <a:t> con mas de 500 </a:t>
+            </a:r>
+            <a:r>
+              <a:rPr sz="1600" dirty="0" err="1"/>
+              <a:t>entidades</a:t>
+            </a:r>
+            <a:r>
+              <a:rPr sz="1600" dirty="0"/>
+              <a:t> </a:t>
+            </a:r>
+            <a:r>
+              <a:rPr sz="1600" dirty="0" err="1"/>
+              <a:t>miembro</a:t>
+            </a:r>
+            <a:r>
+              <a:rPr sz="1600" dirty="0"/>
+              <a:t>.</a:t>
             </a:r>
           </a:p>
           <a:p>
@@ -5188,6 +5283,7 @@
                 <a:latin typeface="Calibri"/>
               </a:defRPr>
             </a:pPr>
+            <a:endParaRPr sz="1600" dirty="0"/>
           </a:p>
           <a:p>
             <a:pPr>
@@ -5202,7 +5298,40 @@
               </a:defRPr>
             </a:pPr>
             <a:r>
-              <a:t>4. Espana, a traves de Alastria y otros actores, es miembro de la</a:t>
+              <a:rPr sz="1600" dirty="0"/>
+              <a:t>4. Espana, a traves de </a:t>
+            </a:r>
+            <a:r>
+              <a:rPr sz="1600" dirty="0" err="1"/>
+              <a:t>Alastria</a:t>
+            </a:r>
+            <a:r>
+              <a:rPr sz="1600" dirty="0"/>
+              <a:t> y </a:t>
+            </a:r>
+            <a:r>
+              <a:rPr sz="1600" dirty="0" err="1"/>
+              <a:t>otros</a:t>
+            </a:r>
+            <a:r>
+              <a:rPr sz="1600" dirty="0"/>
+              <a:t> </a:t>
+            </a:r>
+            <a:r>
+              <a:rPr sz="1600" dirty="0" err="1"/>
+              <a:t>actores</a:t>
+            </a:r>
+            <a:r>
+              <a:rPr sz="1600" dirty="0"/>
+              <a:t>, es </a:t>
+            </a:r>
+            <a:r>
+              <a:rPr sz="1600" dirty="0" err="1"/>
+              <a:t>miembro</a:t>
+            </a:r>
+            <a:r>
+              <a:rPr sz="1600" dirty="0"/>
+              <a:t> de la</a:t>
             </a:r>
           </a:p>
           <a:p>
@@ -5218,8 +5347,30 @@
               </a:defRPr>
             </a:pPr>
             <a:r>
-              <a:t>   European Blockchain Partnership (EBP) desde 2018. Alastria colabora</a:t>
-            </a:r>
+              <a:rPr sz="1600" dirty="0"/>
+              <a:t>   European Blockchain Partnership (EBP) </a:t>
+            </a:r>
+            <a:r>
+              <a:rPr sz="1600" dirty="0" err="1"/>
+              <a:t>desde</a:t>
+            </a:r>
+            <a:r>
+              <a:rPr sz="1600" dirty="0"/>
+              <a:t> 2018. </a:t>
+            </a:r>
+            <a:r>
+              <a:rPr sz="1600" dirty="0" err="1"/>
+              <a:t>Alastria</a:t>
+            </a:r>
+            <a:r>
+              <a:rPr sz="1600" dirty="0"/>
+              <a:t> </a:t>
+            </a:r>
+            <a:r>
+              <a:rPr sz="1600" dirty="0" err="1"/>
+              <a:t>colabora</a:t>
+            </a:r>
+            <a:endParaRPr sz="1600" dirty="0"/>
           </a:p>
           <a:p>
             <a:pPr>
@@ -5234,8 +5385,38 @@
               </a:defRPr>
             </a:pPr>
             <a:r>
-              <a:t>   con EBSI compartiendo estandares de identidad (DID/VC) y participando</a:t>
-            </a:r>
+              <a:rPr sz="1600" dirty="0"/>
+              <a:t>   con EBSI </a:t>
+            </a:r>
+            <a:r>
+              <a:rPr sz="1600" dirty="0" err="1"/>
+              <a:t>compartiendo</a:t>
+            </a:r>
+            <a:r>
+              <a:rPr sz="1600" dirty="0"/>
+              <a:t> </a:t>
+            </a:r>
+            <a:r>
+              <a:rPr sz="1600" dirty="0" err="1"/>
+              <a:t>estandares</a:t>
+            </a:r>
+            <a:r>
+              <a:rPr sz="1600" dirty="0"/>
+              <a:t> de </a:t>
+            </a:r>
+            <a:r>
+              <a:rPr sz="1600" dirty="0" err="1"/>
+              <a:t>identidad</a:t>
+            </a:r>
+            <a:r>
+              <a:rPr sz="1600" dirty="0"/>
+              <a:t> (DID/VC) y </a:t>
+            </a:r>
+            <a:r>
+              <a:rPr sz="1600" dirty="0" err="1"/>
+              <a:t>participando</a:t>
+            </a:r>
+            <a:endParaRPr sz="1600" dirty="0"/>
           </a:p>
           <a:p>
             <a:pPr>
@@ -5250,8 +5431,54 @@
               </a:defRPr>
             </a:pPr>
             <a:r>
-              <a:t>   en los pilotos europeos. La Red B (Hyperledger Besu) esta alineada</a:t>
-            </a:r>
+              <a:rPr sz="1600" dirty="0"/>
+              <a:t>   </a:t>
+            </a:r>
+            <a:r>
+              <a:rPr sz="1600" dirty="0" err="1"/>
+              <a:t>en</a:t>
+            </a:r>
+            <a:r>
+              <a:rPr sz="1600" dirty="0"/>
+              <a:t> </a:t>
+            </a:r>
+            <a:r>
+              <a:rPr sz="1600" dirty="0" err="1"/>
+              <a:t>los</a:t>
+            </a:r>
+            <a:r>
+              <a:rPr sz="1600" dirty="0"/>
+              <a:t> </a:t>
+            </a:r>
+            <a:r>
+              <a:rPr sz="1600" dirty="0" err="1"/>
+              <a:t>pilotos</a:t>
+            </a:r>
+            <a:r>
+              <a:rPr sz="1600" dirty="0"/>
+              <a:t> </a:t>
+            </a:r>
+            <a:r>
+              <a:rPr sz="1600" dirty="0" err="1"/>
+              <a:t>europeos</a:t>
+            </a:r>
+            <a:r>
+              <a:rPr sz="1600" dirty="0"/>
+              <a:t>. La Red B (Hyperledger Besu) </a:t>
+            </a:r>
+            <a:r>
+              <a:rPr sz="1600" dirty="0" err="1"/>
+              <a:t>esta</a:t>
+            </a:r>
+            <a:r>
+              <a:rPr sz="1600" dirty="0"/>
+              <a:t> </a:t>
+            </a:r>
+            <a:r>
+              <a:rPr sz="1600" dirty="0" err="1"/>
+              <a:t>alineada</a:t>
+            </a:r>
+            <a:endParaRPr sz="1600" dirty="0"/>
           </a:p>
           <a:p>
             <a:pPr>
@@ -5266,7 +5493,32 @@
               </a:defRPr>
             </a:pPr>
             <a:r>
-              <a:t>   tecnologicamente con EBSI para facilitar la interoperabilidad.</a:t>
+              <a:rPr sz="1600" dirty="0"/>
+              <a:t>   </a:t>
+            </a:r>
+            <a:r>
+              <a:rPr sz="1600" dirty="0" err="1"/>
+              <a:t>tecnologicamente</a:t>
+            </a:r>
+            <a:r>
+              <a:rPr sz="1600" dirty="0"/>
+              <a:t> con EBSI para </a:t>
+            </a:r>
+            <a:r>
+              <a:rPr sz="1600" dirty="0" err="1"/>
+              <a:t>facilitar</a:t>
+            </a:r>
+            <a:r>
+              <a:rPr sz="1600" dirty="0"/>
+              <a:t> la </a:t>
+            </a:r>
+            <a:r>
+              <a:rPr sz="1600" dirty="0" err="1"/>
+              <a:t>interoperabilidad</a:t>
+            </a:r>
+            <a:r>
+              <a:rPr sz="1600" dirty="0"/>
+              <a:t>.</a:t>
             </a:r>
           </a:p>
         </p:txBody>
@@ -5280,7 +5532,7 @@
 </file>
 
 <file path=ppt/slides/slide16.xml><?xml version="1.0" encoding="utf-8"?>
-<p:sld xmlns:a="http://schemas.openxmlformats.org/drawingml/2006/main" xmlns:p="http://schemas.openxmlformats.org/presentationml/2006/main" xmlns:r="http://schemas.openxmlformats.org/officeDocument/2006/relationships">
+<p:sld xmlns:a="http://schemas.openxmlformats.org/drawingml/2006/main" xmlns:r="http://schemas.openxmlformats.org/officeDocument/2006/relationships" xmlns:p="http://schemas.openxmlformats.org/presentationml/2006/main">
   <p:cSld>
     <p:spTree>
       <p:nvGrpSpPr>
@@ -5288,7 +5540,14 @@
         <p:cNvGrpSpPr/>
         <p:nvPr/>
       </p:nvGrpSpPr>
-      <p:grpSpPr/>
+      <p:grpSpPr>
+        <a:xfrm>
+          <a:off x="0" y="0"/>
+          <a:ext cx="0" cy="0"/>
+          <a:chOff x="0" y="0"/>
+          <a:chExt cx="0" cy="0"/>
+        </a:xfrm>
+      </p:grpSpPr>
       <p:sp>
         <p:nvSpPr>
           <p:cNvPr id="2" name="Rectangle 1"/>
@@ -5329,6 +5588,7 @@
           <a:lstStyle/>
           <a:p>
             <a:pPr algn="ctr"/>
+            <a:endParaRPr/>
           </a:p>
         </p:txBody>
       </p:sp>
@@ -5413,7 +5673,7 @@
 </file>
 
 <file path=ppt/slides/slide17.xml><?xml version="1.0" encoding="utf-8"?>
-<p:sld xmlns:a="http://schemas.openxmlformats.org/drawingml/2006/main" xmlns:p="http://schemas.openxmlformats.org/presentationml/2006/main" xmlns:r="http://schemas.openxmlformats.org/officeDocument/2006/relationships">
+<p:sld xmlns:a="http://schemas.openxmlformats.org/drawingml/2006/main" xmlns:r="http://schemas.openxmlformats.org/officeDocument/2006/relationships" xmlns:p="http://schemas.openxmlformats.org/presentationml/2006/main">
   <p:cSld>
     <p:spTree>
       <p:nvGrpSpPr>
@@ -5421,7 +5681,14 @@
         <p:cNvGrpSpPr/>
         <p:nvPr/>
       </p:nvGrpSpPr>
-      <p:grpSpPr/>
+      <p:grpSpPr>
+        <a:xfrm>
+          <a:off x="0" y="0"/>
+          <a:ext cx="0" cy="0"/>
+          <a:chOff x="0" y="0"/>
+          <a:chExt cx="0" cy="0"/>
+        </a:xfrm>
+      </p:grpSpPr>
       <p:sp>
         <p:nvSpPr>
           <p:cNvPr id="2" name="Rectangle 1"/>
@@ -5462,6 +5729,7 @@
           <a:lstStyle/>
           <a:p>
             <a:pPr algn="ctr"/>
+            <a:endParaRPr/>
           </a:p>
         </p:txBody>
       </p:sp>
@@ -5539,6 +5807,7 @@
           <a:lstStyle/>
           <a:p>
             <a:pPr algn="ctr"/>
+            <a:endParaRPr/>
           </a:p>
         </p:txBody>
       </p:sp>
@@ -5734,7 +6003,7 @@
 </file>
 
 <file path=ppt/slides/slide18.xml><?xml version="1.0" encoding="utf-8"?>
-<p:sld xmlns:a="http://schemas.openxmlformats.org/drawingml/2006/main" xmlns:p="http://schemas.openxmlformats.org/presentationml/2006/main" xmlns:r="http://schemas.openxmlformats.org/officeDocument/2006/relationships">
+<p:sld xmlns:a="http://schemas.openxmlformats.org/drawingml/2006/main" xmlns:r="http://schemas.openxmlformats.org/officeDocument/2006/relationships" xmlns:p="http://schemas.openxmlformats.org/presentationml/2006/main">
   <p:cSld>
     <p:spTree>
       <p:nvGrpSpPr>
@@ -5742,7 +6011,14 @@
         <p:cNvGrpSpPr/>
         <p:nvPr/>
       </p:nvGrpSpPr>
-      <p:grpSpPr/>
+      <p:grpSpPr>
+        <a:xfrm>
+          <a:off x="0" y="0"/>
+          <a:ext cx="0" cy="0"/>
+          <a:chOff x="0" y="0"/>
+          <a:chExt cx="0" cy="0"/>
+        </a:xfrm>
+      </p:grpSpPr>
       <p:sp>
         <p:nvSpPr>
           <p:cNvPr id="2" name="Rectangle 1"/>
@@ -5783,6 +6059,7 @@
           <a:lstStyle/>
           <a:p>
             <a:pPr algn="ctr"/>
+            <a:endParaRPr/>
           </a:p>
         </p:txBody>
       </p:sp>
@@ -5860,6 +6137,7 @@
           <a:lstStyle/>
           <a:p>
             <a:pPr algn="ctr"/>
+            <a:endParaRPr/>
           </a:p>
         </p:txBody>
       </p:sp>
@@ -6055,7 +6333,7 @@
 </file>
 
 <file path=ppt/slides/slide19.xml><?xml version="1.0" encoding="utf-8"?>
-<p:sld xmlns:a="http://schemas.openxmlformats.org/drawingml/2006/main" xmlns:p="http://schemas.openxmlformats.org/presentationml/2006/main" xmlns:r="http://schemas.openxmlformats.org/officeDocument/2006/relationships">
+<p:sld xmlns:a="http://schemas.openxmlformats.org/drawingml/2006/main" xmlns:r="http://schemas.openxmlformats.org/officeDocument/2006/relationships" xmlns:p="http://schemas.openxmlformats.org/presentationml/2006/main">
   <p:cSld>
     <p:spTree>
       <p:nvGrpSpPr>
@@ -6063,7 +6341,14 @@
         <p:cNvGrpSpPr/>
         <p:nvPr/>
       </p:nvGrpSpPr>
-      <p:grpSpPr/>
+      <p:grpSpPr>
+        <a:xfrm>
+          <a:off x="0" y="0"/>
+          <a:ext cx="0" cy="0"/>
+          <a:chOff x="0" y="0"/>
+          <a:chExt cx="0" cy="0"/>
+        </a:xfrm>
+      </p:grpSpPr>
       <p:sp>
         <p:nvSpPr>
           <p:cNvPr id="2" name="Rectangle 1"/>
@@ -6104,6 +6389,7 @@
           <a:lstStyle/>
           <a:p>
             <a:pPr algn="ctr"/>
+            <a:endParaRPr/>
           </a:p>
         </p:txBody>
       </p:sp>
@@ -6181,6 +6467,7 @@
           <a:lstStyle/>
           <a:p>
             <a:pPr algn="ctr"/>
+            <a:endParaRPr/>
           </a:p>
         </p:txBody>
       </p:sp>
@@ -6360,7 +6647,7 @@
 </file>
 
 <file path=ppt/slides/slide2.xml><?xml version="1.0" encoding="utf-8"?>
-<p:sld xmlns:a="http://schemas.openxmlformats.org/drawingml/2006/main" xmlns:p="http://schemas.openxmlformats.org/presentationml/2006/main" xmlns:r="http://schemas.openxmlformats.org/officeDocument/2006/relationships">
+<p:sld xmlns:a="http://schemas.openxmlformats.org/drawingml/2006/main" xmlns:r="http://schemas.openxmlformats.org/officeDocument/2006/relationships" xmlns:p="http://schemas.openxmlformats.org/presentationml/2006/main">
   <p:cSld>
     <p:spTree>
       <p:nvGrpSpPr>
@@ -6368,7 +6655,14 @@
         <p:cNvGrpSpPr/>
         <p:nvPr/>
       </p:nvGrpSpPr>
-      <p:grpSpPr/>
+      <p:grpSpPr>
+        <a:xfrm>
+          <a:off x="0" y="0"/>
+          <a:ext cx="0" cy="0"/>
+          <a:chOff x="0" y="0"/>
+          <a:chExt cx="0" cy="0"/>
+        </a:xfrm>
+      </p:grpSpPr>
       <p:sp>
         <p:nvSpPr>
           <p:cNvPr id="2" name="Rectangle 1"/>
@@ -6409,6 +6703,7 @@
           <a:lstStyle/>
           <a:p>
             <a:pPr algn="ctr"/>
+            <a:endParaRPr/>
           </a:p>
         </p:txBody>
       </p:sp>
@@ -6497,7 +6792,7 @@
 </file>
 
 <file path=ppt/slides/slide20.xml><?xml version="1.0" encoding="utf-8"?>
-<p:sld xmlns:a="http://schemas.openxmlformats.org/drawingml/2006/main" xmlns:p="http://schemas.openxmlformats.org/presentationml/2006/main" xmlns:r="http://schemas.openxmlformats.org/officeDocument/2006/relationships">
+<p:sld xmlns:a="http://schemas.openxmlformats.org/drawingml/2006/main" xmlns:r="http://schemas.openxmlformats.org/officeDocument/2006/relationships" xmlns:p="http://schemas.openxmlformats.org/presentationml/2006/main">
   <p:cSld>
     <p:spTree>
       <p:nvGrpSpPr>
@@ -6505,7 +6800,14 @@
         <p:cNvGrpSpPr/>
         <p:nvPr/>
       </p:nvGrpSpPr>
-      <p:grpSpPr/>
+      <p:grpSpPr>
+        <a:xfrm>
+          <a:off x="0" y="0"/>
+          <a:ext cx="0" cy="0"/>
+          <a:chOff x="0" y="0"/>
+          <a:chExt cx="0" cy="0"/>
+        </a:xfrm>
+      </p:grpSpPr>
       <p:sp>
         <p:nvSpPr>
           <p:cNvPr id="2" name="Rectangle 1"/>
@@ -6546,6 +6848,7 @@
           <a:lstStyle/>
           <a:p>
             <a:pPr algn="ctr"/>
+            <a:endParaRPr/>
           </a:p>
         </p:txBody>
       </p:sp>
@@ -6589,6 +6892,7 @@
           <a:lstStyle/>
           <a:p>
             <a:pPr algn="ctr"/>
+            <a:endParaRPr/>
           </a:p>
         </p:txBody>
       </p:sp>
@@ -6700,6 +7004,7 @@
           <a:lstStyle/>
           <a:p>
             <a:pPr algn="ctr"/>
+            <a:endParaRPr/>
           </a:p>
         </p:txBody>
       </p:sp>
@@ -6815,7 +7120,7 @@
 </file>
 
 <file path=ppt/slides/slide21.xml><?xml version="1.0" encoding="utf-8"?>
-<p:sld xmlns:a="http://schemas.openxmlformats.org/drawingml/2006/main" xmlns:p="http://schemas.openxmlformats.org/presentationml/2006/main" xmlns:r="http://schemas.openxmlformats.org/officeDocument/2006/relationships">
+<p:sld xmlns:a="http://schemas.openxmlformats.org/drawingml/2006/main" xmlns:r="http://schemas.openxmlformats.org/officeDocument/2006/relationships" xmlns:p="http://schemas.openxmlformats.org/presentationml/2006/main">
   <p:cSld>
     <p:spTree>
       <p:nvGrpSpPr>
@@ -6823,7 +7128,14 @@
         <p:cNvGrpSpPr/>
         <p:nvPr/>
       </p:nvGrpSpPr>
-      <p:grpSpPr/>
+      <p:grpSpPr>
+        <a:xfrm>
+          <a:off x="0" y="0"/>
+          <a:ext cx="0" cy="0"/>
+          <a:chOff x="0" y="0"/>
+          <a:chExt cx="0" cy="0"/>
+        </a:xfrm>
+      </p:grpSpPr>
       <p:sp>
         <p:nvSpPr>
           <p:cNvPr id="2" name="Rectangle 1"/>
@@ -6864,6 +7176,7 @@
           <a:lstStyle/>
           <a:p>
             <a:pPr algn="ctr"/>
+            <a:endParaRPr/>
           </a:p>
         </p:txBody>
       </p:sp>
@@ -6948,7 +7261,7 @@
 </file>
 
 <file path=ppt/slides/slide22.xml><?xml version="1.0" encoding="utf-8"?>
-<p:sld xmlns:a="http://schemas.openxmlformats.org/drawingml/2006/main" xmlns:p="http://schemas.openxmlformats.org/presentationml/2006/main" xmlns:r="http://schemas.openxmlformats.org/officeDocument/2006/relationships">
+<p:sld xmlns:a="http://schemas.openxmlformats.org/drawingml/2006/main" xmlns:r="http://schemas.openxmlformats.org/officeDocument/2006/relationships" xmlns:p="http://schemas.openxmlformats.org/presentationml/2006/main">
   <p:cSld>
     <p:spTree>
       <p:nvGrpSpPr>
@@ -6956,7 +7269,14 @@
         <p:cNvGrpSpPr/>
         <p:nvPr/>
       </p:nvGrpSpPr>
-      <p:grpSpPr/>
+      <p:grpSpPr>
+        <a:xfrm>
+          <a:off x="0" y="0"/>
+          <a:ext cx="0" cy="0"/>
+          <a:chOff x="0" y="0"/>
+          <a:chExt cx="0" cy="0"/>
+        </a:xfrm>
+      </p:grpSpPr>
       <p:sp>
         <p:nvSpPr>
           <p:cNvPr id="2" name="Rectangle 1"/>
@@ -6997,6 +7317,7 @@
           <a:lstStyle/>
           <a:p>
             <a:pPr algn="ctr"/>
+            <a:endParaRPr/>
           </a:p>
         </p:txBody>
       </p:sp>
@@ -7074,6 +7395,7 @@
           <a:lstStyle/>
           <a:p>
             <a:pPr algn="ctr"/>
+            <a:endParaRPr/>
           </a:p>
         </p:txBody>
       </p:sp>
@@ -7253,7 +7575,7 @@
 </file>
 
 <file path=ppt/slides/slide23.xml><?xml version="1.0" encoding="utf-8"?>
-<p:sld xmlns:a="http://schemas.openxmlformats.org/drawingml/2006/main" xmlns:p="http://schemas.openxmlformats.org/presentationml/2006/main" xmlns:r="http://schemas.openxmlformats.org/officeDocument/2006/relationships">
+<p:sld xmlns:a="http://schemas.openxmlformats.org/drawingml/2006/main" xmlns:r="http://schemas.openxmlformats.org/officeDocument/2006/relationships" xmlns:p="http://schemas.openxmlformats.org/presentationml/2006/main">
   <p:cSld>
     <p:spTree>
       <p:nvGrpSpPr>
@@ -7261,7 +7583,14 @@
         <p:cNvGrpSpPr/>
         <p:nvPr/>
       </p:nvGrpSpPr>
-      <p:grpSpPr/>
+      <p:grpSpPr>
+        <a:xfrm>
+          <a:off x="0" y="0"/>
+          <a:ext cx="0" cy="0"/>
+          <a:chOff x="0" y="0"/>
+          <a:chExt cx="0" cy="0"/>
+        </a:xfrm>
+      </p:grpSpPr>
       <p:sp>
         <p:nvSpPr>
           <p:cNvPr id="2" name="Rectangle 1"/>
@@ -7302,6 +7631,7 @@
           <a:lstStyle/>
           <a:p>
             <a:pPr algn="ctr"/>
+            <a:endParaRPr/>
           </a:p>
         </p:txBody>
       </p:sp>
@@ -7379,197 +7709,40 @@
           <a:lstStyle/>
           <a:p>
             <a:pPr algn="ctr"/>
-          </a:p>
-        </p:txBody>
-      </p:sp>
-      <p:sp>
-        <p:nvSpPr>
-          <p:cNvPr id="5" name="Rectangle 4"/>
-          <p:cNvSpPr/>
+            <a:endParaRPr/>
+          </a:p>
+        </p:txBody>
+      </p:sp>
+      <p:pic>
+        <p:nvPicPr>
+          <p:cNvPr id="11" name="Imagen 10">
+            <a:extLst>
+              <a:ext uri="{FF2B5EF4-FFF2-40B4-BE49-F238E27FC236}">
+                <a16:creationId xmlns:a16="http://schemas.microsoft.com/office/drawing/2014/main" id="{67C64A04-843F-17BC-B2F4-20BE2570039D}"/>
+              </a:ext>
+            </a:extLst>
+          </p:cNvPr>
+          <p:cNvPicPr>
+            <a:picLocks noChangeAspect="1"/>
+          </p:cNvPicPr>
           <p:nvPr/>
-        </p:nvSpPr>
-        <p:spPr>
-          <a:xfrm>
-            <a:off x="1371600" y="1371600"/>
-            <a:ext cx="9418320" cy="4114800"/>
-          </a:xfrm>
-          <a:prstGeom prst="rect">
-            <a:avLst/>
-          </a:prstGeom>
-          <a:solidFill>
-            <a:srgbClr val="F2F2F2"/>
-          </a:solidFill>
-          <a:ln>
-            <a:noFill/>
-          </a:ln>
-        </p:spPr>
-        <p:style>
-          <a:lnRef idx="1">
-            <a:schemeClr val="accent1"/>
-          </a:lnRef>
-          <a:fillRef idx="3">
-            <a:schemeClr val="accent1"/>
-          </a:fillRef>
-          <a:effectRef idx="2">
-            <a:schemeClr val="accent1"/>
-          </a:effectRef>
-          <a:fontRef idx="minor">
-            <a:schemeClr val="lt1"/>
-          </a:fontRef>
-        </p:style>
-        <p:txBody>
-          <a:bodyPr rtlCol="0" anchor="ctr"/>
-          <a:lstStyle/>
-          <a:p>
-            <a:pPr algn="ctr"/>
-          </a:p>
-        </p:txBody>
-      </p:sp>
-      <p:sp>
-        <p:nvSpPr>
-          <p:cNvPr id="6" name="TextBox 5"/>
-          <p:cNvSpPr txBox="1"/>
-          <p:nvPr/>
-        </p:nvSpPr>
-        <p:spPr>
-          <a:xfrm>
-            <a:off x="1828800" y="2286000"/>
-            <a:ext cx="8503920" cy="1371600"/>
-          </a:xfrm>
-          <a:prstGeom prst="rect">
-            <a:avLst/>
-          </a:prstGeom>
-          <a:noFill/>
-        </p:spPr>
-        <p:txBody>
-          <a:bodyPr wrap="square"/>
-          <a:lstStyle/>
-          <a:p>
-            <a:pPr algn="ctr">
-              <a:defRPr sz="2400" b="0">
-                <a:solidFill>
-                  <a:srgbClr val="999999"/>
-                </a:solidFill>
-                <a:latin typeface="Calibri"/>
-              </a:defRPr>
-            </a:pPr>
-            <a:r>
-              <a:t>[Diagrama: Red Alastria (identidad, DIDs, VCs) conectada con Red Fabric (canales, chaincodes, ledger)]</a:t>
-            </a:r>
-          </a:p>
-        </p:txBody>
-      </p:sp>
-      <p:sp>
-        <p:nvSpPr>
-          <p:cNvPr id="7" name="Rectangle 6"/>
-          <p:cNvSpPr/>
-          <p:nvPr/>
-        </p:nvSpPr>
-        <p:spPr>
-          <a:xfrm>
-            <a:off x="1371600" y="3840480"/>
-            <a:ext cx="9418320" cy="320040"/>
-          </a:xfrm>
-          <a:prstGeom prst="rect">
-            <a:avLst/>
-          </a:prstGeom>
-          <a:solidFill>
-            <a:srgbClr val="7C3AED"/>
-          </a:solidFill>
-          <a:ln>
-            <a:noFill/>
-          </a:ln>
-        </p:spPr>
-        <p:style>
-          <a:lnRef idx="1">
-            <a:schemeClr val="accent1"/>
-          </a:lnRef>
-          <a:fillRef idx="3">
-            <a:schemeClr val="accent1"/>
-          </a:fillRef>
-          <a:effectRef idx="2">
-            <a:schemeClr val="accent1"/>
-          </a:effectRef>
-          <a:fontRef idx="minor">
-            <a:schemeClr val="lt1"/>
-          </a:fontRef>
-        </p:style>
-        <p:txBody>
-          <a:bodyPr rtlCol="0" anchor="ctr"/>
-          <a:lstStyle/>
-          <a:p>
-            <a:pPr algn="ctr"/>
-          </a:p>
-        </p:txBody>
-      </p:sp>
-      <p:sp>
-        <p:nvSpPr>
-          <p:cNvPr id="8" name="TextBox 7"/>
-          <p:cNvSpPr txBox="1"/>
-          <p:nvPr/>
-        </p:nvSpPr>
-        <p:spPr>
-          <a:xfrm>
-            <a:off x="1371600" y="3840480"/>
-            <a:ext cx="9418320" cy="320040"/>
-          </a:xfrm>
-          <a:prstGeom prst="rect">
-            <a:avLst/>
-          </a:prstGeom>
-          <a:noFill/>
-        </p:spPr>
-        <p:txBody>
-          <a:bodyPr wrap="square"/>
-          <a:lstStyle/>
-          <a:p>
-            <a:pPr algn="ctr">
-              <a:defRPr sz="1300" b="1">
-                <a:solidFill>
-                  <a:srgbClr val="FFFFFF"/>
-                </a:solidFill>
-                <a:latin typeface="Calibri"/>
-              </a:defRPr>
-            </a:pPr>
-            <a:r>
-              <a:t>Prompt para IA generativa:</a:t>
-            </a:r>
-          </a:p>
-        </p:txBody>
-      </p:sp>
-      <p:sp>
-        <p:nvSpPr>
-          <p:cNvPr id="9" name="TextBox 8"/>
-          <p:cNvSpPr txBox="1"/>
-          <p:nvPr/>
-        </p:nvSpPr>
-        <p:spPr>
-          <a:xfrm>
-            <a:off x="1645920" y="4297680"/>
-            <a:ext cx="8869680" cy="914400"/>
-          </a:xfrm>
-          <a:prstGeom prst="rect">
-            <a:avLst/>
-          </a:prstGeom>
-          <a:noFill/>
-        </p:spPr>
-        <p:txBody>
-          <a:bodyPr wrap="square"/>
-          <a:lstStyle/>
-          <a:p>
-            <a:pPr algn="l">
-              <a:defRPr sz="1400" b="0">
-                <a:solidFill>
-                  <a:srgbClr val="7C3AED"/>
-                </a:solidFill>
-                <a:latin typeface="Consolas"/>
-              </a:defRPr>
-            </a:pPr>
-            <a:r>
-              <a:t>Split architecture diagram: left side shows Alastria network with DID Registry and VC issuance (blue tones), right side shows Hyperledger Fabric network with channels, chaincodes, and private ledger (green tones). Bridge in the middle showing identity verification flow. Clean corporate style.</a:t>
-            </a:r>
-          </a:p>
-        </p:txBody>
-      </p:sp>
+        </p:nvPicPr>
+        <p:blipFill>
+          <a:blip r:embed="rId2"/>
+          <a:stretch>
+            <a:fillRect/>
+          </a:stretch>
+        </p:blipFill>
+        <p:spPr>
+          <a:xfrm>
+            <a:off x="1305289" y="1510485"/>
+            <a:ext cx="9578246" cy="4786330"/>
+          </a:xfrm>
+          <a:prstGeom prst="rect">
+            <a:avLst/>
+          </a:prstGeom>
+        </p:spPr>
+      </p:pic>
     </p:spTree>
   </p:cSld>
   <p:clrMapOvr>
@@ -7579,7 +7752,7 @@
 </file>
 
 <file path=ppt/slides/slide24.xml><?xml version="1.0" encoding="utf-8"?>
-<p:sld xmlns:a="http://schemas.openxmlformats.org/drawingml/2006/main" xmlns:p="http://schemas.openxmlformats.org/presentationml/2006/main" xmlns:r="http://schemas.openxmlformats.org/officeDocument/2006/relationships">
+<p:sld xmlns:a="http://schemas.openxmlformats.org/drawingml/2006/main" xmlns:r="http://schemas.openxmlformats.org/officeDocument/2006/relationships" xmlns:p="http://schemas.openxmlformats.org/presentationml/2006/main">
   <p:cSld>
     <p:spTree>
       <p:nvGrpSpPr>
@@ -7587,7 +7760,14 @@
         <p:cNvGrpSpPr/>
         <p:nvPr/>
       </p:nvGrpSpPr>
-      <p:grpSpPr/>
+      <p:grpSpPr>
+        <a:xfrm>
+          <a:off x="0" y="0"/>
+          <a:ext cx="0" cy="0"/>
+          <a:chOff x="0" y="0"/>
+          <a:chExt cx="0" cy="0"/>
+        </a:xfrm>
+      </p:grpSpPr>
       <p:sp>
         <p:nvSpPr>
           <p:cNvPr id="2" name="Rectangle 1"/>
@@ -7628,6 +7808,7 @@
           <a:lstStyle/>
           <a:p>
             <a:pPr algn="ctr"/>
+            <a:endParaRPr/>
           </a:p>
         </p:txBody>
       </p:sp>
@@ -7705,6 +7886,7 @@
           <a:lstStyle/>
           <a:p>
             <a:pPr algn="ctr"/>
+            <a:endParaRPr/>
           </a:p>
         </p:txBody>
       </p:sp>
@@ -7900,7 +8082,7 @@
 </file>
 
 <file path=ppt/slides/slide25.xml><?xml version="1.0" encoding="utf-8"?>
-<p:sld xmlns:a="http://schemas.openxmlformats.org/drawingml/2006/main" xmlns:p="http://schemas.openxmlformats.org/presentationml/2006/main" xmlns:r="http://schemas.openxmlformats.org/officeDocument/2006/relationships">
+<p:sld xmlns:a="http://schemas.openxmlformats.org/drawingml/2006/main" xmlns:r="http://schemas.openxmlformats.org/officeDocument/2006/relationships" xmlns:p="http://schemas.openxmlformats.org/presentationml/2006/main">
   <p:cSld>
     <p:spTree>
       <p:nvGrpSpPr>
@@ -7908,7 +8090,14 @@
         <p:cNvGrpSpPr/>
         <p:nvPr/>
       </p:nvGrpSpPr>
-      <p:grpSpPr/>
+      <p:grpSpPr>
+        <a:xfrm>
+          <a:off x="0" y="0"/>
+          <a:ext cx="0" cy="0"/>
+          <a:chOff x="0" y="0"/>
+          <a:chExt cx="0" cy="0"/>
+        </a:xfrm>
+      </p:grpSpPr>
       <p:sp>
         <p:nvSpPr>
           <p:cNvPr id="2" name="Rectangle 1"/>
@@ -7949,6 +8138,7 @@
           <a:lstStyle/>
           <a:p>
             <a:pPr algn="ctr"/>
+            <a:endParaRPr/>
           </a:p>
         </p:txBody>
       </p:sp>
@@ -8026,6 +8216,7 @@
           <a:lstStyle/>
           <a:p>
             <a:pPr algn="ctr"/>
+            <a:endParaRPr/>
           </a:p>
         </p:txBody>
       </p:sp>
@@ -8189,7 +8380,7 @@
 </file>
 
 <file path=ppt/slides/slide26.xml><?xml version="1.0" encoding="utf-8"?>
-<p:sld xmlns:a="http://schemas.openxmlformats.org/drawingml/2006/main" xmlns:p="http://schemas.openxmlformats.org/presentationml/2006/main" xmlns:r="http://schemas.openxmlformats.org/officeDocument/2006/relationships">
+<p:sld xmlns:a="http://schemas.openxmlformats.org/drawingml/2006/main" xmlns:r="http://schemas.openxmlformats.org/officeDocument/2006/relationships" xmlns:p="http://schemas.openxmlformats.org/presentationml/2006/main">
   <p:cSld>
     <p:spTree>
       <p:nvGrpSpPr>
@@ -8197,7 +8388,14 @@
         <p:cNvGrpSpPr/>
         <p:nvPr/>
       </p:nvGrpSpPr>
-      <p:grpSpPr/>
+      <p:grpSpPr>
+        <a:xfrm>
+          <a:off x="0" y="0"/>
+          <a:ext cx="0" cy="0"/>
+          <a:chOff x="0" y="0"/>
+          <a:chExt cx="0" cy="0"/>
+        </a:xfrm>
+      </p:grpSpPr>
       <p:sp>
         <p:nvSpPr>
           <p:cNvPr id="2" name="Rectangle 1"/>
@@ -8238,6 +8436,7 @@
           <a:lstStyle/>
           <a:p>
             <a:pPr algn="ctr"/>
+            <a:endParaRPr/>
           </a:p>
         </p:txBody>
       </p:sp>
@@ -8315,6 +8514,7 @@
           <a:lstStyle/>
           <a:p>
             <a:pPr algn="ctr"/>
+            <a:endParaRPr/>
           </a:p>
         </p:txBody>
       </p:sp>
@@ -8337,9 +8537,27 @@
                 <a:tableStyleId>{5C22544A-7EE6-4342-B048-85BDC9FD1C3A}</a:tableStyleId>
               </a:tblPr>
               <a:tblGrid>
-                <a:gridCol w="3505200"/>
-                <a:gridCol w="3505200"/>
-                <a:gridCol w="3505200"/>
+                <a:gridCol w="3505200">
+                  <a:extLst>
+                    <a:ext uri="{9D8B030D-6E8A-4147-A177-3AD203B41FA5}">
+                      <a16:colId xmlns:a16="http://schemas.microsoft.com/office/drawing/2014/main" val="20000"/>
+                    </a:ext>
+                  </a:extLst>
+                </a:gridCol>
+                <a:gridCol w="3505200">
+                  <a:extLst>
+                    <a:ext uri="{9D8B030D-6E8A-4147-A177-3AD203B41FA5}">
+                      <a16:colId xmlns:a16="http://schemas.microsoft.com/office/drawing/2014/main" val="20001"/>
+                    </a:ext>
+                  </a:extLst>
+                </a:gridCol>
+                <a:gridCol w="3505200">
+                  <a:extLst>
+                    <a:ext uri="{9D8B030D-6E8A-4147-A177-3AD203B41FA5}">
+                      <a16:colId xmlns:a16="http://schemas.microsoft.com/office/drawing/2014/main" val="20002"/>
+                    </a:ext>
+                  </a:extLst>
+                </a:gridCol>
               </a:tblGrid>
               <a:tr h="411480">
                 <a:tc>
@@ -8414,6 +8632,11 @@
                     </a:solidFill>
                   </a:tcPr>
                 </a:tc>
+                <a:extLst>
+                  <a:ext uri="{0D108BD9-81ED-4DB2-BD59-A6C34878D82A}">
+                    <a16:rowId xmlns:a16="http://schemas.microsoft.com/office/drawing/2014/main" val="10000"/>
+                  </a:ext>
+                </a:extLst>
               </a:tr>
               <a:tr h="411480">
                 <a:tc>
@@ -8488,6 +8711,11 @@
                     </a:solidFill>
                   </a:tcPr>
                 </a:tc>
+                <a:extLst>
+                  <a:ext uri="{0D108BD9-81ED-4DB2-BD59-A6C34878D82A}">
+                    <a16:rowId xmlns:a16="http://schemas.microsoft.com/office/drawing/2014/main" val="10001"/>
+                  </a:ext>
+                </a:extLst>
               </a:tr>
               <a:tr h="411480">
                 <a:tc>
@@ -8550,6 +8778,11 @@
                   </a:txBody>
                   <a:tcPr/>
                 </a:tc>
+                <a:extLst>
+                  <a:ext uri="{0D108BD9-81ED-4DB2-BD59-A6C34878D82A}">
+                    <a16:rowId xmlns:a16="http://schemas.microsoft.com/office/drawing/2014/main" val="10002"/>
+                  </a:ext>
+                </a:extLst>
               </a:tr>
               <a:tr h="411480">
                 <a:tc>
@@ -8624,6 +8857,11 @@
                     </a:solidFill>
                   </a:tcPr>
                 </a:tc>
+                <a:extLst>
+                  <a:ext uri="{0D108BD9-81ED-4DB2-BD59-A6C34878D82A}">
+                    <a16:rowId xmlns:a16="http://schemas.microsoft.com/office/drawing/2014/main" val="10003"/>
+                  </a:ext>
+                </a:extLst>
               </a:tr>
               <a:tr h="411480">
                 <a:tc>
@@ -8686,6 +8924,11 @@
                   </a:txBody>
                   <a:tcPr/>
                 </a:tc>
+                <a:extLst>
+                  <a:ext uri="{0D108BD9-81ED-4DB2-BD59-A6C34878D82A}">
+                    <a16:rowId xmlns:a16="http://schemas.microsoft.com/office/drawing/2014/main" val="10004"/>
+                  </a:ext>
+                </a:extLst>
               </a:tr>
               <a:tr h="411480">
                 <a:tc>
@@ -8760,6 +9003,11 @@
                     </a:solidFill>
                   </a:tcPr>
                 </a:tc>
+                <a:extLst>
+                  <a:ext uri="{0D108BD9-81ED-4DB2-BD59-A6C34878D82A}">
+                    <a16:rowId xmlns:a16="http://schemas.microsoft.com/office/drawing/2014/main" val="10005"/>
+                  </a:ext>
+                </a:extLst>
               </a:tr>
               <a:tr h="411480">
                 <a:tc>
@@ -8822,6 +9070,11 @@
                   </a:txBody>
                   <a:tcPr/>
                 </a:tc>
+                <a:extLst>
+                  <a:ext uri="{0D108BD9-81ED-4DB2-BD59-A6C34878D82A}">
+                    <a16:rowId xmlns:a16="http://schemas.microsoft.com/office/drawing/2014/main" val="10006"/>
+                  </a:ext>
+                </a:extLst>
               </a:tr>
               <a:tr h="411480">
                 <a:tc>
@@ -8896,6 +9149,11 @@
                     </a:solidFill>
                   </a:tcPr>
                 </a:tc>
+                <a:extLst>
+                  <a:ext uri="{0D108BD9-81ED-4DB2-BD59-A6C34878D82A}">
+                    <a16:rowId xmlns:a16="http://schemas.microsoft.com/office/drawing/2014/main" val="10007"/>
+                  </a:ext>
+                </a:extLst>
               </a:tr>
             </a:tbl>
           </a:graphicData>
@@ -8910,7 +9168,7 @@
 </file>
 
 <file path=ppt/slides/slide27.xml><?xml version="1.0" encoding="utf-8"?>
-<p:sld xmlns:a="http://schemas.openxmlformats.org/drawingml/2006/main" xmlns:p="http://schemas.openxmlformats.org/presentationml/2006/main" xmlns:r="http://schemas.openxmlformats.org/officeDocument/2006/relationships">
+<p:sld xmlns:a="http://schemas.openxmlformats.org/drawingml/2006/main" xmlns:r="http://schemas.openxmlformats.org/officeDocument/2006/relationships" xmlns:p="http://schemas.openxmlformats.org/presentationml/2006/main">
   <p:cSld>
     <p:spTree>
       <p:nvGrpSpPr>
@@ -8918,7 +9176,14 @@
         <p:cNvGrpSpPr/>
         <p:nvPr/>
       </p:nvGrpSpPr>
-      <p:grpSpPr/>
+      <p:grpSpPr>
+        <a:xfrm>
+          <a:off x="0" y="0"/>
+          <a:ext cx="0" cy="0"/>
+          <a:chOff x="0" y="0"/>
+          <a:chExt cx="0" cy="0"/>
+        </a:xfrm>
+      </p:grpSpPr>
       <p:sp>
         <p:nvSpPr>
           <p:cNvPr id="2" name="Rectangle 1"/>
@@ -8959,6 +9224,7 @@
           <a:lstStyle/>
           <a:p>
             <a:pPr algn="ctr"/>
+            <a:endParaRPr/>
           </a:p>
         </p:txBody>
       </p:sp>
@@ -9002,6 +9268,7 @@
           <a:lstStyle/>
           <a:p>
             <a:pPr algn="ctr"/>
+            <a:endParaRPr/>
           </a:p>
         </p:txBody>
       </p:sp>
@@ -9113,6 +9380,7 @@
           <a:lstStyle/>
           <a:p>
             <a:pPr algn="ctr"/>
+            <a:endParaRPr/>
           </a:p>
         </p:txBody>
       </p:sp>
@@ -9197,6 +9465,7 @@
                 <a:latin typeface="Calibri"/>
               </a:defRPr>
             </a:pPr>
+            <a:endParaRPr/>
           </a:p>
           <a:p>
             <a:pPr>
@@ -9306,6 +9575,7 @@
                 <a:latin typeface="Calibri"/>
               </a:defRPr>
             </a:pPr>
+            <a:endParaRPr/>
           </a:p>
           <a:p>
             <a:pPr>
@@ -9350,7 +9620,7 @@
 </file>
 
 <file path=ppt/slides/slide28.xml><?xml version="1.0" encoding="utf-8"?>
-<p:sld xmlns:a="http://schemas.openxmlformats.org/drawingml/2006/main" xmlns:p="http://schemas.openxmlformats.org/presentationml/2006/main" xmlns:r="http://schemas.openxmlformats.org/officeDocument/2006/relationships">
+<p:sld xmlns:a="http://schemas.openxmlformats.org/drawingml/2006/main" xmlns:r="http://schemas.openxmlformats.org/officeDocument/2006/relationships" xmlns:p="http://schemas.openxmlformats.org/presentationml/2006/main">
   <p:cSld>
     <p:spTree>
       <p:nvGrpSpPr>
@@ -9358,7 +9628,14 @@
         <p:cNvGrpSpPr/>
         <p:nvPr/>
       </p:nvGrpSpPr>
-      <p:grpSpPr/>
+      <p:grpSpPr>
+        <a:xfrm>
+          <a:off x="0" y="0"/>
+          <a:ext cx="0" cy="0"/>
+          <a:chOff x="0" y="0"/>
+          <a:chExt cx="0" cy="0"/>
+        </a:xfrm>
+      </p:grpSpPr>
       <p:sp>
         <p:nvSpPr>
           <p:cNvPr id="2" name="Rectangle 1"/>
@@ -9399,6 +9676,7 @@
           <a:lstStyle/>
           <a:p>
             <a:pPr algn="ctr"/>
+            <a:endParaRPr/>
           </a:p>
         </p:txBody>
       </p:sp>
@@ -9442,6 +9720,7 @@
           <a:lstStyle/>
           <a:p>
             <a:pPr algn="ctr"/>
+            <a:endParaRPr/>
           </a:p>
         </p:txBody>
       </p:sp>
@@ -9553,6 +9832,7 @@
           <a:lstStyle/>
           <a:p>
             <a:pPr algn="ctr"/>
+            <a:endParaRPr/>
           </a:p>
         </p:txBody>
       </p:sp>
@@ -9605,6 +9885,7 @@
                 <a:latin typeface="Calibri"/>
               </a:defRPr>
             </a:pPr>
+            <a:endParaRPr/>
           </a:p>
           <a:p>
             <a:pPr>
@@ -9666,6 +9947,7 @@
                 <a:latin typeface="Calibri"/>
               </a:defRPr>
             </a:pPr>
+            <a:endParaRPr/>
           </a:p>
           <a:p>
             <a:pPr>
@@ -9775,6 +10057,7 @@
                 <a:latin typeface="Calibri"/>
               </a:defRPr>
             </a:pPr>
+            <a:endParaRPr/>
           </a:p>
           <a:p>
             <a:pPr>
@@ -9803,7 +10086,7 @@
 </file>
 
 <file path=ppt/slides/slide29.xml><?xml version="1.0" encoding="utf-8"?>
-<p:sld xmlns:a="http://schemas.openxmlformats.org/drawingml/2006/main" xmlns:p="http://schemas.openxmlformats.org/presentationml/2006/main" xmlns:r="http://schemas.openxmlformats.org/officeDocument/2006/relationships">
+<p:sld xmlns:a="http://schemas.openxmlformats.org/drawingml/2006/main" xmlns:r="http://schemas.openxmlformats.org/officeDocument/2006/relationships" xmlns:p="http://schemas.openxmlformats.org/presentationml/2006/main">
   <p:cSld>
     <p:spTree>
       <p:nvGrpSpPr>
@@ -9811,7 +10094,14 @@
         <p:cNvGrpSpPr/>
         <p:nvPr/>
       </p:nvGrpSpPr>
-      <p:grpSpPr/>
+      <p:grpSpPr>
+        <a:xfrm>
+          <a:off x="0" y="0"/>
+          <a:ext cx="0" cy="0"/>
+          <a:chOff x="0" y="0"/>
+          <a:chExt cx="0" cy="0"/>
+        </a:xfrm>
+      </p:grpSpPr>
       <p:sp>
         <p:nvSpPr>
           <p:cNvPr id="2" name="Rectangle 1"/>
@@ -9852,6 +10142,7 @@
           <a:lstStyle/>
           <a:p>
             <a:pPr algn="ctr"/>
+            <a:endParaRPr/>
           </a:p>
         </p:txBody>
       </p:sp>
@@ -9895,6 +10186,7 @@
           <a:lstStyle/>
           <a:p>
             <a:pPr algn="ctr"/>
+            <a:endParaRPr/>
           </a:p>
         </p:txBody>
       </p:sp>
@@ -10006,6 +10298,7 @@
           <a:lstStyle/>
           <a:p>
             <a:pPr algn="ctr"/>
+            <a:endParaRPr/>
           </a:p>
         </p:txBody>
       </p:sp>
@@ -10121,7 +10414,7 @@
 </file>
 
 <file path=ppt/slides/slide3.xml><?xml version="1.0" encoding="utf-8"?>
-<p:sld xmlns:a="http://schemas.openxmlformats.org/drawingml/2006/main" xmlns:p="http://schemas.openxmlformats.org/presentationml/2006/main" xmlns:r="http://schemas.openxmlformats.org/officeDocument/2006/relationships">
+<p:sld xmlns:a="http://schemas.openxmlformats.org/drawingml/2006/main" xmlns:r="http://schemas.openxmlformats.org/officeDocument/2006/relationships" xmlns:p="http://schemas.openxmlformats.org/presentationml/2006/main">
   <p:cSld>
     <p:spTree>
       <p:nvGrpSpPr>
@@ -10129,7 +10422,14 @@
         <p:cNvGrpSpPr/>
         <p:nvPr/>
       </p:nvGrpSpPr>
-      <p:grpSpPr/>
+      <p:grpSpPr>
+        <a:xfrm>
+          <a:off x="0" y="0"/>
+          <a:ext cx="0" cy="0"/>
+          <a:chOff x="0" y="0"/>
+          <a:chExt cx="0" cy="0"/>
+        </a:xfrm>
+      </p:grpSpPr>
       <p:sp>
         <p:nvSpPr>
           <p:cNvPr id="2" name="Rectangle 1"/>
@@ -10170,6 +10470,7 @@
           <a:lstStyle/>
           <a:p>
             <a:pPr algn="ctr"/>
+            <a:endParaRPr/>
           </a:p>
         </p:txBody>
       </p:sp>
@@ -10247,6 +10548,7 @@
           <a:lstStyle/>
           <a:p>
             <a:pPr algn="ctr"/>
+            <a:endParaRPr/>
           </a:p>
         </p:txBody>
       </p:sp>
@@ -10442,7 +10744,7 @@
 </file>
 
 <file path=ppt/slides/slide30.xml><?xml version="1.0" encoding="utf-8"?>
-<p:sld xmlns:a="http://schemas.openxmlformats.org/drawingml/2006/main" xmlns:p="http://schemas.openxmlformats.org/presentationml/2006/main" xmlns:r="http://schemas.openxmlformats.org/officeDocument/2006/relationships">
+<p:sld xmlns:a="http://schemas.openxmlformats.org/drawingml/2006/main" xmlns:r="http://schemas.openxmlformats.org/officeDocument/2006/relationships" xmlns:p="http://schemas.openxmlformats.org/presentationml/2006/main">
   <p:cSld>
     <p:spTree>
       <p:nvGrpSpPr>
@@ -10450,7 +10752,14 @@
         <p:cNvGrpSpPr/>
         <p:nvPr/>
       </p:nvGrpSpPr>
-      <p:grpSpPr/>
+      <p:grpSpPr>
+        <a:xfrm>
+          <a:off x="0" y="0"/>
+          <a:ext cx="0" cy="0"/>
+          <a:chOff x="0" y="0"/>
+          <a:chExt cx="0" cy="0"/>
+        </a:xfrm>
+      </p:grpSpPr>
       <p:sp>
         <p:nvSpPr>
           <p:cNvPr id="2" name="Rectangle 1"/>
@@ -10491,6 +10800,7 @@
           <a:lstStyle/>
           <a:p>
             <a:pPr algn="ctr"/>
+            <a:endParaRPr/>
           </a:p>
         </p:txBody>
       </p:sp>
@@ -10568,6 +10878,7 @@
           <a:lstStyle/>
           <a:p>
             <a:pPr algn="ctr"/>
+            <a:endParaRPr/>
           </a:p>
         </p:txBody>
       </p:sp>
@@ -10731,7 +11042,7 @@
 </file>
 
 <file path=ppt/slides/slide4.xml><?xml version="1.0" encoding="utf-8"?>
-<p:sld xmlns:a="http://schemas.openxmlformats.org/drawingml/2006/main" xmlns:p="http://schemas.openxmlformats.org/presentationml/2006/main" xmlns:r="http://schemas.openxmlformats.org/officeDocument/2006/relationships">
+<p:sld xmlns:a="http://schemas.openxmlformats.org/drawingml/2006/main" xmlns:r="http://schemas.openxmlformats.org/officeDocument/2006/relationships" xmlns:p="http://schemas.openxmlformats.org/presentationml/2006/main">
   <p:cSld>
     <p:spTree>
       <p:nvGrpSpPr>
@@ -10739,7 +11050,14 @@
         <p:cNvGrpSpPr/>
         <p:nvPr/>
       </p:nvGrpSpPr>
-      <p:grpSpPr/>
+      <p:grpSpPr>
+        <a:xfrm>
+          <a:off x="0" y="0"/>
+          <a:ext cx="0" cy="0"/>
+          <a:chOff x="0" y="0"/>
+          <a:chExt cx="0" cy="0"/>
+        </a:xfrm>
+      </p:grpSpPr>
       <p:sp>
         <p:nvSpPr>
           <p:cNvPr id="2" name="Rectangle 1"/>
@@ -10780,6 +11098,7 @@
           <a:lstStyle/>
           <a:p>
             <a:pPr algn="ctr"/>
+            <a:endParaRPr/>
           </a:p>
         </p:txBody>
       </p:sp>
@@ -10857,6 +11176,7 @@
           <a:lstStyle/>
           <a:p>
             <a:pPr algn="ctr"/>
+            <a:endParaRPr/>
           </a:p>
         </p:txBody>
       </p:sp>
@@ -11036,7 +11356,7 @@
 </file>
 
 <file path=ppt/slides/slide5.xml><?xml version="1.0" encoding="utf-8"?>
-<p:sld xmlns:a="http://schemas.openxmlformats.org/drawingml/2006/main" xmlns:p="http://schemas.openxmlformats.org/presentationml/2006/main" xmlns:r="http://schemas.openxmlformats.org/officeDocument/2006/relationships">
+<p:sld xmlns:a="http://schemas.openxmlformats.org/drawingml/2006/main" xmlns:r="http://schemas.openxmlformats.org/officeDocument/2006/relationships" xmlns:p="http://schemas.openxmlformats.org/presentationml/2006/main">
   <p:cSld>
     <p:spTree>
       <p:nvGrpSpPr>
@@ -11044,7 +11364,14 @@
         <p:cNvGrpSpPr/>
         <p:nvPr/>
       </p:nvGrpSpPr>
-      <p:grpSpPr/>
+      <p:grpSpPr>
+        <a:xfrm>
+          <a:off x="0" y="0"/>
+          <a:ext cx="0" cy="0"/>
+          <a:chOff x="0" y="0"/>
+          <a:chExt cx="0" cy="0"/>
+        </a:xfrm>
+      </p:grpSpPr>
       <p:sp>
         <p:nvSpPr>
           <p:cNvPr id="2" name="Rectangle 1"/>
@@ -11085,6 +11412,7 @@
           <a:lstStyle/>
           <a:p>
             <a:pPr algn="ctr"/>
+            <a:endParaRPr/>
           </a:p>
         </p:txBody>
       </p:sp>
@@ -11162,197 +11490,40 @@
           <a:lstStyle/>
           <a:p>
             <a:pPr algn="ctr"/>
-          </a:p>
-        </p:txBody>
-      </p:sp>
-      <p:sp>
-        <p:nvSpPr>
-          <p:cNvPr id="5" name="Rectangle 4"/>
-          <p:cNvSpPr/>
+            <a:endParaRPr/>
+          </a:p>
+        </p:txBody>
+      </p:sp>
+      <p:pic>
+        <p:nvPicPr>
+          <p:cNvPr id="11" name="Imagen 10">
+            <a:extLst>
+              <a:ext uri="{FF2B5EF4-FFF2-40B4-BE49-F238E27FC236}">
+                <a16:creationId xmlns:a16="http://schemas.microsoft.com/office/drawing/2014/main" id="{1CE31246-8BAD-6ACC-305B-0D4D8C754D62}"/>
+              </a:ext>
+            </a:extLst>
+          </p:cNvPr>
+          <p:cNvPicPr>
+            <a:picLocks noChangeAspect="1"/>
+          </p:cNvPicPr>
           <p:nvPr/>
-        </p:nvSpPr>
-        <p:spPr>
-          <a:xfrm>
-            <a:off x="1371600" y="1371600"/>
-            <a:ext cx="9418320" cy="4114800"/>
-          </a:xfrm>
-          <a:prstGeom prst="rect">
-            <a:avLst/>
-          </a:prstGeom>
-          <a:solidFill>
-            <a:srgbClr val="F2F2F2"/>
-          </a:solidFill>
-          <a:ln>
-            <a:noFill/>
-          </a:ln>
-        </p:spPr>
-        <p:style>
-          <a:lnRef idx="1">
-            <a:schemeClr val="accent1"/>
-          </a:lnRef>
-          <a:fillRef idx="3">
-            <a:schemeClr val="accent1"/>
-          </a:fillRef>
-          <a:effectRef idx="2">
-            <a:schemeClr val="accent1"/>
-          </a:effectRef>
-          <a:fontRef idx="minor">
-            <a:schemeClr val="lt1"/>
-          </a:fontRef>
-        </p:style>
-        <p:txBody>
-          <a:bodyPr rtlCol="0" anchor="ctr"/>
-          <a:lstStyle/>
-          <a:p>
-            <a:pPr algn="ctr"/>
-          </a:p>
-        </p:txBody>
-      </p:sp>
-      <p:sp>
-        <p:nvSpPr>
-          <p:cNvPr id="6" name="TextBox 5"/>
-          <p:cNvSpPr txBox="1"/>
-          <p:nvPr/>
-        </p:nvSpPr>
-        <p:spPr>
-          <a:xfrm>
-            <a:off x="1828800" y="2286000"/>
-            <a:ext cx="8503920" cy="1371600"/>
-          </a:xfrm>
-          <a:prstGeom prst="rect">
-            <a:avLst/>
-          </a:prstGeom>
-          <a:noFill/>
-        </p:spPr>
-        <p:txBody>
-          <a:bodyPr wrap="square"/>
-          <a:lstStyle/>
-          <a:p>
-            <a:pPr algn="ctr">
-              <a:defRPr sz="2400" b="0">
-                <a:solidFill>
-                  <a:srgbClr val="999999"/>
-                </a:solidFill>
-                <a:latin typeface="Calibri"/>
-              </a:defRPr>
-            </a:pPr>
-            <a:r>
-              <a:t>[Diagrama: nodos validadores por pais conectados a APIs publicas, capa DID/VC encima]</a:t>
-            </a:r>
-          </a:p>
-        </p:txBody>
-      </p:sp>
-      <p:sp>
-        <p:nvSpPr>
-          <p:cNvPr id="7" name="Rectangle 6"/>
-          <p:cNvSpPr/>
-          <p:nvPr/>
-        </p:nvSpPr>
-        <p:spPr>
-          <a:xfrm>
-            <a:off x="1371600" y="3840480"/>
-            <a:ext cx="9418320" cy="320040"/>
-          </a:xfrm>
-          <a:prstGeom prst="rect">
-            <a:avLst/>
-          </a:prstGeom>
-          <a:solidFill>
-            <a:srgbClr val="7C3AED"/>
-          </a:solidFill>
-          <a:ln>
-            <a:noFill/>
-          </a:ln>
-        </p:spPr>
-        <p:style>
-          <a:lnRef idx="1">
-            <a:schemeClr val="accent1"/>
-          </a:lnRef>
-          <a:fillRef idx="3">
-            <a:schemeClr val="accent1"/>
-          </a:fillRef>
-          <a:effectRef idx="2">
-            <a:schemeClr val="accent1"/>
-          </a:effectRef>
-          <a:fontRef idx="minor">
-            <a:schemeClr val="lt1"/>
-          </a:fontRef>
-        </p:style>
-        <p:txBody>
-          <a:bodyPr rtlCol="0" anchor="ctr"/>
-          <a:lstStyle/>
-          <a:p>
-            <a:pPr algn="ctr"/>
-          </a:p>
-        </p:txBody>
-      </p:sp>
-      <p:sp>
-        <p:nvSpPr>
-          <p:cNvPr id="8" name="TextBox 7"/>
-          <p:cNvSpPr txBox="1"/>
-          <p:nvPr/>
-        </p:nvSpPr>
-        <p:spPr>
-          <a:xfrm>
-            <a:off x="1371600" y="3840480"/>
-            <a:ext cx="9418320" cy="320040"/>
-          </a:xfrm>
-          <a:prstGeom prst="rect">
-            <a:avLst/>
-          </a:prstGeom>
-          <a:noFill/>
-        </p:spPr>
-        <p:txBody>
-          <a:bodyPr wrap="square"/>
-          <a:lstStyle/>
-          <a:p>
-            <a:pPr algn="ctr">
-              <a:defRPr sz="1300" b="1">
-                <a:solidFill>
-                  <a:srgbClr val="FFFFFF"/>
-                </a:solidFill>
-                <a:latin typeface="Calibri"/>
-              </a:defRPr>
-            </a:pPr>
-            <a:r>
-              <a:t>Prompt para IA generativa:</a:t>
-            </a:r>
-          </a:p>
-        </p:txBody>
-      </p:sp>
-      <p:sp>
-        <p:nvSpPr>
-          <p:cNvPr id="9" name="TextBox 8"/>
-          <p:cNvSpPr txBox="1"/>
-          <p:nvPr/>
-        </p:nvSpPr>
-        <p:spPr>
-          <a:xfrm>
-            <a:off x="1645920" y="4297680"/>
-            <a:ext cx="8869680" cy="914400"/>
-          </a:xfrm>
-          <a:prstGeom prst="rect">
-            <a:avLst/>
-          </a:prstGeom>
-          <a:noFill/>
-        </p:spPr>
-        <p:txBody>
-          <a:bodyPr wrap="square"/>
-          <a:lstStyle/>
-          <a:p>
-            <a:pPr algn="l">
-              <a:defRPr sz="1400" b="0">
-                <a:solidFill>
-                  <a:srgbClr val="7C3AED"/>
-                </a:solidFill>
-                <a:latin typeface="Consolas"/>
-              </a:defRPr>
-            </a:pPr>
-            <a:r>
-              <a:t>Architecture diagram of EBSI: network of validator nodes from EU member states connected to public APIs (DID Registry, Trusted Issuers, Schemas, Timestamp). Layer on top shows DID/VC ecosystem with issuers, holders and verifiers. Clean flat design, EU blue color scheme.</a:t>
-            </a:r>
-          </a:p>
-        </p:txBody>
-      </p:sp>
+        </p:nvPicPr>
+        <p:blipFill>
+          <a:blip r:embed="rId2"/>
+          <a:stretch>
+            <a:fillRect/>
+          </a:stretch>
+        </p:blipFill>
+        <p:spPr>
+          <a:xfrm>
+            <a:off x="1074944" y="1509916"/>
+            <a:ext cx="10038936" cy="5073764"/>
+          </a:xfrm>
+          <a:prstGeom prst="rect">
+            <a:avLst/>
+          </a:prstGeom>
+        </p:spPr>
+      </p:pic>
     </p:spTree>
   </p:cSld>
   <p:clrMapOvr>
@@ -11362,7 +11533,7 @@
 </file>
 
 <file path=ppt/slides/slide6.xml><?xml version="1.0" encoding="utf-8"?>
-<p:sld xmlns:a="http://schemas.openxmlformats.org/drawingml/2006/main" xmlns:p="http://schemas.openxmlformats.org/presentationml/2006/main" xmlns:r="http://schemas.openxmlformats.org/officeDocument/2006/relationships">
+<p:sld xmlns:a="http://schemas.openxmlformats.org/drawingml/2006/main" xmlns:r="http://schemas.openxmlformats.org/officeDocument/2006/relationships" xmlns:p="http://schemas.openxmlformats.org/presentationml/2006/main">
   <p:cSld>
     <p:spTree>
       <p:nvGrpSpPr>
@@ -11370,7 +11541,14 @@
         <p:cNvGrpSpPr/>
         <p:nvPr/>
       </p:nvGrpSpPr>
-      <p:grpSpPr/>
+      <p:grpSpPr>
+        <a:xfrm>
+          <a:off x="0" y="0"/>
+          <a:ext cx="0" cy="0"/>
+          <a:chOff x="0" y="0"/>
+          <a:chExt cx="0" cy="0"/>
+        </a:xfrm>
+      </p:grpSpPr>
       <p:sp>
         <p:nvSpPr>
           <p:cNvPr id="2" name="Rectangle 1"/>
@@ -11411,6 +11589,7 @@
           <a:lstStyle/>
           <a:p>
             <a:pPr algn="ctr"/>
+            <a:endParaRPr/>
           </a:p>
         </p:txBody>
       </p:sp>
@@ -11488,6 +11667,7 @@
           <a:lstStyle/>
           <a:p>
             <a:pPr algn="ctr"/>
+            <a:endParaRPr/>
           </a:p>
         </p:txBody>
       </p:sp>
@@ -11635,7 +11815,7 @@
 </file>
 
 <file path=ppt/slides/slide7.xml><?xml version="1.0" encoding="utf-8"?>
-<p:sld xmlns:a="http://schemas.openxmlformats.org/drawingml/2006/main" xmlns:p="http://schemas.openxmlformats.org/presentationml/2006/main" xmlns:r="http://schemas.openxmlformats.org/officeDocument/2006/relationships">
+<p:sld xmlns:a="http://schemas.openxmlformats.org/drawingml/2006/main" xmlns:r="http://schemas.openxmlformats.org/officeDocument/2006/relationships" xmlns:p="http://schemas.openxmlformats.org/presentationml/2006/main">
   <p:cSld>
     <p:spTree>
       <p:nvGrpSpPr>
@@ -11643,7 +11823,14 @@
         <p:cNvGrpSpPr/>
         <p:nvPr/>
       </p:nvGrpSpPr>
-      <p:grpSpPr/>
+      <p:grpSpPr>
+        <a:xfrm>
+          <a:off x="0" y="0"/>
+          <a:ext cx="0" cy="0"/>
+          <a:chOff x="0" y="0"/>
+          <a:chExt cx="0" cy="0"/>
+        </a:xfrm>
+      </p:grpSpPr>
       <p:sp>
         <p:nvSpPr>
           <p:cNvPr id="2" name="Rectangle 1"/>
@@ -11684,6 +11871,7 @@
           <a:lstStyle/>
           <a:p>
             <a:pPr algn="ctr"/>
+            <a:endParaRPr/>
           </a:p>
         </p:txBody>
       </p:sp>
@@ -11772,7 +11960,7 @@
 </file>
 
 <file path=ppt/slides/slide8.xml><?xml version="1.0" encoding="utf-8"?>
-<p:sld xmlns:a="http://schemas.openxmlformats.org/drawingml/2006/main" xmlns:p="http://schemas.openxmlformats.org/presentationml/2006/main" xmlns:r="http://schemas.openxmlformats.org/officeDocument/2006/relationships">
+<p:sld xmlns:a="http://schemas.openxmlformats.org/drawingml/2006/main" xmlns:r="http://schemas.openxmlformats.org/officeDocument/2006/relationships" xmlns:p="http://schemas.openxmlformats.org/presentationml/2006/main">
   <p:cSld>
     <p:spTree>
       <p:nvGrpSpPr>
@@ -11780,7 +11968,14 @@
         <p:cNvGrpSpPr/>
         <p:nvPr/>
       </p:nvGrpSpPr>
-      <p:grpSpPr/>
+      <p:grpSpPr>
+        <a:xfrm>
+          <a:off x="0" y="0"/>
+          <a:ext cx="0" cy="0"/>
+          <a:chOff x="0" y="0"/>
+          <a:chExt cx="0" cy="0"/>
+        </a:xfrm>
+      </p:grpSpPr>
       <p:sp>
         <p:nvSpPr>
           <p:cNvPr id="2" name="Rectangle 1"/>
@@ -11821,6 +12016,7 @@
           <a:lstStyle/>
           <a:p>
             <a:pPr algn="ctr"/>
+            <a:endParaRPr/>
           </a:p>
         </p:txBody>
       </p:sp>
@@ -11898,6 +12094,7 @@
           <a:lstStyle/>
           <a:p>
             <a:pPr algn="ctr"/>
+            <a:endParaRPr/>
           </a:p>
         </p:txBody>
       </p:sp>
@@ -12109,7 +12306,7 @@
 </file>
 
 <file path=ppt/slides/slide9.xml><?xml version="1.0" encoding="utf-8"?>
-<p:sld xmlns:a="http://schemas.openxmlformats.org/drawingml/2006/main" xmlns:p="http://schemas.openxmlformats.org/presentationml/2006/main" xmlns:r="http://schemas.openxmlformats.org/officeDocument/2006/relationships">
+<p:sld xmlns:a="http://schemas.openxmlformats.org/drawingml/2006/main" xmlns:r="http://schemas.openxmlformats.org/officeDocument/2006/relationships" xmlns:p="http://schemas.openxmlformats.org/presentationml/2006/main">
   <p:cSld>
     <p:spTree>
       <p:nvGrpSpPr>
@@ -12117,7 +12314,14 @@
         <p:cNvGrpSpPr/>
         <p:nvPr/>
       </p:nvGrpSpPr>
-      <p:grpSpPr/>
+      <p:grpSpPr>
+        <a:xfrm>
+          <a:off x="0" y="0"/>
+          <a:ext cx="0" cy="0"/>
+          <a:chOff x="0" y="0"/>
+          <a:chExt cx="0" cy="0"/>
+        </a:xfrm>
+      </p:grpSpPr>
       <p:sp>
         <p:nvSpPr>
           <p:cNvPr id="2" name="Rectangle 1"/>
@@ -12158,6 +12362,7 @@
           <a:lstStyle/>
           <a:p>
             <a:pPr algn="ctr"/>
+            <a:endParaRPr/>
           </a:p>
         </p:txBody>
       </p:sp>
@@ -12235,6 +12440,7 @@
           <a:lstStyle/>
           <a:p>
             <a:pPr algn="ctr"/>
+            <a:endParaRPr/>
           </a:p>
         </p:txBody>
       </p:sp>

</xml_diff>